<commit_message>
feat(ecnu-cg): P15 代码由文本块改为 VS Code 风格截图
按汇报人要求，把附录页的关键代码换成截图：六段代码渲染成 Dark+ 配色的
PNG（2x 分辨率，含行号列），以 Image 组件嵌入，投影与打印都不糊。

- 02-PPT/code_png/01..06.png：新增六张代码截图（1136px 宽，2 倍图）
  * 01 ①②③ 检索/粗筛/建边   scene/scene_model_loop_closure.py:179
  * 02 ④ 协视图贪心扩张       poses/ba_problem.py:648
  * 03 ⑤ LM + Schur 局部 BA   poses/mini_ba.py:285
  * 04 ⑥ 回环检测与补边       poses/ba_problem.py:1054
  * 05 ⑦-a 分块深度对齐       scene/mono_depth.py:315
  * 06 ⑦-b 渐进层级与合并     scene/hierarchy_cut.py:105
- 02-PPT/slides/15.slide：代码 Text 改为 <Image>，卡片背景改 #1E1E1E 与截图同色；
  行高与卡片间距重排后仍单页不溢出
- 02-PPT/tools/render_code_png.py：截图生成脚本（Pygments 词法 + Pillow 绘制，
  Consolas/微软雅黑双字体，中英混排按基线对齐）
- 02-PPT/tools/gen_slide15.py：P15 DSL 生成脚本
- 02-PPT/preview/s15.png：预览更新
- 02-PPT/STORY.md、README.md、交付说明.md、04-讲稿：P15 描述改为「源码截图」
</commit_message>
<xml_diff>
--- a/ecnu-cg/02-PPT/PPT-即时三维高斯泼溅重建.pptx
+++ b/ecnu-cg/02-PPT/PPT-即时三维高斯泼溅重建.pptx
@@ -8145,11 +8145,11 @@
 </file>
 
 <file path=ppt/slides/slide15.xml><?xml version="1.0" encoding="utf-8"?>
-<p:sld xmlns:p="http://schemas.openxmlformats.org/presentationml/2006/main" xmlns:a="http://schemas.openxmlformats.org/drawingml/2006/main">
+<p:sld xmlns:p="http://schemas.openxmlformats.org/presentationml/2006/main" xmlns:a="http://schemas.openxmlformats.org/drawingml/2006/main" xmlns:r="http://schemas.openxmlformats.org/officeDocument/2006/relationships">
   <p:cSld>
     <p:spTree>
       <p:nvGrpSpPr>
-        <p:cNvPr id="159" name="" descr="&lt;Slide style={{ width: '1280px', height: '720px', backgroundColor: '#FFFFFF', padding: '0px', flexDirection: 'column' }}&gt;&#10;    &lt;Box style={{ width: '1280px', height: '8px', backgroundColor: '#1E4FA8' }} /&gt;&#10;    &lt;Box style={{ padding: '16px 40px 0px 40px', flexDirection: 'row', justifyContent: 'space-between', alignItems: 'flex-end' }}&gt;&#10;        &lt;Text style={{ fontSize: 32, fontWeight: 'bold', color: '#1E4FA8' }}&gt;附：七个步骤在源码里长什么样&lt;/Text&gt;&#10;        &lt;Text style={{ fontSize: 15, color: '#8B97A8' }}&gt;15 / 15&lt;/Text&gt;&#10;    &lt;/Box&gt;&#10;    &lt;Box style={{ padding: '6px 40px 0px 40px' }}&gt;&#10;        &lt;Text style={{ fontSize: 17, color: '#4A5568' }}&gt;真实源码片段，行号对应第 7 页七步链：&lt;b&gt;①②③ 定跟谁比、④ 定跟谁一起算、⑤ 才真解位姿、⑥⑦ 修漂移与压显存&lt;/b&gt;。&lt;/Text&gt;&#10;    &lt;/Box&gt;&#10;    &lt;Box style={{ padding: '9px 40px 0px 40px', flexDirection: 'row', gap: 14 }}&gt;&#10;        &lt;Box style={{ flex: 1, flexDirection: 'column', gap: 8 }}&gt;&#10;        &lt;Box style={{ backgroundColor: '#0F1D33', borderRadius: 5, padding: '6px 11px 6px 11px', flexDirection: 'column' }}&gt;&#10;            &lt;Text style={{ fontSize: 13, fontWeight: 'bold', color: '#8FBBFF', marginBottom: 1 }}&gt;① ② ③  检索 → 粗筛 → 建边&lt;/Text&gt;&#10;            &lt;Text style={{ fontFamily: 'Consolas', fontSize: 10, color: '#6D87AC', marginBottom: 3 }}&gt;scene/scene_model_loop_closure.py:179&lt;/Text&gt;&#10;            &lt;Text style={{ fontFamily: 'Consolas', fontSize: 13, color: '#D7E3F6', lineHeight: 1.28 }}&gt;cossim = self.vpr_features @ vpr_feature.T     # 全局描述子&lt;/Text&gt;&#10;            &lt;Text style={{ fontFamily: 'Consolas', fontSize: 13, color: '#D7E3F6', lineHeight: 1.28 }}&gt;_, cand = torch.topk(cossim_best, n_candidates)   # top-20&lt;/Text&gt;&#10;            &lt;Text style={{ fontFamily: 'Consolas', fontSize: 13, color: '#D7E3F6', lineHeight: 1.28 }}&gt;n_m = self.matcher.batched_evaluate_match(...)  # XFeat&lt;/Text&gt;&#10;            &lt;Text style={{ fontFamily: 'Consolas', fontSize: 13, color: '#D7E3F6', lineHeight: 1.28 }}&gt;_, best = torch.topk(n_m, n)                      # 留 top-5&lt;/Text&gt;&#10;            &lt;Text style={{ fontFamily: 'Consolas', fontSize: 13, color: '#D7E3F6', lineHeight: 1.28 }}&gt;self.matcher(..., remove_outliers=True, use_lightglue=True)  # 建边&lt;/Text&gt;&#10;        &lt;/Box&gt;&#10;        &lt;Box style={{ backgroundColor: '#0F1D33', borderRadius: 5, padding: '6px 11px 6px 11px', flexDirection: 'column' }}&gt;&#10;            &lt;Text style={{ fontSize: 13, fontWeight: 'bold', color: '#8FBBFF', marginBottom: 1 }}&gt;④  协视图贪心扩张（式 1）&lt;/Text&gt;&#10;            &lt;Text style={{ fontFamily: 'Consolas', fontSize: 10, color: '#6D87AC', marginBottom: 3 }}&gt;poses/ba_problem.py:648&lt;/Text&gt;&#10;            &lt;Text style={{ fontFamily: 'Consolas', fontSize: 13, color: '#D7E3F6', lineHeight: 1.28 }}&gt;while len(selected_ids) &amp;#60; get_n_keyframes:        # 扩到 20 帧&lt;/Text&gt;&#10;            &lt;Text style={{ fontFamily: 'Consolas', fontSize: 13, color: '#D7E3F6', lineHeight: 1.28 }}&gt;    for sid in selected_ids:&lt;/Text&gt;&#10;            &lt;Text style={{ fontFamily: 'Consolas', fontSize: 13, color: '#D7E3F6', lineHeight: 1.28 }}&gt;        for nb in self.pose_graph.neighbors(sid):&lt;/Text&gt;&#10;            &lt;Text style={{ fontFamily: 'Consolas', fontSize: 13, color: '#D7E3F6', lineHeight: 1.28 }}&gt;            if nb not in selected_ids:            # 边权 = 1/|M|&lt;/Text&gt;&#10;            &lt;Text style={{ fontFamily: 'Consolas', fontSize: 13, color: '#D7E3F6', lineHeight: 1.28 }}&gt;                neighbor_counts[nb] += 1.0 / w(sid, nb)&lt;/Text&gt;&#10;            &lt;Text style={{ fontFamily: 'Consolas', fontSize: 13, color: '#D7E3F6', lineHeight: 1.28 }}&gt;    selected_ids.add(neighbor_counts.most_common(1)[0][0])&lt;/Text&gt;&#10;        &lt;/Box&gt;&#10;        &lt;Box style={{ backgroundColor: '#0F1D33', borderRadius: 5, padding: '6px 11px 6px 11px', flexDirection: 'column' }}&gt;&#10;            &lt;Text style={{ fontSize: 13, fontWeight: 'bold', color: '#8FBBFF', marginBottom: 1 }}&gt;⑤  局部 BA：LM 迭代 + Schur 消元&lt;/Text&gt;&#10;            &lt;Text style={{ fontFamily: 'Consolas', fontSize: 10, color: '#6D87AC', marginBottom: 3 }}&gt;poses/mini_ba.py:285&lt;/Text&gt;&#10;            &lt;Text style={{ fontFamily: 'Consolas', fontSize: 13, color: '#D7E3F6', lineHeight: 1.28 }}&gt;for it in range(self.iters):&lt;/Text&gt;&#10;            &lt;Text style={{ fontFamily: 'Consolas', fontSize: 13, color: '#D7E3F6', lineHeight: 1.28 }}&gt;    jtj_cam, ..., resid = self._assemble_jtj(...)&lt;/Text&gt;&#10;            &lt;Text style={{ fontFamily: 'Consolas', fontSize: 13, color: '#D7E3F6', lineHeight: 1.28 }}&gt;    jtj_cam.diagonal().mul_(1 + lm)        # LM 阻尼&lt;/Text&gt;&#10;            &lt;Text style={{ fontFamily: 'Consolas', fontSize: 13, color: '#D7E3F6', lineHeight: 1.28 }}&gt;    jtj_xyz_inv = self.inv_3x3(jtj_xyz)    # C^-1&lt;/Text&gt;&#10;            &lt;Text style={{ fontFamily: 'Consolas', fontSize: 13, color: '#D7E3F6', lineHeight: 1.28 }}&gt;    S = jtj_cam - jtj_xyz_inv @ jtj_cam_xyz.T @ jtj_cam_xyz&lt;/Text&gt;&#10;            &lt;Text style={{ fontFamily: 'Consolas', fontSize: 13, color: '#D7E3F6', lineHeight: 1.28 }}&gt;    L = torch.linalg.cholesky_ex(S)[0]      # 舒尔补 S&lt;/Text&gt;&#10;            &lt;Text style={{ fontFamily: 'Consolas', fontSize: 13, color: '#D7E3F6', lineHeight: 1.28 }}&gt;    dcam = torch.linalg.solve_triangular(...)  # ΔT&lt;/Text&gt;&#10;            &lt;Text style={{ fontFamily: 'Consolas', fontSize: 13, color: '#D7E3F6', lineHeight: 1.28 }}&gt;    dxyz = torch.bmm(b.view(-1, 1, 3), jtj_xyz_inv)&lt;/Text&gt;&#10;        &lt;/Box&gt;&#10;        &lt;/Box&gt;&#10;        &lt;Box style={{ flex: 1, flexDirection: 'column', gap: 8 }}&gt;&#10;        &lt;Box style={{ backgroundColor: '#0F1D33', borderRadius: 5, padding: '6px 11px 6px 11px', flexDirection: 'column' }}&gt;&#10;            &lt;Text style={{ fontSize: 13, fontWeight: 'bold', color: '#8FBBFF', marginBottom: 1 }}&gt;⑥  回环检测与补边&lt;/Text&gt;&#10;            &lt;Text style={{ fontFamily: 'Consolas', fontSize: 10, color: '#6D87AC', marginBottom: 3 }}&gt;poses/ba_problem.py:1054&lt;/Text&gt;&#10;            &lt;Text style={{ fontFamily: 'Consolas', fontSize: 13, color: '#D7E3F6', lineHeight: 1.28 }}&gt;if dists.max() &amp;#62; self.min_loop_size:      # 图距 &amp;#62; 10&lt;/Text&gt;&#10;            &lt;Text style={{ fontFamily: 'Consolas', fontSize: 13, color: '#D7E3F6', lineHeight: 1.28 }}&gt;    clusters_t = split_into_clusters(dists)   # 分两簇&lt;/Text&gt;&#10;            &lt;Text style={{ fontFamily: 'Consolas', fontSize: 13, color: '#D7E3F6', lineHeight: 1.28 }}&gt;is_loop = (min(n_robust_pairs) &amp;#62; n // 2 and&lt;/Text&gt;&#10;            &lt;Text style={{ fontFamily: 'Consolas', fontSize: 13, color: '#D7E3F6', lineHeight: 1.28 }}&gt;           min(max_matches_robustness) &amp;#62; 0.5 * max(...))&lt;/Text&gt;&#10;            &lt;Text style={{ fontFamily: 'Consolas', fontSize: 13, color: '#D7E3F6', lineHeight: 1.28 }}&gt;if len(match.kpts) &amp;#62;= self.min_matches_edge:   # τm=500&lt;/Text&gt;&#10;            &lt;Text style={{ fontFamily: 'Consolas', fontSize: 13, color: '#D7E3F6', lineHeight: 1.28 }}&gt;    self.pose_graph.add_match(i, j, 1.0 / len(match.kpts))&lt;/Text&gt;&#10;        &lt;/Box&gt;&#10;        &lt;Box style={{ backgroundColor: '#0F1D33', borderRadius: 5, padding: '6px 11px 6px 11px', flexDirection: 'column' }}&gt;&#10;            &lt;Text style={{ fontSize: 13, fontWeight: 'bold', color: '#8FBBFF', marginBottom: 1 }}&gt;⑦-a  分块深度对齐&lt;/Text&gt;&#10;            &lt;Text style={{ fontFamily: 'Consolas', fontSize: 10, color: '#6D87AC', marginBottom: 3 }}&gt;scene/mono_depth.py:315&lt;/Text&gt;&#10;            &lt;Text style={{ fontFamily: 'Consolas', fontSize: 13, color: '#D7E3F6', lineHeight: 1.28 }}&gt;tri_idepth = 1 / (pts3d[has_pt3d] @ R.T + t)[..., -1]&lt;/Text&gt;&#10;            &lt;Text style={{ fontFamily: 'Consolas', fontSize: 13, color: '#D7E3F6', lineHeight: 1.28 }}&gt;mono_al, g_s, g_o = align_samples(tri_idepth, sampled)&lt;/Text&gt;&#10;            &lt;Text style={{ fontFamily: 'Consolas', fontSize: 13, color: '#D7E3F6', lineHeight: 1.28 }}&gt;valid = err &amp;#60; m_err + grid_outlier_mult * err_dev&lt;/Text&gt;&#10;            &lt;Text style={{ fontFamily: 'Consolas', fontSize: 13, color: '#D7E3F6', lineHeight: 1.28 }}&gt;return align_depth_grid(..., 4, g_s, g_o)   # 4x4 分块&lt;/Text&gt;&#10;        &lt;/Box&gt;&#10;        &lt;Box style={{ backgroundColor: '#0F1D33', borderRadius: 5, padding: '6px 11px 6px 11px', flexDirection: 'column' }}&gt;&#10;            &lt;Text style={{ fontSize: 13, fontWeight: 'bold', color: '#8FBBFF', marginBottom: 1 }}&gt;⑦-b  渐进层级与合并&lt;/Text&gt;&#10;            &lt;Text style={{ fontFamily: 'Consolas', fontSize: 10, color: '#6D87AC', marginBottom: 3 }}&gt;scene/hierarchy_cut.py:105&lt;/Text&gt;&#10;            &lt;Text style={{ fontFamily: 'Consolas', fontSize: 13, color: '#D7E3F6', lineHeight: 1.28 }}&gt;mask = screen_size &amp;#60; self.hierarchy_screen_size_threshold  # 0.5 px&lt;/Text&gt;&#10;            &lt;Text style={{ fontFamily: 'Consolas', fontSize: 13, color: '#D7E3F6', lineHeight: 1.28 }}&gt;if mask.sum() &amp;#62; max(len(self.xyz) * 0.1, 200_000):&lt;/Text&gt;&#10;            &lt;Text style={{ fontFamily: 'Consolas', fontSize: 13, color: '#D7E3F6', lineHeight: 1.28 }}&gt;    n_merged = self.create_hierarchy_level(cam_centre, mask)&lt;/Text&gt;&#10;            &lt;Text style={{ fontFamily: 'Consolas', fontSize: 13, color: '#D7E3F6', lineHeight: 1.28 }}&gt;# 合并权重 = opacity * screen_size^2（非 KL 投影）&lt;/Text&gt;&#10;            &lt;Text style={{ fontFamily: 'Consolas', fontSize: 13, color: '#D7E3F6', lineHeight: 1.28 }}&gt;weights = opa.sigmoid() * screen_size[selected] ** 2&lt;/Text&gt;&#10;        &lt;/Box&gt;&#10;        &lt;/Box&gt;&#10;    &lt;/Box&gt;&#10;    &lt;Box style={{ padding: '8px 40px 0px 40px' }}&gt;&#10;        &lt;Text style={{ fontSize: 14, color: '#8B97A8', lineHeight: 1.4 }}&gt;为排版做了换行与变量缩写（w = edge_weight），逻辑未改。第 7 页按源码默认值修正：回环触发为&lt;b&gt;加权图距 &amp;gt; 10&lt;/b&gt;；层级合并触发为&lt;b&gt;可并数 &amp;gt; max(10%, 20 万)&lt;/b&gt;，且是 &lt;b&gt;kNN 加权平均&lt;/b&gt;而非 KL。&lt;/Text&gt;&#10;    &lt;/Box&gt;&#10;&lt;/Slide&gt;&#10;"/>
+        <p:cNvPr id="159" name="" descr="&lt;Slide style={{ width: '1280px', height: '720px', backgroundColor: '#FFFFFF', padding: '0px', flexDirection: 'column' }}&gt;&#10;    &lt;Box style={{ width: '1280px', height: '8px', backgroundColor: '#1E4FA8' }} /&gt;&#10;    &lt;Box style={{ padding: '14px 40px 0px 40px', flexDirection: 'row', justifyContent: 'space-between', alignItems: 'flex-end' }}&gt;&#10;        &lt;Text style={{ fontSize: 32, fontWeight: 'bold', color: '#1E4FA8' }}&gt;附：七个步骤在源码里长什么样&lt;/Text&gt;&#10;        &lt;Text style={{ fontSize: 15, color: '#8B97A8' }}&gt;15 / 15&lt;/Text&gt;&#10;    &lt;/Box&gt;&#10;    &lt;Box style={{ padding: '5px 40px 0px 40px' }}&gt;&#10;        &lt;Text style={{ fontSize: 17, color: '#4A5568' }}&gt;真实源码截图，行号对应第 7 页七步链：&lt;b&gt;①②③ 定跟谁比、④ 定跟谁一起算、⑤ 才真解位姿、⑥⑦ 修漂移与压显存&lt;/b&gt;。&lt;/Text&gt;&#10;    &lt;/Box&gt;&#10;    &lt;Box style={{ padding: '8px 40px 0px 40px', flexDirection: 'row', gap: 14 }}&gt;&#10;        &lt;Box style={{ flex: 1, flexDirection: 'column', gap: 10 }}&gt;&#10;        &lt;Box style={{ backgroundColor: '#1E1E1E', borderRadius: 5, padding: '5px 11px 5px 11px', flexDirection: 'column' }}&gt;&#10;            &lt;Text style={{ fontSize: 13, fontWeight: 'bold', color: '#8FBBFF', marginBottom: 0 }}&gt;① ② ③  检索 → 粗筛 → 建边&lt;/Text&gt;&#10;            &lt;Text style={{ fontFamily: 'Consolas', fontSize: 10, color: '#7F8C9F', marginBottom: 2 }}&gt;scene/scene_model_loop_closure.py:179&lt;/Text&gt;&#10;            &lt;Image src=&quot;code_png/01.png&quot; style={{ width: 568, height: 104.5 }} /&gt;&#10;        &lt;/Box&gt;&#10;        &lt;Box style={{ backgroundColor: '#1E1E1E', borderRadius: 5, padding: '5px 11px 5px 11px', flexDirection: 'column' }}&gt;&#10;            &lt;Text style={{ fontSize: 13, fontWeight: 'bold', color: '#8FBBFF', marginBottom: 0 }}&gt;④  协视图贪心扩张（式 1）&lt;/Text&gt;&#10;            &lt;Text style={{ fontFamily: 'Consolas', fontSize: 10, color: '#7F8C9F', marginBottom: 2 }}&gt;poses/ba_problem.py:648&lt;/Text&gt;&#10;            &lt;Image src=&quot;code_png/02.png&quot; style={{ width: 568, height: 123.0 }} /&gt;&#10;        &lt;/Box&gt;&#10;        &lt;Box style={{ backgroundColor: '#1E1E1E', borderRadius: 5, padding: '5px 11px 5px 11px', flexDirection: 'column' }}&gt;&#10;            &lt;Text style={{ fontSize: 13, fontWeight: 'bold', color: '#8FBBFF', marginBottom: 0 }}&gt;⑤  局部 BA：LM 迭代 + Schur 消元&lt;/Text&gt;&#10;            &lt;Text style={{ fontFamily: 'Consolas', fontSize: 10, color: '#7F8C9F', marginBottom: 2 }}&gt;poses/mini_ba.py:285&lt;/Text&gt;&#10;            &lt;Image src=&quot;code_png/03.png&quot; style={{ width: 568, height: 160.0 }} /&gt;&#10;        &lt;/Box&gt;&#10;        &lt;/Box&gt;&#10;        &lt;Box style={{ flex: 1, flexDirection: 'column', gap: 10 }}&gt;&#10;        &lt;Box style={{ backgroundColor: '#1E1E1E', borderRadius: 5, padding: '5px 11px 5px 11px', flexDirection: 'column' }}&gt;&#10;            &lt;Text style={{ fontSize: 13, fontWeight: 'bold', color: '#8FBBFF', marginBottom: 0 }}&gt;⑥  回环检测与补边&lt;/Text&gt;&#10;            &lt;Text style={{ fontFamily: 'Consolas', fontSize: 10, color: '#7F8C9F', marginBottom: 2 }}&gt;poses/ba_problem.py:1054&lt;/Text&gt;&#10;            &lt;Image src=&quot;code_png/04.png&quot; style={{ width: 568, height: 123.0 }} /&gt;&#10;        &lt;/Box&gt;&#10;        &lt;Box style={{ backgroundColor: '#1E1E1E', borderRadius: 5, padding: '5px 11px 5px 11px', flexDirection: 'column' }}&gt;&#10;            &lt;Text style={{ fontSize: 13, fontWeight: 'bold', color: '#8FBBFF', marginBottom: 0 }}&gt;⑦-a  分块深度对齐&lt;/Text&gt;&#10;            &lt;Text style={{ fontFamily: 'Consolas', fontSize: 10, color: '#7F8C9F', marginBottom: 2 }}&gt;scene/mono_depth.py:315&lt;/Text&gt;&#10;            &lt;Image src=&quot;code_png/05.png&quot; style={{ width: 568, height: 86.0 }} /&gt;&#10;        &lt;/Box&gt;&#10;        &lt;Box style={{ backgroundColor: '#1E1E1E', borderRadius: 5, padding: '5px 11px 5px 11px', flexDirection: 'column' }}&gt;&#10;            &lt;Text style={{ fontSize: 13, fontWeight: 'bold', color: '#8FBBFF', marginBottom: 0 }}&gt;⑦-b  渐进层级与合并&lt;/Text&gt;&#10;            &lt;Text style={{ fontFamily: 'Consolas', fontSize: 10, color: '#7F8C9F', marginBottom: 2 }}&gt;scene/hierarchy_cut.py:105&lt;/Text&gt;&#10;            &lt;Image src=&quot;code_png/06.png&quot; style={{ width: 568, height: 104.5 }} /&gt;&#10;        &lt;/Box&gt;&#10;        &lt;/Box&gt;&#10;    &lt;/Box&gt;&#10;    &lt;Box style={{ padding: '7px 40px 0px 40px' }}&gt;&#10;        &lt;Text style={{ fontSize: 13.5, color: '#8B97A8', lineHeight: 1.35 }}&gt;行号指向片段起点；为投影宽度做了换行与变量缩写（w = edge_weight），逻辑未改。第 7 页已按源码默认值修正：回环触发为&lt;b&gt;加权图距 &amp;gt; 10&lt;/b&gt;；层级合并触发为&lt;b&gt;可并数 &amp;gt; max(10%, 20 万)&lt;/b&gt;，且是 &lt;b&gt;kNN 加权平均&lt;/b&gt;而非 KL。&lt;/Text&gt;&#10;    &lt;/Box&gt;&#10;&lt;/Slide&gt;&#10;"/>
         <p:cNvGrpSpPr/>
         <p:nvPr/>
       </p:nvGrpSpPr>
@@ -8217,7 +8217,7 @@
         </p:nvSpPr>
         <p:spPr>
           <a:xfrm rot="0" flipH="0" flipV="0">
-            <a:off x="381000" y="228600"/>
+            <a:off x="381000" y="209550"/>
             <a:ext cx="4267200" cy="371475"/>
           </a:xfrm>
           <a:prstGeom prst="rect"/>
@@ -8252,7 +8252,7 @@
         </p:nvSpPr>
         <p:spPr>
           <a:xfrm rot="0" flipH="0" flipV="0">
-            <a:off x="11325225" y="428625"/>
+            <a:off x="11325225" y="409575"/>
             <a:ext cx="485775" cy="171450"/>
           </a:xfrm>
           <a:prstGeom prst="rect"/>
@@ -8287,7 +8287,7 @@
         </p:nvSpPr>
         <p:spPr>
           <a:xfrm rot="0" flipH="0" flipV="0">
-            <a:off x="381000" y="657225"/>
+            <a:off x="381000" y="628650"/>
             <a:ext cx="11430000" cy="200025"/>
           </a:xfrm>
           <a:prstGeom prst="rect"/>
@@ -8308,7 +8308,7 @@
                 <a:latin typeface="Microsoft YaHei"/>
                 <a:ea typeface="Microsoft YaHei"/>
               </a:rPr>
-              <a:t>真实源码片段，行号对应第</a:t>
+              <a:t>真实源码截图，行号对应第</a:t>
             </a:r>
             <a:r>
               <a:rPr lang="en-US" sz="1275">
@@ -8432,16 +8432,16 @@
         </p:nvSpPr>
         <p:spPr>
           <a:xfrm rot="0" flipH="0" flipV="0">
-            <a:off x="381000" y="942975"/>
-            <a:ext cx="5648325" cy="1371600"/>
+            <a:off x="381000" y="904875"/>
+            <a:ext cx="5648325" cy="1381125"/>
           </a:xfrm>
           <a:prstGeom prst="roundRect">
             <a:avLst>
-              <a:gd name="adj" fmla="val 3472"/>
+              <a:gd name="adj" fmla="val 3448"/>
             </a:avLst>
           </a:prstGeom>
           <a:solidFill>
-            <a:srgbClr val="0F1D33"/>
+            <a:srgbClr val="1E1E1E"/>
           </a:solidFill>
           <a:ln/>
         </p:spPr>
@@ -8458,7 +8458,7 @@
         </p:nvSpPr>
         <p:spPr>
           <a:xfrm rot="0" flipH="0" flipV="0">
-            <a:off x="485775" y="1000125"/>
+            <a:off x="485775" y="952500"/>
             <a:ext cx="5438775" cy="152400"/>
           </a:xfrm>
           <a:prstGeom prst="rect"/>
@@ -8543,7 +8543,7 @@
         </p:nvSpPr>
         <p:spPr>
           <a:xfrm rot="0" flipH="0" flipV="0">
-            <a:off x="485775" y="1162050"/>
+            <a:off x="485775" y="1104900"/>
             <a:ext cx="5438775" cy="114300"/>
           </a:xfrm>
           <a:prstGeom prst="rect"/>
@@ -8559,7 +8559,7 @@
             <a:r>
               <a:rPr lang="en-US" sz="750">
                 <a:solidFill>
-                  <a:srgbClr val="6D87AC"/>
+                  <a:srgbClr val="7F8C9F"/>
                 </a:solidFill>
                 <a:latin typeface="Consolas"/>
                 <a:ea typeface="Consolas"/>
@@ -8570,239 +8570,50 @@
           </a:p>
         </p:txBody>
       </p:sp>
-      <p:sp>
-        <p:nvSpPr>
-          <p:cNvPr id="168" name="" descr="{&quot;isTemplate&quot;:true,&quot;type&quot;:&quot;text&quot;}"/>
-          <p:cNvSpPr txBox="1"/>
-          <p:nvPr/>
-        </p:nvSpPr>
-        <p:spPr>
-          <a:xfrm rot="0" flipH="0" flipV="0">
-            <a:off x="485775" y="1304925"/>
-            <a:ext cx="5438775" cy="190500"/>
-          </a:xfrm>
-          <a:prstGeom prst="rect"/>
-        </p:spPr>
-        <p:txBody>
-          <a:bodyPr wrap="none" lIns="0" tIns="0" rIns="0" bIns="0"/>
-          <a:p>
-            <a:pPr>
-              <a:lnSpc>
-                <a:spcPct val="128000"/>
-              </a:lnSpc>
-            </a:pPr>
-            <a:r>
-              <a:rPr lang="en-US" sz="975">
-                <a:solidFill>
-                  <a:srgbClr val="D7E3F6"/>
-                </a:solidFill>
-                <a:latin typeface="Consolas"/>
-                <a:ea typeface="Consolas"/>
-              </a:rPr>
-              <a:t xml:space="preserve">cossim = self.vpr_features @ vpr_feature.T     # </a:t>
-            </a:r>
-            <a:r>
-              <a:rPr lang="zh-CN" sz="975">
-                <a:solidFill>
-                  <a:srgbClr val="D7E3F6"/>
-                </a:solidFill>
-                <a:latin typeface="Consolas"/>
-                <a:ea typeface="Consolas"/>
-              </a:rPr>
-              <a:t>全局描述子</a:t>
-            </a:r>
-            <a:endParaRPr/>
-          </a:p>
-        </p:txBody>
-      </p:sp>
-      <p:sp>
-        <p:nvSpPr>
-          <p:cNvPr id="169" name="" descr="{&quot;isTemplate&quot;:true,&quot;type&quot;:&quot;text&quot;}"/>
-          <p:cNvSpPr txBox="1"/>
-          <p:nvPr/>
-        </p:nvSpPr>
-        <p:spPr>
-          <a:xfrm rot="0" flipH="0" flipV="0">
-            <a:off x="485775" y="1495425"/>
-            <a:ext cx="5438775" cy="190500"/>
-          </a:xfrm>
-          <a:prstGeom prst="rect"/>
-        </p:spPr>
-        <p:txBody>
-          <a:bodyPr wrap="none" lIns="0" tIns="0" rIns="0" bIns="0"/>
-          <a:p>
-            <a:pPr>
-              <a:lnSpc>
-                <a:spcPct val="128000"/>
-              </a:lnSpc>
-            </a:pPr>
-            <a:r>
-              <a:rPr lang="en-US" sz="975">
-                <a:solidFill>
-                  <a:srgbClr val="D7E3F6"/>
-                </a:solidFill>
-                <a:latin typeface="Consolas"/>
-                <a:ea typeface="Consolas"/>
-              </a:rPr>
-              <a:t>_, cand = torch.topk(cossim_best, n_candidates)   # top-20</a:t>
-            </a:r>
-            <a:endParaRPr/>
-          </a:p>
-        </p:txBody>
-      </p:sp>
-      <p:sp>
-        <p:nvSpPr>
-          <p:cNvPr id="170" name="" descr="{&quot;isTemplate&quot;:true,&quot;type&quot;:&quot;text&quot;}"/>
-          <p:cNvSpPr txBox="1"/>
-          <p:nvPr/>
-        </p:nvSpPr>
-        <p:spPr>
-          <a:xfrm rot="0" flipH="0" flipV="0">
-            <a:off x="485775" y="1685925"/>
-            <a:ext cx="5438775" cy="190500"/>
-          </a:xfrm>
-          <a:prstGeom prst="rect"/>
-        </p:spPr>
-        <p:txBody>
-          <a:bodyPr wrap="none" lIns="0" tIns="0" rIns="0" bIns="0"/>
-          <a:p>
-            <a:pPr>
-              <a:lnSpc>
-                <a:spcPct val="128000"/>
-              </a:lnSpc>
-            </a:pPr>
-            <a:r>
-              <a:rPr lang="en-US" sz="975">
-                <a:solidFill>
-                  <a:srgbClr val="D7E3F6"/>
-                </a:solidFill>
-                <a:latin typeface="Consolas"/>
-                <a:ea typeface="Consolas"/>
-              </a:rPr>
-              <a:t>n_m = self.matcher.batched_evaluate_match(...)  # XFeat</a:t>
-            </a:r>
-            <a:endParaRPr/>
-          </a:p>
-        </p:txBody>
-      </p:sp>
-      <p:sp>
-        <p:nvSpPr>
-          <p:cNvPr id="171" name="" descr="{&quot;isTemplate&quot;:true,&quot;type&quot;:&quot;text&quot;}"/>
-          <p:cNvSpPr txBox="1"/>
-          <p:nvPr/>
-        </p:nvSpPr>
-        <p:spPr>
-          <a:xfrm rot="0" flipH="0" flipV="0">
-            <a:off x="485775" y="1876425"/>
-            <a:ext cx="5438775" cy="190500"/>
-          </a:xfrm>
-          <a:prstGeom prst="rect"/>
-        </p:spPr>
-        <p:txBody>
-          <a:bodyPr wrap="none" lIns="0" tIns="0" rIns="0" bIns="0"/>
-          <a:p>
-            <a:pPr>
-              <a:lnSpc>
-                <a:spcPct val="128000"/>
-              </a:lnSpc>
-            </a:pPr>
-            <a:r>
-              <a:rPr lang="en-US" sz="975">
-                <a:solidFill>
-                  <a:srgbClr val="D7E3F6"/>
-                </a:solidFill>
-                <a:latin typeface="Consolas"/>
-                <a:ea typeface="Consolas"/>
-              </a:rPr>
-              <a:t xml:space="preserve">_, best = torch.topk(n_m, n)                      # </a:t>
-            </a:r>
-            <a:r>
-              <a:rPr lang="zh-CN" sz="975">
-                <a:solidFill>
-                  <a:srgbClr val="D7E3F6"/>
-                </a:solidFill>
-                <a:latin typeface="Consolas"/>
-                <a:ea typeface="Consolas"/>
-              </a:rPr>
-              <a:t>留</a:t>
-            </a:r>
-            <a:r>
-              <a:rPr lang="en-US" sz="975">
-                <a:solidFill>
-                  <a:srgbClr val="D7E3F6"/>
-                </a:solidFill>
-                <a:latin typeface="Consolas"/>
-                <a:ea typeface="Consolas"/>
-              </a:rPr>
-              <a:t xml:space="preserve"> top-5</a:t>
-            </a:r>
-            <a:endParaRPr/>
-          </a:p>
-        </p:txBody>
-      </p:sp>
-      <p:sp>
-        <p:nvSpPr>
-          <p:cNvPr id="172" name="" descr="{&quot;isTemplate&quot;:true,&quot;type&quot;:&quot;text&quot;}"/>
-          <p:cNvSpPr txBox="1"/>
-          <p:nvPr/>
-        </p:nvSpPr>
-        <p:spPr>
-          <a:xfrm rot="0" flipH="0" flipV="0">
-            <a:off x="485775" y="2066925"/>
-            <a:ext cx="5438775" cy="190500"/>
-          </a:xfrm>
-          <a:prstGeom prst="rect"/>
-        </p:spPr>
-        <p:txBody>
-          <a:bodyPr wrap="none" lIns="0" tIns="0" rIns="0" bIns="0"/>
-          <a:p>
-            <a:pPr>
-              <a:lnSpc>
-                <a:spcPct val="128000"/>
-              </a:lnSpc>
-            </a:pPr>
-            <a:r>
-              <a:rPr lang="en-US" sz="975">
-                <a:solidFill>
-                  <a:srgbClr val="D7E3F6"/>
-                </a:solidFill>
-                <a:latin typeface="Consolas"/>
-                <a:ea typeface="Consolas"/>
-              </a:rPr>
-              <a:t xml:space="preserve">self.matcher(..., remove_outliers=True, use_lightglue=True)  # </a:t>
-            </a:r>
-            <a:r>
-              <a:rPr lang="zh-CN" sz="975">
-                <a:solidFill>
-                  <a:srgbClr val="D7E3F6"/>
-                </a:solidFill>
-                <a:latin typeface="Consolas"/>
-                <a:ea typeface="Consolas"/>
-              </a:rPr>
-              <a:t>建边</a:t>
-            </a:r>
-            <a:endParaRPr/>
-          </a:p>
-        </p:txBody>
-      </p:sp>
-      <p:sp>
-        <p:nvSpPr>
-          <p:cNvPr id="173" name=""/>
+      <p:pic>
+        <p:nvPicPr>
+          <p:cNvPr id="168" name=""/>
+          <p:cNvPicPr>
+            <a:picLocks noChangeAspect="1"/>
+          </p:cNvPicPr>
+          <p:nvPr/>
+        </p:nvPicPr>
+        <p:blipFill>
+          <a:blip r:embed="rId1"/>
+          <a:srcRect l="238" t="0" r="238" b="0"/>
+          <a:stretch>
+            <a:fillRect/>
+          </a:stretch>
+        </p:blipFill>
+        <p:spPr>
+          <a:xfrm rot="0" flipH="0" flipV="0">
+            <a:off x="485775" y="1238250"/>
+            <a:ext cx="5410200" cy="1000125"/>
+          </a:xfrm>
+          <a:prstGeom prst="rect">
+            <a:avLst/>
+          </a:prstGeom>
+          <a:ln/>
+        </p:spPr>
+      </p:pic>
+      <p:sp>
+        <p:nvSpPr>
+          <p:cNvPr id="169" name=""/>
           <p:cNvSpPr/>
           <p:nvPr/>
         </p:nvSpPr>
         <p:spPr>
           <a:xfrm rot="0" flipH="0" flipV="0">
-            <a:off x="381000" y="2390775"/>
-            <a:ext cx="5648325" cy="1562100"/>
+            <a:off x="381000" y="2381250"/>
+            <a:ext cx="5648325" cy="1552575"/>
           </a:xfrm>
           <a:prstGeom prst="roundRect">
             <a:avLst>
-              <a:gd name="adj" fmla="val 3049"/>
+              <a:gd name="adj" fmla="val 3067"/>
             </a:avLst>
           </a:prstGeom>
           <a:solidFill>
-            <a:srgbClr val="0F1D33"/>
+            <a:srgbClr val="1E1E1E"/>
           </a:solidFill>
           <a:ln/>
         </p:spPr>
@@ -8813,13 +8624,13 @@
       </p:sp>
       <p:sp>
         <p:nvSpPr>
-          <p:cNvPr id="174" name="" descr="{&quot;isTemplate&quot;:true,&quot;type&quot;:&quot;text&quot;}"/>
-          <p:cNvSpPr txBox="1"/>
-          <p:nvPr/>
-        </p:nvSpPr>
-        <p:spPr>
-          <a:xfrm rot="0" flipH="0" flipV="0">
-            <a:off x="485775" y="2447925"/>
+          <p:cNvPr id="170" name="" descr="{&quot;isTemplate&quot;:true,&quot;type&quot;:&quot;text&quot;}"/>
+          <p:cNvSpPr txBox="1"/>
+          <p:nvPr/>
+        </p:nvSpPr>
+        <p:spPr>
+          <a:xfrm rot="0" flipH="0" flipV="0">
+            <a:off x="485775" y="2428875"/>
             <a:ext cx="5438775" cy="152400"/>
           </a:xfrm>
           <a:prstGeom prst="rect"/>
@@ -8878,13 +8689,13 @@
       </p:sp>
       <p:sp>
         <p:nvSpPr>
-          <p:cNvPr id="175" name="" descr="{&quot;isTemplate&quot;:true,&quot;type&quot;:&quot;text&quot;}"/>
-          <p:cNvSpPr txBox="1"/>
-          <p:nvPr/>
-        </p:nvSpPr>
-        <p:spPr>
-          <a:xfrm rot="0" flipH="0" flipV="0">
-            <a:off x="485775" y="2609850"/>
+          <p:cNvPr id="171" name="" descr="{&quot;isTemplate&quot;:true,&quot;type&quot;:&quot;text&quot;}"/>
+          <p:cNvSpPr txBox="1"/>
+          <p:nvPr/>
+        </p:nvSpPr>
+        <p:spPr>
+          <a:xfrm rot="0" flipH="0" flipV="0">
+            <a:off x="485775" y="2581275"/>
             <a:ext cx="5438775" cy="114300"/>
           </a:xfrm>
           <a:prstGeom prst="rect"/>
@@ -8900,7 +8711,7 @@
             <a:r>
               <a:rPr lang="en-US" sz="750">
                 <a:solidFill>
-                  <a:srgbClr val="6D87AC"/>
+                  <a:srgbClr val="7F8C9F"/>
                 </a:solidFill>
                 <a:latin typeface="Consolas"/>
                 <a:ea typeface="Consolas"/>
@@ -8911,284 +8722,49 @@
           </a:p>
         </p:txBody>
       </p:sp>
-      <p:sp>
-        <p:nvSpPr>
-          <p:cNvPr id="176" name="" descr="{&quot;isTemplate&quot;:true,&quot;type&quot;:&quot;text&quot;}"/>
-          <p:cNvSpPr txBox="1"/>
-          <p:nvPr/>
-        </p:nvSpPr>
-        <p:spPr>
-          <a:xfrm rot="0" flipH="0" flipV="0">
-            <a:off x="485775" y="2752725"/>
-            <a:ext cx="5438775" cy="190500"/>
-          </a:xfrm>
-          <a:prstGeom prst="rect"/>
-        </p:spPr>
-        <p:txBody>
-          <a:bodyPr wrap="none" lIns="0" tIns="0" rIns="0" bIns="0"/>
-          <a:p>
-            <a:pPr>
-              <a:lnSpc>
-                <a:spcPct val="128000"/>
-              </a:lnSpc>
-            </a:pPr>
-            <a:r>
-              <a:rPr lang="en-US" sz="975">
-                <a:solidFill>
-                  <a:srgbClr val="D7E3F6"/>
-                </a:solidFill>
-                <a:latin typeface="Consolas"/>
-                <a:ea typeface="Consolas"/>
-              </a:rPr>
-              <a:t xml:space="preserve">while len(selected_ids) &lt; get_n_keyframes:        # </a:t>
-            </a:r>
-            <a:r>
-              <a:rPr lang="zh-CN" sz="975">
-                <a:solidFill>
-                  <a:srgbClr val="D7E3F6"/>
-                </a:solidFill>
-                <a:latin typeface="Consolas"/>
-                <a:ea typeface="Consolas"/>
-              </a:rPr>
-              <a:t>扩到</a:t>
-            </a:r>
-            <a:r>
-              <a:rPr lang="en-US" sz="975">
-                <a:solidFill>
-                  <a:srgbClr val="D7E3F6"/>
-                </a:solidFill>
-                <a:latin typeface="Consolas"/>
-                <a:ea typeface="Consolas"/>
-              </a:rPr>
-              <a:t xml:space="preserve"> 20 </a:t>
-            </a:r>
-            <a:r>
-              <a:rPr lang="zh-CN" sz="975">
-                <a:solidFill>
-                  <a:srgbClr val="D7E3F6"/>
-                </a:solidFill>
-                <a:latin typeface="Consolas"/>
-                <a:ea typeface="Consolas"/>
-              </a:rPr>
-              <a:t>帧</a:t>
-            </a:r>
-            <a:endParaRPr/>
-          </a:p>
-        </p:txBody>
-      </p:sp>
-      <p:sp>
-        <p:nvSpPr>
-          <p:cNvPr id="177" name="" descr="{&quot;isTemplate&quot;:true,&quot;type&quot;:&quot;text&quot;}"/>
-          <p:cNvSpPr txBox="1"/>
-          <p:nvPr/>
-        </p:nvSpPr>
-        <p:spPr>
-          <a:xfrm rot="0" flipH="0" flipV="0">
-            <a:off x="485775" y="2943225"/>
-            <a:ext cx="5438775" cy="190500"/>
-          </a:xfrm>
-          <a:prstGeom prst="rect"/>
-        </p:spPr>
-        <p:txBody>
-          <a:bodyPr wrap="none" lIns="0" tIns="0" rIns="0" bIns="0"/>
-          <a:p>
-            <a:pPr>
-              <a:lnSpc>
-                <a:spcPct val="128000"/>
-              </a:lnSpc>
-            </a:pPr>
-            <a:r>
-              <a:rPr lang="en-US" sz="975">
-                <a:solidFill>
-                  <a:srgbClr val="D7E3F6"/>
-                </a:solidFill>
-                <a:latin typeface="Consolas"/>
-                <a:ea typeface="Consolas"/>
-              </a:rPr>
-              <a:t xml:space="preserve">    for sid in selected_ids:</a:t>
-            </a:r>
-            <a:endParaRPr/>
-          </a:p>
-        </p:txBody>
-      </p:sp>
-      <p:sp>
-        <p:nvSpPr>
-          <p:cNvPr id="178" name="" descr="{&quot;isTemplate&quot;:true,&quot;type&quot;:&quot;text&quot;}"/>
-          <p:cNvSpPr txBox="1"/>
-          <p:nvPr/>
-        </p:nvSpPr>
-        <p:spPr>
-          <a:xfrm rot="0" flipH="0" flipV="0">
-            <a:off x="485775" y="3133725"/>
-            <a:ext cx="5438775" cy="190500"/>
-          </a:xfrm>
-          <a:prstGeom prst="rect"/>
-        </p:spPr>
-        <p:txBody>
-          <a:bodyPr wrap="none" lIns="0" tIns="0" rIns="0" bIns="0"/>
-          <a:p>
-            <a:pPr>
-              <a:lnSpc>
-                <a:spcPct val="128000"/>
-              </a:lnSpc>
-            </a:pPr>
-            <a:r>
-              <a:rPr lang="en-US" sz="975">
-                <a:solidFill>
-                  <a:srgbClr val="D7E3F6"/>
-                </a:solidFill>
-                <a:latin typeface="Consolas"/>
-                <a:ea typeface="Consolas"/>
-              </a:rPr>
-              <a:t xml:space="preserve">        for nb in self.pose_graph.neighbors(sid):</a:t>
-            </a:r>
-            <a:endParaRPr/>
-          </a:p>
-        </p:txBody>
-      </p:sp>
-      <p:sp>
-        <p:nvSpPr>
-          <p:cNvPr id="179" name="" descr="{&quot;isTemplate&quot;:true,&quot;type&quot;:&quot;text&quot;}"/>
-          <p:cNvSpPr txBox="1"/>
-          <p:nvPr/>
-        </p:nvSpPr>
-        <p:spPr>
-          <a:xfrm rot="0" flipH="0" flipV="0">
-            <a:off x="485775" y="3324225"/>
-            <a:ext cx="5438775" cy="190500"/>
-          </a:xfrm>
-          <a:prstGeom prst="rect"/>
-        </p:spPr>
-        <p:txBody>
-          <a:bodyPr wrap="none" lIns="0" tIns="0" rIns="0" bIns="0"/>
-          <a:p>
-            <a:pPr>
-              <a:lnSpc>
-                <a:spcPct val="128000"/>
-              </a:lnSpc>
-            </a:pPr>
-            <a:r>
-              <a:rPr lang="en-US" sz="975">
-                <a:solidFill>
-                  <a:srgbClr val="D7E3F6"/>
-                </a:solidFill>
-                <a:latin typeface="Consolas"/>
-                <a:ea typeface="Consolas"/>
-              </a:rPr>
-              <a:t xml:space="preserve">            if nb not in selected_ids:            # </a:t>
-            </a:r>
-            <a:r>
-              <a:rPr lang="zh-CN" sz="975">
-                <a:solidFill>
-                  <a:srgbClr val="D7E3F6"/>
-                </a:solidFill>
-                <a:latin typeface="Consolas"/>
-                <a:ea typeface="Consolas"/>
-              </a:rPr>
-              <a:t>边权</a:t>
-            </a:r>
-            <a:r>
-              <a:rPr lang="en-US" sz="975">
-                <a:solidFill>
-                  <a:srgbClr val="D7E3F6"/>
-                </a:solidFill>
-                <a:latin typeface="Consolas"/>
-                <a:ea typeface="Consolas"/>
-              </a:rPr>
-              <a:t xml:space="preserve"> = 1/|M|</a:t>
-            </a:r>
-            <a:endParaRPr/>
-          </a:p>
-        </p:txBody>
-      </p:sp>
-      <p:sp>
-        <p:nvSpPr>
-          <p:cNvPr id="180" name="" descr="{&quot;isTemplate&quot;:true,&quot;type&quot;:&quot;text&quot;}"/>
-          <p:cNvSpPr txBox="1"/>
-          <p:nvPr/>
-        </p:nvSpPr>
-        <p:spPr>
-          <a:xfrm rot="0" flipH="0" flipV="0">
-            <a:off x="485775" y="3514725"/>
-            <a:ext cx="5438775" cy="190500"/>
-          </a:xfrm>
-          <a:prstGeom prst="rect"/>
-        </p:spPr>
-        <p:txBody>
-          <a:bodyPr wrap="none" lIns="0" tIns="0" rIns="0" bIns="0"/>
-          <a:p>
-            <a:pPr>
-              <a:lnSpc>
-                <a:spcPct val="128000"/>
-              </a:lnSpc>
-            </a:pPr>
-            <a:r>
-              <a:rPr lang="en-US" sz="975">
-                <a:solidFill>
-                  <a:srgbClr val="D7E3F6"/>
-                </a:solidFill>
-                <a:latin typeface="Consolas"/>
-                <a:ea typeface="Consolas"/>
-              </a:rPr>
-              <a:t xml:space="preserve">                neighbor_counts[nb] += 1.0 / w(sid, nb)</a:t>
-            </a:r>
-            <a:endParaRPr/>
-          </a:p>
-        </p:txBody>
-      </p:sp>
-      <p:sp>
-        <p:nvSpPr>
-          <p:cNvPr id="181" name="" descr="{&quot;isTemplate&quot;:true,&quot;type&quot;:&quot;text&quot;}"/>
-          <p:cNvSpPr txBox="1"/>
-          <p:nvPr/>
-        </p:nvSpPr>
-        <p:spPr>
-          <a:xfrm rot="0" flipH="0" flipV="0">
-            <a:off x="485775" y="3705225"/>
-            <a:ext cx="5438775" cy="190500"/>
-          </a:xfrm>
-          <a:prstGeom prst="rect"/>
-        </p:spPr>
-        <p:txBody>
-          <a:bodyPr wrap="none" lIns="0" tIns="0" rIns="0" bIns="0"/>
-          <a:p>
-            <a:pPr>
-              <a:lnSpc>
-                <a:spcPct val="128000"/>
-              </a:lnSpc>
-            </a:pPr>
-            <a:r>
-              <a:rPr lang="en-US" sz="975">
-                <a:solidFill>
-                  <a:srgbClr val="D7E3F6"/>
-                </a:solidFill>
-                <a:latin typeface="Consolas"/>
-                <a:ea typeface="Consolas"/>
-              </a:rPr>
-              <a:t xml:space="preserve">    selected_ids.add(neighbor_counts.most_common(1)[0][0])</a:t>
-            </a:r>
-            <a:endParaRPr/>
-          </a:p>
-        </p:txBody>
-      </p:sp>
-      <p:sp>
-        <p:nvSpPr>
-          <p:cNvPr id="182" name=""/>
+      <p:pic>
+        <p:nvPicPr>
+          <p:cNvPr id="172" name=""/>
+          <p:cNvPicPr>
+            <a:picLocks noChangeAspect="1"/>
+          </p:cNvPicPr>
+          <p:nvPr/>
+        </p:nvPicPr>
+        <p:blipFill>
+          <a:blip r:embed="rId2"/>
+          <a:stretch>
+            <a:fillRect/>
+          </a:stretch>
+        </p:blipFill>
+        <p:spPr>
+          <a:xfrm rot="0" flipH="0" flipV="0">
+            <a:off x="485775" y="2714625"/>
+            <a:ext cx="5410200" cy="1171575"/>
+          </a:xfrm>
+          <a:prstGeom prst="rect">
+            <a:avLst/>
+          </a:prstGeom>
+          <a:ln/>
+        </p:spPr>
+      </p:pic>
+      <p:sp>
+        <p:nvSpPr>
+          <p:cNvPr id="173" name=""/>
           <p:cNvSpPr/>
           <p:nvPr/>
         </p:nvSpPr>
         <p:spPr>
           <a:xfrm rot="0" flipH="0" flipV="0">
             <a:off x="381000" y="4029075"/>
-            <a:ext cx="5648325" cy="1943100"/>
+            <a:ext cx="5648325" cy="1905000"/>
           </a:xfrm>
           <a:prstGeom prst="roundRect">
             <a:avLst>
-              <a:gd name="adj" fmla="val 2451"/>
+              <a:gd name="adj" fmla="val 2500"/>
             </a:avLst>
           </a:prstGeom>
           <a:solidFill>
-            <a:srgbClr val="0F1D33"/>
+            <a:srgbClr val="1E1E1E"/>
           </a:solidFill>
           <a:ln/>
         </p:spPr>
@@ -9199,13 +8775,13 @@
       </p:sp>
       <p:sp>
         <p:nvSpPr>
-          <p:cNvPr id="183" name="" descr="{&quot;isTemplate&quot;:true,&quot;type&quot;:&quot;text&quot;}"/>
-          <p:cNvSpPr txBox="1"/>
-          <p:nvPr/>
-        </p:nvSpPr>
-        <p:spPr>
-          <a:xfrm rot="0" flipH="0" flipV="0">
-            <a:off x="485775" y="4086225"/>
+          <p:cNvPr id="174" name="" descr="{&quot;isTemplate&quot;:true,&quot;type&quot;:&quot;text&quot;}"/>
+          <p:cNvSpPr txBox="1"/>
+          <p:nvPr/>
+        </p:nvSpPr>
+        <p:spPr>
+          <a:xfrm rot="0" flipH="0" flipV="0">
+            <a:off x="485775" y="4076700"/>
             <a:ext cx="5438775" cy="152400"/>
           </a:xfrm>
           <a:prstGeom prst="rect"/>
@@ -9304,13 +8880,13 @@
       </p:sp>
       <p:sp>
         <p:nvSpPr>
-          <p:cNvPr id="184" name="" descr="{&quot;isTemplate&quot;:true,&quot;type&quot;:&quot;text&quot;}"/>
-          <p:cNvSpPr txBox="1"/>
-          <p:nvPr/>
-        </p:nvSpPr>
-        <p:spPr>
-          <a:xfrm rot="0" flipH="0" flipV="0">
-            <a:off x="485775" y="4248150"/>
+          <p:cNvPr id="175" name="" descr="{&quot;isTemplate&quot;:true,&quot;type&quot;:&quot;text&quot;}"/>
+          <p:cNvSpPr txBox="1"/>
+          <p:nvPr/>
+        </p:nvSpPr>
+        <p:spPr>
+          <a:xfrm rot="0" flipH="0" flipV="0">
+            <a:off x="485775" y="4229100"/>
             <a:ext cx="5438775" cy="114300"/>
           </a:xfrm>
           <a:prstGeom prst="rect"/>
@@ -9326,7 +8902,7 @@
             <a:r>
               <a:rPr lang="en-US" sz="750">
                 <a:solidFill>
-                  <a:srgbClr val="6D87AC"/>
+                  <a:srgbClr val="7F8C9F"/>
                 </a:solidFill>
                 <a:latin typeface="Consolas"/>
                 <a:ea typeface="Consolas"/>
@@ -9337,334 +8913,49 @@
           </a:p>
         </p:txBody>
       </p:sp>
-      <p:sp>
-        <p:nvSpPr>
-          <p:cNvPr id="185" name="" descr="{&quot;isTemplate&quot;:true,&quot;type&quot;:&quot;text&quot;}"/>
-          <p:cNvSpPr txBox="1"/>
-          <p:nvPr/>
-        </p:nvSpPr>
-        <p:spPr>
-          <a:xfrm rot="0" flipH="0" flipV="0">
-            <a:off x="485775" y="4391025"/>
-            <a:ext cx="5438775" cy="190500"/>
-          </a:xfrm>
-          <a:prstGeom prst="rect"/>
-        </p:spPr>
-        <p:txBody>
-          <a:bodyPr wrap="none" lIns="0" tIns="0" rIns="0" bIns="0"/>
-          <a:p>
-            <a:pPr>
-              <a:lnSpc>
-                <a:spcPct val="128000"/>
-              </a:lnSpc>
-            </a:pPr>
-            <a:r>
-              <a:rPr lang="en-US" sz="975">
-                <a:solidFill>
-                  <a:srgbClr val="D7E3F6"/>
-                </a:solidFill>
-                <a:latin typeface="Consolas"/>
-                <a:ea typeface="Consolas"/>
-              </a:rPr>
-              <a:t>for it in range(self.iters):</a:t>
-            </a:r>
-            <a:endParaRPr/>
-          </a:p>
-        </p:txBody>
-      </p:sp>
-      <p:sp>
-        <p:nvSpPr>
-          <p:cNvPr id="186" name="" descr="{&quot;isTemplate&quot;:true,&quot;type&quot;:&quot;text&quot;}"/>
-          <p:cNvSpPr txBox="1"/>
-          <p:nvPr/>
-        </p:nvSpPr>
-        <p:spPr>
-          <a:xfrm rot="0" flipH="0" flipV="0">
-            <a:off x="485775" y="4581525"/>
-            <a:ext cx="5438775" cy="190500"/>
-          </a:xfrm>
-          <a:prstGeom prst="rect"/>
-        </p:spPr>
-        <p:txBody>
-          <a:bodyPr wrap="none" lIns="0" tIns="0" rIns="0" bIns="0"/>
-          <a:p>
-            <a:pPr>
-              <a:lnSpc>
-                <a:spcPct val="128000"/>
-              </a:lnSpc>
-            </a:pPr>
-            <a:r>
-              <a:rPr lang="en-US" sz="975">
-                <a:solidFill>
-                  <a:srgbClr val="D7E3F6"/>
-                </a:solidFill>
-                <a:latin typeface="Consolas"/>
-                <a:ea typeface="Consolas"/>
-              </a:rPr>
-              <a:t xml:space="preserve">    jtj_cam, ..., resid = self._assemble_jtj(...)</a:t>
-            </a:r>
-            <a:endParaRPr/>
-          </a:p>
-        </p:txBody>
-      </p:sp>
-      <p:sp>
-        <p:nvSpPr>
-          <p:cNvPr id="187" name="" descr="{&quot;isTemplate&quot;:true,&quot;type&quot;:&quot;text&quot;}"/>
-          <p:cNvSpPr txBox="1"/>
-          <p:nvPr/>
-        </p:nvSpPr>
-        <p:spPr>
-          <a:xfrm rot="0" flipH="0" flipV="0">
-            <a:off x="485775" y="4772025"/>
-            <a:ext cx="5438775" cy="190500"/>
-          </a:xfrm>
-          <a:prstGeom prst="rect"/>
-        </p:spPr>
-        <p:txBody>
-          <a:bodyPr wrap="none" lIns="0" tIns="0" rIns="0" bIns="0"/>
-          <a:p>
-            <a:pPr>
-              <a:lnSpc>
-                <a:spcPct val="128000"/>
-              </a:lnSpc>
-            </a:pPr>
-            <a:r>
-              <a:rPr lang="en-US" sz="975">
-                <a:solidFill>
-                  <a:srgbClr val="D7E3F6"/>
-                </a:solidFill>
-                <a:latin typeface="Consolas"/>
-                <a:ea typeface="Consolas"/>
-              </a:rPr>
-              <a:t xml:space="preserve">    jtj_cam.diagonal().mul_(1 + lm)        # LM </a:t>
-            </a:r>
-            <a:r>
-              <a:rPr lang="zh-CN" sz="975">
-                <a:solidFill>
-                  <a:srgbClr val="D7E3F6"/>
-                </a:solidFill>
-                <a:latin typeface="Consolas"/>
-                <a:ea typeface="Consolas"/>
-              </a:rPr>
-              <a:t>阻尼</a:t>
-            </a:r>
-            <a:endParaRPr/>
-          </a:p>
-        </p:txBody>
-      </p:sp>
-      <p:sp>
-        <p:nvSpPr>
-          <p:cNvPr id="188" name="" descr="{&quot;isTemplate&quot;:true,&quot;type&quot;:&quot;text&quot;}"/>
-          <p:cNvSpPr txBox="1"/>
-          <p:nvPr/>
-        </p:nvSpPr>
-        <p:spPr>
-          <a:xfrm rot="0" flipH="0" flipV="0">
-            <a:off x="485775" y="4962525"/>
-            <a:ext cx="5438775" cy="190500"/>
-          </a:xfrm>
-          <a:prstGeom prst="rect"/>
-        </p:spPr>
-        <p:txBody>
-          <a:bodyPr wrap="none" lIns="0" tIns="0" rIns="0" bIns="0"/>
-          <a:p>
-            <a:pPr>
-              <a:lnSpc>
-                <a:spcPct val="128000"/>
-              </a:lnSpc>
-            </a:pPr>
-            <a:r>
-              <a:rPr lang="en-US" sz="975">
-                <a:solidFill>
-                  <a:srgbClr val="D7E3F6"/>
-                </a:solidFill>
-                <a:latin typeface="Consolas"/>
-                <a:ea typeface="Consolas"/>
-              </a:rPr>
-              <a:t xml:space="preserve">    jtj_xyz_inv = self.inv_3x3(jtj_xyz)    # C^-1</a:t>
-            </a:r>
-            <a:endParaRPr/>
-          </a:p>
-        </p:txBody>
-      </p:sp>
-      <p:sp>
-        <p:nvSpPr>
-          <p:cNvPr id="189" name="" descr="{&quot;isTemplate&quot;:true,&quot;type&quot;:&quot;text&quot;}"/>
-          <p:cNvSpPr txBox="1"/>
-          <p:nvPr/>
-        </p:nvSpPr>
-        <p:spPr>
-          <a:xfrm rot="0" flipH="0" flipV="0">
-            <a:off x="485775" y="5153025"/>
-            <a:ext cx="5438775" cy="190500"/>
-          </a:xfrm>
-          <a:prstGeom prst="rect"/>
-        </p:spPr>
-        <p:txBody>
-          <a:bodyPr wrap="none" lIns="0" tIns="0" rIns="0" bIns="0"/>
-          <a:p>
-            <a:pPr>
-              <a:lnSpc>
-                <a:spcPct val="128000"/>
-              </a:lnSpc>
-            </a:pPr>
-            <a:r>
-              <a:rPr lang="en-US" sz="975">
-                <a:solidFill>
-                  <a:srgbClr val="D7E3F6"/>
-                </a:solidFill>
-                <a:latin typeface="Consolas"/>
-                <a:ea typeface="Consolas"/>
-              </a:rPr>
-              <a:t xml:space="preserve">    S = jtj_cam - jtj_xyz_inv @ jtj_cam_xyz.T @ jtj_cam_xyz</a:t>
-            </a:r>
-            <a:endParaRPr/>
-          </a:p>
-        </p:txBody>
-      </p:sp>
-      <p:sp>
-        <p:nvSpPr>
-          <p:cNvPr id="190" name="" descr="{&quot;isTemplate&quot;:true,&quot;type&quot;:&quot;text&quot;}"/>
-          <p:cNvSpPr txBox="1"/>
-          <p:nvPr/>
-        </p:nvSpPr>
-        <p:spPr>
-          <a:xfrm rot="0" flipH="0" flipV="0">
-            <a:off x="485775" y="5343525"/>
-            <a:ext cx="5438775" cy="190500"/>
-          </a:xfrm>
-          <a:prstGeom prst="rect"/>
-        </p:spPr>
-        <p:txBody>
-          <a:bodyPr wrap="none" lIns="0" tIns="0" rIns="0" bIns="0"/>
-          <a:p>
-            <a:pPr>
-              <a:lnSpc>
-                <a:spcPct val="128000"/>
-              </a:lnSpc>
-            </a:pPr>
-            <a:r>
-              <a:rPr lang="en-US" sz="975">
-                <a:solidFill>
-                  <a:srgbClr val="D7E3F6"/>
-                </a:solidFill>
-                <a:latin typeface="Consolas"/>
-                <a:ea typeface="Consolas"/>
-              </a:rPr>
-              <a:t xml:space="preserve">    L = torch.linalg.cholesky_ex(S)[0]      # </a:t>
-            </a:r>
-            <a:r>
-              <a:rPr lang="zh-CN" sz="975">
-                <a:solidFill>
-                  <a:srgbClr val="D7E3F6"/>
-                </a:solidFill>
-                <a:latin typeface="Consolas"/>
-                <a:ea typeface="Consolas"/>
-              </a:rPr>
-              <a:t>舒尔补</a:t>
-            </a:r>
-            <a:r>
-              <a:rPr lang="en-US" sz="975">
-                <a:solidFill>
-                  <a:srgbClr val="D7E3F6"/>
-                </a:solidFill>
-                <a:latin typeface="Consolas"/>
-                <a:ea typeface="Consolas"/>
-              </a:rPr>
-              <a:t xml:space="preserve"> S</a:t>
-            </a:r>
-            <a:endParaRPr/>
-          </a:p>
-        </p:txBody>
-      </p:sp>
-      <p:sp>
-        <p:nvSpPr>
-          <p:cNvPr id="191" name="" descr="{&quot;isTemplate&quot;:true,&quot;type&quot;:&quot;text&quot;}"/>
-          <p:cNvSpPr txBox="1"/>
-          <p:nvPr/>
-        </p:nvSpPr>
-        <p:spPr>
-          <a:xfrm rot="0" flipH="0" flipV="0">
-            <a:off x="485775" y="5534025"/>
-            <a:ext cx="5438775" cy="190500"/>
-          </a:xfrm>
-          <a:prstGeom prst="rect"/>
-        </p:spPr>
-        <p:txBody>
-          <a:bodyPr wrap="none" lIns="0" tIns="0" rIns="0" bIns="0"/>
-          <a:p>
-            <a:pPr>
-              <a:lnSpc>
-                <a:spcPct val="128000"/>
-              </a:lnSpc>
-            </a:pPr>
-            <a:r>
-              <a:rPr lang="en-US" sz="975">
-                <a:solidFill>
-                  <a:srgbClr val="D7E3F6"/>
-                </a:solidFill>
-                <a:latin typeface="Consolas"/>
-                <a:ea typeface="Consolas"/>
-              </a:rPr>
-              <a:t xml:space="preserve">    dcam = torch.linalg.solve_triangular(...)  # ΔT</a:t>
-            </a:r>
-            <a:endParaRPr/>
-          </a:p>
-        </p:txBody>
-      </p:sp>
-      <p:sp>
-        <p:nvSpPr>
-          <p:cNvPr id="192" name="" descr="{&quot;isTemplate&quot;:true,&quot;type&quot;:&quot;text&quot;}"/>
-          <p:cNvSpPr txBox="1"/>
-          <p:nvPr/>
-        </p:nvSpPr>
-        <p:spPr>
-          <a:xfrm rot="0" flipH="0" flipV="0">
-            <a:off x="485775" y="5724525"/>
-            <a:ext cx="5438775" cy="190500"/>
-          </a:xfrm>
-          <a:prstGeom prst="rect"/>
-        </p:spPr>
-        <p:txBody>
-          <a:bodyPr wrap="none" lIns="0" tIns="0" rIns="0" bIns="0"/>
-          <a:p>
-            <a:pPr>
-              <a:lnSpc>
-                <a:spcPct val="128000"/>
-              </a:lnSpc>
-            </a:pPr>
-            <a:r>
-              <a:rPr lang="en-US" sz="975">
-                <a:solidFill>
-                  <a:srgbClr val="D7E3F6"/>
-                </a:solidFill>
-                <a:latin typeface="Consolas"/>
-                <a:ea typeface="Consolas"/>
-              </a:rPr>
-              <a:t xml:space="preserve">    dxyz = torch.bmm(b.view(-1, 1, 3), jtj_xyz_inv)</a:t>
-            </a:r>
-            <a:endParaRPr/>
-          </a:p>
-        </p:txBody>
-      </p:sp>
-      <p:sp>
-        <p:nvSpPr>
-          <p:cNvPr id="193" name=""/>
+      <p:pic>
+        <p:nvPicPr>
+          <p:cNvPr id="176" name=""/>
+          <p:cNvPicPr>
+            <a:picLocks noChangeAspect="1"/>
+          </p:cNvPicPr>
+          <p:nvPr/>
+        </p:nvPicPr>
+        <p:blipFill>
+          <a:blip r:embed="rId3"/>
+          <a:stretch>
+            <a:fillRect/>
+          </a:stretch>
+        </p:blipFill>
+        <p:spPr>
+          <a:xfrm rot="0" flipH="0" flipV="0">
+            <a:off x="485775" y="4362450"/>
+            <a:ext cx="5410200" cy="1524000"/>
+          </a:xfrm>
+          <a:prstGeom prst="rect">
+            <a:avLst/>
+          </a:prstGeom>
+          <a:ln/>
+        </p:spPr>
+      </p:pic>
+      <p:sp>
+        <p:nvSpPr>
+          <p:cNvPr id="177" name=""/>
           <p:cNvSpPr/>
           <p:nvPr/>
         </p:nvSpPr>
         <p:spPr>
           <a:xfrm rot="0" flipH="0" flipV="0">
-            <a:off x="6162675" y="942975"/>
-            <a:ext cx="5648325" cy="1562100"/>
+            <a:off x="6162675" y="904875"/>
+            <a:ext cx="5648325" cy="1552575"/>
           </a:xfrm>
           <a:prstGeom prst="roundRect">
             <a:avLst>
-              <a:gd name="adj" fmla="val 3049"/>
+              <a:gd name="adj" fmla="val 3067"/>
             </a:avLst>
           </a:prstGeom>
           <a:solidFill>
-            <a:srgbClr val="0F1D33"/>
+            <a:srgbClr val="1E1E1E"/>
           </a:solidFill>
           <a:ln/>
         </p:spPr>
@@ -9675,13 +8966,13 @@
       </p:sp>
       <p:sp>
         <p:nvSpPr>
-          <p:cNvPr id="194" name="" descr="{&quot;isTemplate&quot;:true,&quot;type&quot;:&quot;text&quot;}"/>
-          <p:cNvSpPr txBox="1"/>
-          <p:nvPr/>
-        </p:nvSpPr>
-        <p:spPr>
-          <a:xfrm rot="0" flipH="0" flipV="0">
-            <a:off x="6267450" y="1000125"/>
+          <p:cNvPr id="178" name="" descr="{&quot;isTemplate&quot;:true,&quot;type&quot;:&quot;text&quot;}"/>
+          <p:cNvSpPr txBox="1"/>
+          <p:nvPr/>
+        </p:nvSpPr>
+        <p:spPr>
+          <a:xfrm rot="0" flipH="0" flipV="0">
+            <a:off x="6267450" y="952500"/>
             <a:ext cx="5438775" cy="152400"/>
           </a:xfrm>
           <a:prstGeom prst="rect"/>
@@ -9720,13 +9011,13 @@
       </p:sp>
       <p:sp>
         <p:nvSpPr>
-          <p:cNvPr id="195" name="" descr="{&quot;isTemplate&quot;:true,&quot;type&quot;:&quot;text&quot;}"/>
-          <p:cNvSpPr txBox="1"/>
-          <p:nvPr/>
-        </p:nvSpPr>
-        <p:spPr>
-          <a:xfrm rot="0" flipH="0" flipV="0">
-            <a:off x="6267450" y="1162050"/>
+          <p:cNvPr id="179" name="" descr="{&quot;isTemplate&quot;:true,&quot;type&quot;:&quot;text&quot;}"/>
+          <p:cNvSpPr txBox="1"/>
+          <p:nvPr/>
+        </p:nvSpPr>
+        <p:spPr>
+          <a:xfrm rot="0" flipH="0" flipV="0">
+            <a:off x="6267450" y="1104900"/>
             <a:ext cx="5438775" cy="114300"/>
           </a:xfrm>
           <a:prstGeom prst="rect"/>
@@ -9742,7 +9033,7 @@
             <a:r>
               <a:rPr lang="en-US" sz="750">
                 <a:solidFill>
-                  <a:srgbClr val="6D87AC"/>
+                  <a:srgbClr val="7F8C9F"/>
                 </a:solidFill>
                 <a:latin typeface="Consolas"/>
                 <a:ea typeface="Consolas"/>
@@ -9753,264 +9044,49 @@
           </a:p>
         </p:txBody>
       </p:sp>
-      <p:sp>
-        <p:nvSpPr>
-          <p:cNvPr id="196" name="" descr="{&quot;isTemplate&quot;:true,&quot;type&quot;:&quot;text&quot;}"/>
-          <p:cNvSpPr txBox="1"/>
-          <p:nvPr/>
-        </p:nvSpPr>
-        <p:spPr>
-          <a:xfrm rot="0" flipH="0" flipV="0">
-            <a:off x="6267450" y="1304925"/>
-            <a:ext cx="5438775" cy="190500"/>
-          </a:xfrm>
-          <a:prstGeom prst="rect"/>
-        </p:spPr>
-        <p:txBody>
-          <a:bodyPr wrap="none" lIns="0" tIns="0" rIns="0" bIns="0"/>
-          <a:p>
-            <a:pPr>
-              <a:lnSpc>
-                <a:spcPct val="128000"/>
-              </a:lnSpc>
-            </a:pPr>
-            <a:r>
-              <a:rPr lang="en-US" sz="975">
-                <a:solidFill>
-                  <a:srgbClr val="D7E3F6"/>
-                </a:solidFill>
-                <a:latin typeface="Consolas"/>
-                <a:ea typeface="Consolas"/>
-              </a:rPr>
-              <a:t xml:space="preserve">if dists.max() &gt; self.min_loop_size:      # </a:t>
-            </a:r>
-            <a:r>
-              <a:rPr lang="zh-CN" sz="975">
-                <a:solidFill>
-                  <a:srgbClr val="D7E3F6"/>
-                </a:solidFill>
-                <a:latin typeface="Consolas"/>
-                <a:ea typeface="Consolas"/>
-              </a:rPr>
-              <a:t>图距</a:t>
-            </a:r>
-            <a:r>
-              <a:rPr lang="en-US" sz="975">
-                <a:solidFill>
-                  <a:srgbClr val="D7E3F6"/>
-                </a:solidFill>
-                <a:latin typeface="Consolas"/>
-                <a:ea typeface="Consolas"/>
-              </a:rPr>
-              <a:t xml:space="preserve"> &gt; 10</a:t>
-            </a:r>
-            <a:endParaRPr/>
-          </a:p>
-        </p:txBody>
-      </p:sp>
-      <p:sp>
-        <p:nvSpPr>
-          <p:cNvPr id="197" name="" descr="{&quot;isTemplate&quot;:true,&quot;type&quot;:&quot;text&quot;}"/>
-          <p:cNvSpPr txBox="1"/>
-          <p:nvPr/>
-        </p:nvSpPr>
-        <p:spPr>
-          <a:xfrm rot="0" flipH="0" flipV="0">
-            <a:off x="6267450" y="1495425"/>
-            <a:ext cx="5438775" cy="190500"/>
-          </a:xfrm>
-          <a:prstGeom prst="rect"/>
-        </p:spPr>
-        <p:txBody>
-          <a:bodyPr wrap="none" lIns="0" tIns="0" rIns="0" bIns="0"/>
-          <a:p>
-            <a:pPr>
-              <a:lnSpc>
-                <a:spcPct val="128000"/>
-              </a:lnSpc>
-            </a:pPr>
-            <a:r>
-              <a:rPr lang="en-US" sz="975">
-                <a:solidFill>
-                  <a:srgbClr val="D7E3F6"/>
-                </a:solidFill>
-                <a:latin typeface="Consolas"/>
-                <a:ea typeface="Consolas"/>
-              </a:rPr>
-              <a:t xml:space="preserve">    clusters_t = split_into_clusters(dists)   # </a:t>
-            </a:r>
-            <a:r>
-              <a:rPr lang="zh-CN" sz="975">
-                <a:solidFill>
-                  <a:srgbClr val="D7E3F6"/>
-                </a:solidFill>
-                <a:latin typeface="Consolas"/>
-                <a:ea typeface="Consolas"/>
-              </a:rPr>
-              <a:t>分两簇</a:t>
-            </a:r>
-            <a:endParaRPr/>
-          </a:p>
-        </p:txBody>
-      </p:sp>
-      <p:sp>
-        <p:nvSpPr>
-          <p:cNvPr id="198" name="" descr="{&quot;isTemplate&quot;:true,&quot;type&quot;:&quot;text&quot;}"/>
-          <p:cNvSpPr txBox="1"/>
-          <p:nvPr/>
-        </p:nvSpPr>
-        <p:spPr>
-          <a:xfrm rot="0" flipH="0" flipV="0">
-            <a:off x="6267450" y="1685925"/>
-            <a:ext cx="5438775" cy="190500"/>
-          </a:xfrm>
-          <a:prstGeom prst="rect"/>
-        </p:spPr>
-        <p:txBody>
-          <a:bodyPr wrap="none" lIns="0" tIns="0" rIns="0" bIns="0"/>
-          <a:p>
-            <a:pPr>
-              <a:lnSpc>
-                <a:spcPct val="128000"/>
-              </a:lnSpc>
-            </a:pPr>
-            <a:r>
-              <a:rPr lang="en-US" sz="975">
-                <a:solidFill>
-                  <a:srgbClr val="D7E3F6"/>
-                </a:solidFill>
-                <a:latin typeface="Consolas"/>
-                <a:ea typeface="Consolas"/>
-              </a:rPr>
-              <a:t>is_loop = (min(n_robust_pairs) &gt; n // 2 and</a:t>
-            </a:r>
-            <a:endParaRPr/>
-          </a:p>
-        </p:txBody>
-      </p:sp>
-      <p:sp>
-        <p:nvSpPr>
-          <p:cNvPr id="199" name="" descr="{&quot;isTemplate&quot;:true,&quot;type&quot;:&quot;text&quot;}"/>
-          <p:cNvSpPr txBox="1"/>
-          <p:nvPr/>
-        </p:nvSpPr>
-        <p:spPr>
-          <a:xfrm rot="0" flipH="0" flipV="0">
-            <a:off x="6267450" y="1876425"/>
-            <a:ext cx="5438775" cy="190500"/>
-          </a:xfrm>
-          <a:prstGeom prst="rect"/>
-        </p:spPr>
-        <p:txBody>
-          <a:bodyPr wrap="none" lIns="0" tIns="0" rIns="0" bIns="0"/>
-          <a:p>
-            <a:pPr>
-              <a:lnSpc>
-                <a:spcPct val="128000"/>
-              </a:lnSpc>
-            </a:pPr>
-            <a:r>
-              <a:rPr lang="en-US" sz="975">
-                <a:solidFill>
-                  <a:srgbClr val="D7E3F6"/>
-                </a:solidFill>
-                <a:latin typeface="Consolas"/>
-                <a:ea typeface="Consolas"/>
-              </a:rPr>
-              <a:t xml:space="preserve">           min(max_matches_robustness) &gt; 0.5 * max(...))</a:t>
-            </a:r>
-            <a:endParaRPr/>
-          </a:p>
-        </p:txBody>
-      </p:sp>
-      <p:sp>
-        <p:nvSpPr>
-          <p:cNvPr id="200" name="" descr="{&quot;isTemplate&quot;:true,&quot;type&quot;:&quot;text&quot;}"/>
-          <p:cNvSpPr txBox="1"/>
-          <p:nvPr/>
-        </p:nvSpPr>
-        <p:spPr>
-          <a:xfrm rot="0" flipH="0" flipV="0">
-            <a:off x="6267450" y="2066925"/>
-            <a:ext cx="5438775" cy="190500"/>
-          </a:xfrm>
-          <a:prstGeom prst="rect"/>
-        </p:spPr>
-        <p:txBody>
-          <a:bodyPr wrap="none" lIns="0" tIns="0" rIns="0" bIns="0"/>
-          <a:p>
-            <a:pPr>
-              <a:lnSpc>
-                <a:spcPct val="128000"/>
-              </a:lnSpc>
-            </a:pPr>
-            <a:r>
-              <a:rPr lang="en-US" sz="975">
-                <a:solidFill>
-                  <a:srgbClr val="D7E3F6"/>
-                </a:solidFill>
-                <a:latin typeface="Consolas"/>
-                <a:ea typeface="Consolas"/>
-              </a:rPr>
-              <a:t>if len(match.kpts) &gt;= self.min_matches_edge:   # τm=500</a:t>
-            </a:r>
-            <a:endParaRPr/>
-          </a:p>
-        </p:txBody>
-      </p:sp>
-      <p:sp>
-        <p:nvSpPr>
-          <p:cNvPr id="201" name="" descr="{&quot;isTemplate&quot;:true,&quot;type&quot;:&quot;text&quot;}"/>
-          <p:cNvSpPr txBox="1"/>
-          <p:nvPr/>
-        </p:nvSpPr>
-        <p:spPr>
-          <a:xfrm rot="0" flipH="0" flipV="0">
-            <a:off x="6267450" y="2257425"/>
-            <a:ext cx="5438775" cy="190500"/>
-          </a:xfrm>
-          <a:prstGeom prst="rect"/>
-        </p:spPr>
-        <p:txBody>
-          <a:bodyPr wrap="none" lIns="0" tIns="0" rIns="0" bIns="0"/>
-          <a:p>
-            <a:pPr>
-              <a:lnSpc>
-                <a:spcPct val="128000"/>
-              </a:lnSpc>
-            </a:pPr>
-            <a:r>
-              <a:rPr lang="en-US" sz="975">
-                <a:solidFill>
-                  <a:srgbClr val="D7E3F6"/>
-                </a:solidFill>
-                <a:latin typeface="Consolas"/>
-                <a:ea typeface="Consolas"/>
-              </a:rPr>
-              <a:t xml:space="preserve">    self.pose_graph.add_match(i, j, 1.0 / len(match.kpts))</a:t>
-            </a:r>
-            <a:endParaRPr/>
-          </a:p>
-        </p:txBody>
-      </p:sp>
-      <p:sp>
-        <p:nvSpPr>
-          <p:cNvPr id="202" name=""/>
+      <p:pic>
+        <p:nvPicPr>
+          <p:cNvPr id="180" name=""/>
+          <p:cNvPicPr>
+            <a:picLocks noChangeAspect="1"/>
+          </p:cNvPicPr>
+          <p:nvPr/>
+        </p:nvPicPr>
+        <p:blipFill>
+          <a:blip r:embed="rId4"/>
+          <a:stretch>
+            <a:fillRect/>
+          </a:stretch>
+        </p:blipFill>
+        <p:spPr>
+          <a:xfrm rot="0" flipH="0" flipV="0">
+            <a:off x="6267450" y="1238250"/>
+            <a:ext cx="5410200" cy="1171575"/>
+          </a:xfrm>
+          <a:prstGeom prst="rect">
+            <a:avLst/>
+          </a:prstGeom>
+          <a:ln/>
+        </p:spPr>
+      </p:pic>
+      <p:sp>
+        <p:nvSpPr>
+          <p:cNvPr id="181" name=""/>
           <p:cNvSpPr/>
           <p:nvPr/>
         </p:nvSpPr>
         <p:spPr>
           <a:xfrm rot="0" flipH="0" flipV="0">
-            <a:off x="6162675" y="2581275"/>
-            <a:ext cx="5648325" cy="1181100"/>
+            <a:off x="6162675" y="2552700"/>
+            <a:ext cx="5648325" cy="1200150"/>
           </a:xfrm>
           <a:prstGeom prst="roundRect">
             <a:avLst>
-              <a:gd name="adj" fmla="val 4032"/>
+              <a:gd name="adj" fmla="val 3968"/>
             </a:avLst>
           </a:prstGeom>
           <a:solidFill>
-            <a:srgbClr val="0F1D33"/>
+            <a:srgbClr val="1E1E1E"/>
           </a:solidFill>
           <a:ln/>
         </p:spPr>
@@ -10021,13 +9097,13 @@
       </p:sp>
       <p:sp>
         <p:nvSpPr>
-          <p:cNvPr id="203" name="" descr="{&quot;isTemplate&quot;:true,&quot;type&quot;:&quot;text&quot;}"/>
-          <p:cNvSpPr txBox="1"/>
-          <p:nvPr/>
-        </p:nvSpPr>
-        <p:spPr>
-          <a:xfrm rot="0" flipH="0" flipV="0">
-            <a:off x="6267450" y="2638425"/>
+          <p:cNvPr id="182" name="" descr="{&quot;isTemplate&quot;:true,&quot;type&quot;:&quot;text&quot;}"/>
+          <p:cNvSpPr txBox="1"/>
+          <p:nvPr/>
+        </p:nvSpPr>
+        <p:spPr>
+          <a:xfrm rot="0" flipH="0" flipV="0">
+            <a:off x="6267450" y="2600325"/>
             <a:ext cx="5438775" cy="152400"/>
           </a:xfrm>
           <a:prstGeom prst="rect"/>
@@ -10066,13 +9142,13 @@
       </p:sp>
       <p:sp>
         <p:nvSpPr>
-          <p:cNvPr id="204" name="" descr="{&quot;isTemplate&quot;:true,&quot;type&quot;:&quot;text&quot;}"/>
-          <p:cNvSpPr txBox="1"/>
-          <p:nvPr/>
-        </p:nvSpPr>
-        <p:spPr>
-          <a:xfrm rot="0" flipH="0" flipV="0">
-            <a:off x="6267450" y="2800350"/>
+          <p:cNvPr id="183" name="" descr="{&quot;isTemplate&quot;:true,&quot;type&quot;:&quot;text&quot;}"/>
+          <p:cNvSpPr txBox="1"/>
+          <p:nvPr/>
+        </p:nvSpPr>
+        <p:spPr>
+          <a:xfrm rot="0" flipH="0" flipV="0">
+            <a:off x="6267450" y="2752725"/>
             <a:ext cx="5438775" cy="114300"/>
           </a:xfrm>
           <a:prstGeom prst="rect"/>
@@ -10088,7 +9164,7 @@
             <a:r>
               <a:rPr lang="en-US" sz="750">
                 <a:solidFill>
-                  <a:srgbClr val="6D87AC"/>
+                  <a:srgbClr val="7F8C9F"/>
                 </a:solidFill>
                 <a:latin typeface="Consolas"/>
                 <a:ea typeface="Consolas"/>
@@ -10099,174 +9175,49 @@
           </a:p>
         </p:txBody>
       </p:sp>
-      <p:sp>
-        <p:nvSpPr>
-          <p:cNvPr id="205" name="" descr="{&quot;isTemplate&quot;:true,&quot;type&quot;:&quot;text&quot;}"/>
-          <p:cNvSpPr txBox="1"/>
-          <p:nvPr/>
-        </p:nvSpPr>
-        <p:spPr>
-          <a:xfrm rot="0" flipH="0" flipV="0">
-            <a:off x="6267450" y="2943225"/>
-            <a:ext cx="5438775" cy="190500"/>
-          </a:xfrm>
-          <a:prstGeom prst="rect"/>
-        </p:spPr>
-        <p:txBody>
-          <a:bodyPr wrap="none" lIns="0" tIns="0" rIns="0" bIns="0"/>
-          <a:p>
-            <a:pPr>
-              <a:lnSpc>
-                <a:spcPct val="128000"/>
-              </a:lnSpc>
-            </a:pPr>
-            <a:r>
-              <a:rPr lang="en-US" sz="975">
-                <a:solidFill>
-                  <a:srgbClr val="D7E3F6"/>
-                </a:solidFill>
-                <a:latin typeface="Consolas"/>
-                <a:ea typeface="Consolas"/>
-              </a:rPr>
-              <a:t>tri_idepth = 1 / (pts3d[has_pt3d] @ R.T + t)[..., -1]</a:t>
-            </a:r>
-            <a:endParaRPr/>
-          </a:p>
-        </p:txBody>
-      </p:sp>
-      <p:sp>
-        <p:nvSpPr>
-          <p:cNvPr id="206" name="" descr="{&quot;isTemplate&quot;:true,&quot;type&quot;:&quot;text&quot;}"/>
-          <p:cNvSpPr txBox="1"/>
-          <p:nvPr/>
-        </p:nvSpPr>
-        <p:spPr>
-          <a:xfrm rot="0" flipH="0" flipV="0">
-            <a:off x="6267450" y="3133725"/>
-            <a:ext cx="5438775" cy="190500"/>
-          </a:xfrm>
-          <a:prstGeom prst="rect"/>
-        </p:spPr>
-        <p:txBody>
-          <a:bodyPr wrap="none" lIns="0" tIns="0" rIns="0" bIns="0"/>
-          <a:p>
-            <a:pPr>
-              <a:lnSpc>
-                <a:spcPct val="128000"/>
-              </a:lnSpc>
-            </a:pPr>
-            <a:r>
-              <a:rPr lang="en-US" sz="975">
-                <a:solidFill>
-                  <a:srgbClr val="D7E3F6"/>
-                </a:solidFill>
-                <a:latin typeface="Consolas"/>
-                <a:ea typeface="Consolas"/>
-              </a:rPr>
-              <a:t>mono_al, g_s, g_o = align_samples(tri_idepth, sampled)</a:t>
-            </a:r>
-            <a:endParaRPr/>
-          </a:p>
-        </p:txBody>
-      </p:sp>
-      <p:sp>
-        <p:nvSpPr>
-          <p:cNvPr id="207" name="" descr="{&quot;isTemplate&quot;:true,&quot;type&quot;:&quot;text&quot;}"/>
-          <p:cNvSpPr txBox="1"/>
-          <p:nvPr/>
-        </p:nvSpPr>
-        <p:spPr>
-          <a:xfrm rot="0" flipH="0" flipV="0">
-            <a:off x="6267450" y="3324225"/>
-            <a:ext cx="5438775" cy="190500"/>
-          </a:xfrm>
-          <a:prstGeom prst="rect"/>
-        </p:spPr>
-        <p:txBody>
-          <a:bodyPr wrap="none" lIns="0" tIns="0" rIns="0" bIns="0"/>
-          <a:p>
-            <a:pPr>
-              <a:lnSpc>
-                <a:spcPct val="128000"/>
-              </a:lnSpc>
-            </a:pPr>
-            <a:r>
-              <a:rPr lang="en-US" sz="975">
-                <a:solidFill>
-                  <a:srgbClr val="D7E3F6"/>
-                </a:solidFill>
-                <a:latin typeface="Consolas"/>
-                <a:ea typeface="Consolas"/>
-              </a:rPr>
-              <a:t>valid = err &lt; m_err + grid_outlier_mult * err_dev</a:t>
-            </a:r>
-            <a:endParaRPr/>
-          </a:p>
-        </p:txBody>
-      </p:sp>
-      <p:sp>
-        <p:nvSpPr>
-          <p:cNvPr id="208" name="" descr="{&quot;isTemplate&quot;:true,&quot;type&quot;:&quot;text&quot;}"/>
-          <p:cNvSpPr txBox="1"/>
-          <p:nvPr/>
-        </p:nvSpPr>
-        <p:spPr>
-          <a:xfrm rot="0" flipH="0" flipV="0">
-            <a:off x="6267450" y="3514725"/>
-            <a:ext cx="5438775" cy="190500"/>
-          </a:xfrm>
-          <a:prstGeom prst="rect"/>
-        </p:spPr>
-        <p:txBody>
-          <a:bodyPr wrap="none" lIns="0" tIns="0" rIns="0" bIns="0"/>
-          <a:p>
-            <a:pPr>
-              <a:lnSpc>
-                <a:spcPct val="128000"/>
-              </a:lnSpc>
-            </a:pPr>
-            <a:r>
-              <a:rPr lang="en-US" sz="975">
-                <a:solidFill>
-                  <a:srgbClr val="D7E3F6"/>
-                </a:solidFill>
-                <a:latin typeface="Consolas"/>
-                <a:ea typeface="Consolas"/>
-              </a:rPr>
-              <a:t xml:space="preserve">return align_depth_grid(..., 4, g_s, g_o)   # 4x4 </a:t>
-            </a:r>
-            <a:r>
-              <a:rPr lang="zh-CN" sz="975">
-                <a:solidFill>
-                  <a:srgbClr val="D7E3F6"/>
-                </a:solidFill>
-                <a:latin typeface="Consolas"/>
-                <a:ea typeface="Consolas"/>
-              </a:rPr>
-              <a:t>分块</a:t>
-            </a:r>
-            <a:endParaRPr/>
-          </a:p>
-        </p:txBody>
-      </p:sp>
-      <p:sp>
-        <p:nvSpPr>
-          <p:cNvPr id="209" name=""/>
+      <p:pic>
+        <p:nvPicPr>
+          <p:cNvPr id="184" name=""/>
+          <p:cNvPicPr>
+            <a:picLocks noChangeAspect="1"/>
+          </p:cNvPicPr>
+          <p:nvPr/>
+        </p:nvPicPr>
+        <p:blipFill>
+          <a:blip r:embed="rId5"/>
+          <a:stretch>
+            <a:fillRect/>
+          </a:stretch>
+        </p:blipFill>
+        <p:spPr>
+          <a:xfrm rot="0" flipH="0" flipV="0">
+            <a:off x="6267450" y="2886075"/>
+            <a:ext cx="5410200" cy="819150"/>
+          </a:xfrm>
+          <a:prstGeom prst="rect">
+            <a:avLst/>
+          </a:prstGeom>
+          <a:ln/>
+        </p:spPr>
+      </p:pic>
+      <p:sp>
+        <p:nvSpPr>
+          <p:cNvPr id="185" name=""/>
           <p:cNvSpPr/>
           <p:nvPr/>
         </p:nvSpPr>
         <p:spPr>
           <a:xfrm rot="0" flipH="0" flipV="0">
-            <a:off x="6162675" y="3838575"/>
-            <a:ext cx="5648325" cy="1371600"/>
+            <a:off x="6162675" y="3848100"/>
+            <a:ext cx="5648325" cy="1381125"/>
           </a:xfrm>
           <a:prstGeom prst="roundRect">
             <a:avLst>
-              <a:gd name="adj" fmla="val 3472"/>
+              <a:gd name="adj" fmla="val 3448"/>
             </a:avLst>
           </a:prstGeom>
           <a:solidFill>
-            <a:srgbClr val="0F1D33"/>
+            <a:srgbClr val="1E1E1E"/>
           </a:solidFill>
           <a:ln/>
         </p:spPr>
@@ -10277,7 +9228,7 @@
       </p:sp>
       <p:sp>
         <p:nvSpPr>
-          <p:cNvPr id="210" name="" descr="{&quot;isTemplate&quot;:true,&quot;type&quot;:&quot;text&quot;}"/>
+          <p:cNvPr id="186" name="" descr="{&quot;isTemplate&quot;:true,&quot;type&quot;:&quot;text&quot;}"/>
           <p:cNvSpPr txBox="1"/>
           <p:nvPr/>
         </p:nvSpPr>
@@ -10322,13 +9273,13 @@
       </p:sp>
       <p:sp>
         <p:nvSpPr>
-          <p:cNvPr id="211" name="" descr="{&quot;isTemplate&quot;:true,&quot;type&quot;:&quot;text&quot;}"/>
-          <p:cNvSpPr txBox="1"/>
-          <p:nvPr/>
-        </p:nvSpPr>
-        <p:spPr>
-          <a:xfrm rot="0" flipH="0" flipV="0">
-            <a:off x="6267450" y="4057650"/>
+          <p:cNvPr id="187" name="" descr="{&quot;isTemplate&quot;:true,&quot;type&quot;:&quot;text&quot;}"/>
+          <p:cNvSpPr txBox="1"/>
+          <p:nvPr/>
+        </p:nvSpPr>
+        <p:spPr>
+          <a:xfrm rot="0" flipH="0" flipV="0">
+            <a:off x="6267450" y="4048125"/>
             <a:ext cx="5438775" cy="114300"/>
           </a:xfrm>
           <a:prstGeom prst="rect"/>
@@ -10344,7 +9295,7 @@
             <a:r>
               <a:rPr lang="en-US" sz="750">
                 <a:solidFill>
-                  <a:srgbClr val="6D87AC"/>
+                  <a:srgbClr val="7F8C9F"/>
                 </a:solidFill>
                 <a:latin typeface="Consolas"/>
                 <a:ea typeface="Consolas"/>
@@ -10355,241 +9306,42 @@
           </a:p>
         </p:txBody>
       </p:sp>
-      <p:sp>
-        <p:nvSpPr>
-          <p:cNvPr id="212" name="" descr="{&quot;isTemplate&quot;:true,&quot;type&quot;:&quot;text&quot;}"/>
-          <p:cNvSpPr txBox="1"/>
-          <p:nvPr/>
-        </p:nvSpPr>
-        <p:spPr>
-          <a:xfrm rot="0" flipH="0" flipV="0">
-            <a:off x="6267450" y="4200525"/>
-            <a:ext cx="5438775" cy="190500"/>
-          </a:xfrm>
-          <a:prstGeom prst="rect"/>
-        </p:spPr>
-        <p:txBody>
-          <a:bodyPr wrap="none" lIns="0" tIns="0" rIns="0" bIns="0"/>
-          <a:p>
-            <a:pPr>
-              <a:lnSpc>
-                <a:spcPct val="128000"/>
-              </a:lnSpc>
-            </a:pPr>
-            <a:r>
-              <a:rPr lang="en-US" sz="975">
-                <a:solidFill>
-                  <a:srgbClr val="D7E3F6"/>
-                </a:solidFill>
-                <a:latin typeface="Consolas"/>
-                <a:ea typeface="Consolas"/>
-              </a:rPr>
-              <a:t>mask = screen_size &lt; self.hierarchy_screen_size_threshold  # 0.5 px</a:t>
-            </a:r>
-            <a:endParaRPr/>
-          </a:p>
-        </p:txBody>
-      </p:sp>
-      <p:sp>
-        <p:nvSpPr>
-          <p:cNvPr id="213" name="" descr="{&quot;isTemplate&quot;:true,&quot;type&quot;:&quot;text&quot;}"/>
-          <p:cNvSpPr txBox="1"/>
-          <p:nvPr/>
-        </p:nvSpPr>
-        <p:spPr>
-          <a:xfrm rot="0" flipH="0" flipV="0">
-            <a:off x="6267450" y="4391025"/>
-            <a:ext cx="5438775" cy="190500"/>
-          </a:xfrm>
-          <a:prstGeom prst="rect"/>
-        </p:spPr>
-        <p:txBody>
-          <a:bodyPr wrap="none" lIns="0" tIns="0" rIns="0" bIns="0"/>
-          <a:p>
-            <a:pPr>
-              <a:lnSpc>
-                <a:spcPct val="128000"/>
-              </a:lnSpc>
-            </a:pPr>
-            <a:r>
-              <a:rPr lang="en-US" sz="975">
-                <a:solidFill>
-                  <a:srgbClr val="D7E3F6"/>
-                </a:solidFill>
-                <a:latin typeface="Consolas"/>
-                <a:ea typeface="Consolas"/>
-              </a:rPr>
-              <a:t>if mask.sum() &gt; max(len(self.xyz) * 0.1, 200_000):</a:t>
-            </a:r>
-            <a:endParaRPr/>
-          </a:p>
-        </p:txBody>
-      </p:sp>
-      <p:sp>
-        <p:nvSpPr>
-          <p:cNvPr id="214" name="" descr="{&quot;isTemplate&quot;:true,&quot;type&quot;:&quot;text&quot;}"/>
-          <p:cNvSpPr txBox="1"/>
-          <p:nvPr/>
-        </p:nvSpPr>
-        <p:spPr>
-          <a:xfrm rot="0" flipH="0" flipV="0">
-            <a:off x="6267450" y="4581525"/>
-            <a:ext cx="5438775" cy="190500"/>
-          </a:xfrm>
-          <a:prstGeom prst="rect"/>
-        </p:spPr>
-        <p:txBody>
-          <a:bodyPr wrap="none" lIns="0" tIns="0" rIns="0" bIns="0"/>
-          <a:p>
-            <a:pPr>
-              <a:lnSpc>
-                <a:spcPct val="128000"/>
-              </a:lnSpc>
-            </a:pPr>
-            <a:r>
-              <a:rPr lang="en-US" sz="975">
-                <a:solidFill>
-                  <a:srgbClr val="D7E3F6"/>
-                </a:solidFill>
-                <a:latin typeface="Consolas"/>
-                <a:ea typeface="Consolas"/>
-              </a:rPr>
-              <a:t xml:space="preserve">    n_merged = self.create_hierarchy_level(cam_centre, mask)</a:t>
-            </a:r>
-            <a:endParaRPr/>
-          </a:p>
-        </p:txBody>
-      </p:sp>
-      <p:sp>
-        <p:nvSpPr>
-          <p:cNvPr id="215" name="" descr="{&quot;isTemplate&quot;:true,&quot;type&quot;:&quot;text&quot;}"/>
-          <p:cNvSpPr txBox="1"/>
-          <p:nvPr/>
-        </p:nvSpPr>
-        <p:spPr>
-          <a:xfrm rot="0" flipH="0" flipV="0">
-            <a:off x="6267450" y="4772025"/>
-            <a:ext cx="5438775" cy="190500"/>
-          </a:xfrm>
-          <a:prstGeom prst="rect"/>
-        </p:spPr>
-        <p:txBody>
-          <a:bodyPr wrap="none" lIns="0" tIns="0" rIns="0" bIns="0"/>
-          <a:p>
-            <a:pPr>
-              <a:lnSpc>
-                <a:spcPct val="128000"/>
-              </a:lnSpc>
-            </a:pPr>
-            <a:r>
-              <a:rPr lang="en-US" sz="975">
-                <a:solidFill>
-                  <a:srgbClr val="D7E3F6"/>
-                </a:solidFill>
-                <a:latin typeface="Consolas"/>
-                <a:ea typeface="Consolas"/>
-              </a:rPr>
-              <a:t xml:space="preserve"># </a:t>
-            </a:r>
-            <a:r>
-              <a:rPr lang="zh-CN" sz="975">
-                <a:solidFill>
-                  <a:srgbClr val="D7E3F6"/>
-                </a:solidFill>
-                <a:latin typeface="Consolas"/>
-                <a:ea typeface="Consolas"/>
-              </a:rPr>
-              <a:t>合并权重</a:t>
-            </a:r>
-            <a:r>
-              <a:rPr lang="en-US" sz="975">
-                <a:solidFill>
-                  <a:srgbClr val="D7E3F6"/>
-                </a:solidFill>
-                <a:latin typeface="Consolas"/>
-                <a:ea typeface="Consolas"/>
-              </a:rPr>
-              <a:t xml:space="preserve"> = opacity * screen_size^2</a:t>
-            </a:r>
-            <a:r>
-              <a:rPr lang="zh-CN" sz="975">
-                <a:solidFill>
-                  <a:srgbClr val="D7E3F6"/>
-                </a:solidFill>
-                <a:latin typeface="Consolas"/>
-                <a:ea typeface="Consolas"/>
-              </a:rPr>
-              <a:t>（非</a:t>
-            </a:r>
-            <a:r>
-              <a:rPr lang="en-US" sz="975">
-                <a:solidFill>
-                  <a:srgbClr val="D7E3F6"/>
-                </a:solidFill>
-                <a:latin typeface="Consolas"/>
-                <a:ea typeface="Consolas"/>
-              </a:rPr>
-              <a:t xml:space="preserve"> KL </a:t>
-            </a:r>
-            <a:r>
-              <a:rPr lang="zh-CN" sz="975">
-                <a:solidFill>
-                  <a:srgbClr val="D7E3F6"/>
-                </a:solidFill>
-                <a:latin typeface="Consolas"/>
-                <a:ea typeface="Consolas"/>
-              </a:rPr>
-              <a:t>投影）</a:t>
-            </a:r>
-            <a:endParaRPr/>
-          </a:p>
-        </p:txBody>
-      </p:sp>
-      <p:sp>
-        <p:nvSpPr>
-          <p:cNvPr id="216" name="" descr="{&quot;isTemplate&quot;:true,&quot;type&quot;:&quot;text&quot;}"/>
-          <p:cNvSpPr txBox="1"/>
-          <p:nvPr/>
-        </p:nvSpPr>
-        <p:spPr>
-          <a:xfrm rot="0" flipH="0" flipV="0">
-            <a:off x="6267450" y="4962525"/>
-            <a:ext cx="5438775" cy="190500"/>
-          </a:xfrm>
-          <a:prstGeom prst="rect"/>
-        </p:spPr>
-        <p:txBody>
-          <a:bodyPr wrap="none" lIns="0" tIns="0" rIns="0" bIns="0"/>
-          <a:p>
-            <a:pPr>
-              <a:lnSpc>
-                <a:spcPct val="128000"/>
-              </a:lnSpc>
-            </a:pPr>
-            <a:r>
-              <a:rPr lang="en-US" sz="975">
-                <a:solidFill>
-                  <a:srgbClr val="D7E3F6"/>
-                </a:solidFill>
-                <a:latin typeface="Consolas"/>
-                <a:ea typeface="Consolas"/>
-              </a:rPr>
-              <a:t>weights = opa.sigmoid() * screen_size[selected] ** 2</a:t>
-            </a:r>
-            <a:endParaRPr/>
-          </a:p>
-        </p:txBody>
-      </p:sp>
-      <p:sp>
-        <p:nvSpPr>
-          <p:cNvPr id="217" name="" descr="{&quot;isTemplate&quot;:true,&quot;type&quot;:&quot;text&quot;}"/>
-          <p:cNvSpPr txBox="1"/>
-          <p:nvPr/>
-        </p:nvSpPr>
-        <p:spPr>
-          <a:xfrm rot="0" flipH="0" flipV="0">
-            <a:off x="381000" y="6048375"/>
-            <a:ext cx="11430000" cy="457200"/>
+      <p:pic>
+        <p:nvPicPr>
+          <p:cNvPr id="188" name=""/>
+          <p:cNvPicPr>
+            <a:picLocks noChangeAspect="1"/>
+          </p:cNvPicPr>
+          <p:nvPr/>
+        </p:nvPicPr>
+        <p:blipFill>
+          <a:blip r:embed="rId6"/>
+          <a:srcRect l="238" t="0" r="238" b="0"/>
+          <a:stretch>
+            <a:fillRect/>
+          </a:stretch>
+        </p:blipFill>
+        <p:spPr>
+          <a:xfrm rot="0" flipH="0" flipV="0">
+            <a:off x="6267450" y="4181475"/>
+            <a:ext cx="5410200" cy="1000125"/>
+          </a:xfrm>
+          <a:prstGeom prst="rect">
+            <a:avLst/>
+          </a:prstGeom>
+          <a:ln/>
+        </p:spPr>
+      </p:pic>
+      <p:sp>
+        <p:nvSpPr>
+          <p:cNvPr id="189" name="" descr="{&quot;isTemplate&quot;:true,&quot;type&quot;:&quot;text&quot;}"/>
+          <p:cNvSpPr txBox="1"/>
+          <p:nvPr/>
+        </p:nvSpPr>
+        <p:spPr>
+          <a:xfrm rot="0" flipH="0" flipV="0">
+            <a:off x="381000" y="6000750"/>
+            <a:ext cx="11430000" cy="419100"/>
           </a:xfrm>
           <a:prstGeom prst="rect"/>
         </p:spPr>
@@ -10600,21 +9352,21 @@
           <a:p>
             <a:pPr>
               <a:lnSpc>
-                <a:spcPct val="140000"/>
-              </a:lnSpc>
-            </a:pPr>
-            <a:r>
-              <a:rPr lang="zh-CN" sz="1050">
+                <a:spcPct val="135000"/>
+              </a:lnSpc>
+            </a:pPr>
+            <a:r>
+              <a:rPr lang="zh-CN" sz="1013">
                 <a:solidFill>
                   <a:srgbClr val="8B97A8"/>
                 </a:solidFill>
                 <a:latin typeface="Microsoft YaHei"/>
                 <a:ea typeface="Microsoft YaHei"/>
               </a:rPr>
-              <a:t>为排版做了换行与变量缩写（</a:t>
-            </a:r>
-            <a:r>
-              <a:rPr lang="en-US" sz="1050">
+              <a:t>行号指向片段起点；为投影宽度做了换行与变量缩写（</a:t>
+            </a:r>
+            <a:r>
+              <a:rPr lang="en-US" sz="1013">
                 <a:solidFill>
                   <a:srgbClr val="8B97A8"/>
                 </a:solidFill>
@@ -10624,7 +9376,7 @@
               <a:t>w = edge_weight</a:t>
             </a:r>
             <a:r>
-              <a:rPr lang="zh-CN" sz="1050">
+              <a:rPr lang="zh-CN" sz="1013">
                 <a:solidFill>
                   <a:srgbClr val="8B97A8"/>
                 </a:solidFill>
@@ -10634,7 +9386,7 @@
               <a:t>），逻辑未改。第</a:t>
             </a:r>
             <a:r>
-              <a:rPr lang="en-US" sz="1050">
+              <a:rPr lang="en-US" sz="1013">
                 <a:solidFill>
                   <a:srgbClr val="8B97A8"/>
                 </a:solidFill>
@@ -10644,17 +9396,17 @@
               <a:t xml:space="preserve"> 7 </a:t>
             </a:r>
             <a:r>
-              <a:rPr lang="zh-CN" sz="1050">
+              <a:rPr lang="zh-CN" sz="1013">
                 <a:solidFill>
                   <a:srgbClr val="8B97A8"/>
                 </a:solidFill>
                 <a:latin typeface="Microsoft YaHei"/>
                 <a:ea typeface="Microsoft YaHei"/>
               </a:rPr>
-              <a:t>页按源码默认值修正：回环触发为</a:t>
-            </a:r>
-            <a:r>
-              <a:rPr lang="zh-CN" sz="1050">
+              <a:t>页已按源码默认值修正：回环触发为</a:t>
+            </a:r>
+            <a:r>
+              <a:rPr lang="zh-CN" sz="1013">
                 <a:solidFill>
                   <a:srgbClr val="8B97A8"/>
                 </a:solidFill>
@@ -10664,7 +9416,7 @@
               <a:t>加权图距</a:t>
             </a:r>
             <a:r>
-              <a:rPr lang="en-US" sz="1050">
+              <a:rPr lang="en-US" sz="1013">
                 <a:solidFill>
                   <a:srgbClr val="8B97A8"/>
                 </a:solidFill>
@@ -10674,7 +9426,7 @@
               <a:t xml:space="preserve"> &gt; 10</a:t>
             </a:r>
             <a:r>
-              <a:rPr lang="zh-CN" sz="1050">
+              <a:rPr lang="zh-CN" sz="1013">
                 <a:solidFill>
                   <a:srgbClr val="8B97A8"/>
                 </a:solidFill>
@@ -10684,7 +9436,7 @@
               <a:t>；层级合并触发为</a:t>
             </a:r>
             <a:r>
-              <a:rPr lang="zh-CN" sz="1050">
+              <a:rPr lang="zh-CN" sz="1013">
                 <a:solidFill>
                   <a:srgbClr val="8B97A8"/>
                 </a:solidFill>
@@ -10694,7 +9446,7 @@
               <a:t>可并数</a:t>
             </a:r>
             <a:r>
-              <a:rPr lang="en-US" sz="1050">
+              <a:rPr lang="en-US" sz="1013">
                 <a:solidFill>
                   <a:srgbClr val="8B97A8"/>
                 </a:solidFill>
@@ -10704,7 +9456,7 @@
               <a:t xml:space="preserve"> &gt; max(10%, 20 </a:t>
             </a:r>
             <a:r>
-              <a:rPr lang="zh-CN" sz="1050">
+              <a:rPr lang="zh-CN" sz="1013">
                 <a:solidFill>
                   <a:srgbClr val="8B97A8"/>
                 </a:solidFill>
@@ -10714,7 +9466,7 @@
               <a:t>万</a:t>
             </a:r>
             <a:r>
-              <a:rPr lang="en-US" sz="1050">
+              <a:rPr lang="en-US" sz="1013">
                 <a:solidFill>
                   <a:srgbClr val="8B97A8"/>
                 </a:solidFill>
@@ -10724,7 +9476,7 @@
               <a:t>)</a:t>
             </a:r>
             <a:r>
-              <a:rPr lang="zh-CN" sz="1050">
+              <a:rPr lang="zh-CN" sz="1013">
                 <a:solidFill>
                   <a:srgbClr val="8B97A8"/>
                 </a:solidFill>
@@ -10734,7 +9486,7 @@
               <a:t>，且是</a:t>
             </a:r>
             <a:r>
-              <a:rPr lang="en-US" sz="1050">
+              <a:rPr lang="en-US" sz="1013">
                 <a:solidFill>
                   <a:srgbClr val="8B97A8"/>
                 </a:solidFill>
@@ -10744,7 +9496,7 @@
               <a:t xml:space="preserve"> </a:t>
             </a:r>
             <a:r>
-              <a:rPr lang="en-US" sz="1050">
+              <a:rPr lang="en-US" sz="1013">
                 <a:solidFill>
                   <a:srgbClr val="8B97A8"/>
                 </a:solidFill>
@@ -10754,7 +9506,7 @@
               <a:t xml:space="preserve">kNN </a:t>
             </a:r>
             <a:r>
-              <a:rPr lang="zh-CN" sz="1050">
+              <a:rPr lang="zh-CN" sz="1013">
                 <a:solidFill>
                   <a:srgbClr val="8B97A8"/>
                 </a:solidFill>
@@ -10764,7 +9516,7 @@
               <a:t>加权平均</a:t>
             </a:r>
             <a:r>
-              <a:rPr lang="zh-CN" sz="1050">
+              <a:rPr lang="zh-CN" sz="1013">
                 <a:solidFill>
                   <a:srgbClr val="8B97A8"/>
                 </a:solidFill>
@@ -10774,7 +9526,7 @@
               <a:t>而非</a:t>
             </a:r>
             <a:r>
-              <a:rPr lang="en-US" sz="1050">
+              <a:rPr lang="en-US" sz="1013">
                 <a:solidFill>
                   <a:srgbClr val="8B97A8"/>
                 </a:solidFill>
@@ -10784,7 +9536,7 @@
               <a:t xml:space="preserve"> KL</a:t>
             </a:r>
             <a:r>
-              <a:rPr lang="zh-CN" sz="1050">
+              <a:rPr lang="zh-CN" sz="1013">
                 <a:solidFill>
                   <a:srgbClr val="8B97A8"/>
                 </a:solidFill>
@@ -10807,7 +9559,7 @@
   <p:cSld>
     <p:spTree>
       <p:nvGrpSpPr>
-        <p:cNvPr id="218" name="" descr="&lt;Slide style={{ width: '1280px', height: '720px', backgroundColor: '#FFFFFF', padding: '0px', flexDirection: 'column' }}&gt;&#10;    &lt;Box style={{ width: '1280px', height: '8px', backgroundColor: '#1E4FA8' }} /&gt;&#10;    &lt;Box style={{ padding: '34px 40px 0px 40px', flexDirection: 'row', justifyContent: 'space-between', alignItems: 'flex-end' }}&gt;&#10;        &lt;Text style={{ fontSize: 34, fontWeight: 'bold', color: '#1E4FA8' }}&gt;摘要&lt;/Text&gt;&#10;        &lt;Text style={{ fontSize: 15, color: '#8B97A8' }}&gt;02 / 15&lt;/Text&gt;&#10;    &lt;/Box&gt;&#10;    &lt;Box style={{ padding: '20px 40px 0px 40px', flexDirection: 'column', gap: 13 }}&gt;&#10;        &lt;Box style={{ backgroundColor: '#F0F5FC', borderLeft: '5px solid #1E4FA8', padding: '14px 20px', flexDirection: 'column' }}&gt;&#10;            &lt;Text style={{ fontSize: 22, fontWeight: 'bold', color: '#1E4FA8' }}&gt;问题&lt;/Text&gt;&#10;            &lt;Text style={{ fontSize: 22, color: '#1A2230', lineHeight: 1.5, marginTop: 6 }}&gt;3DGS 重建质量高、可实时渲染，但训练前必须由 SfM（COLMAP）离线解算相机位姿；SfM 要等&lt;b&gt;全部图像到齐&lt;/b&gt;，且对&lt;b&gt;乱序采集&lt;/b&gt;敏感。&lt;/Text&gt;&#10;        &lt;/Box&gt;&#10;        &lt;Box style={{ backgroundColor: '#F7F9FC', borderLeft: '5px solid #4A5568', padding: '14px 20px', flexDirection: 'column' }}&gt;&#10;            &lt;Text style={{ fontSize: 22, fontWeight: 'bold', color: '#4A5568' }}&gt;现状缺口&lt;/Text&gt;&#10;            &lt;Text style={{ fontSize: 22, color: '#1A2230', lineHeight: 1.5, marginTop: 6 }}&gt;离线 SfM + 3DGS 质量好、但慢且无现场反馈；SLAM 类增量重建能实时，却&lt;b&gt;假设图像有序&lt;/b&gt;——两者之间没人补齐。&lt;/Text&gt;&#10;        &lt;/Box&gt;&#10;        &lt;Box style={{ backgroundColor: '#F0F5FC', borderLeft: '5px solid #1E4FA8', padding: '14px 20px', flexDirection: 'column' }}&gt;&#10;            &lt;Text style={{ fontSize: 22, fontWeight: 'bold', color: '#1E4FA8' }}&gt;本文做法&lt;/Text&gt;&#10;            &lt;Text style={{ fontSize: 22, color: '#1A2230', lineHeight: 1.5, marginTop: 6 }}&gt;首个面向无序输入、具备全局一致性的即时反馈 3DGS 重建：两级快速匹配 + GPU 局部 BA + 簇级回环图传播 + 渐进式高斯层级。&lt;/Text&gt;&#10;        &lt;/Box&gt;&#10;        &lt;Box style={{ backgroundColor: '#F7F9FC', borderLeft: '5px solid #3D7BD9', padding: '14px 20px', flexDirection: 'column' }}&gt;&#10;            &lt;Text style={{ fontSize: 22, fontWeight: 'bold', color: '#3D7BD9' }}&gt;结果与复现&lt;/Text&gt;&#10;            &lt;Text style={{ fontSize: 22, color: '#1A2230', lineHeight: 1.5, marginTop: 6 }}&gt;MipNeRF360 上 &lt;b&gt;1 分 17 秒&lt;/b&gt;达到 &lt;b&gt;26.29 dB&lt;/b&gt;（离线参考 8 分 50 秒 / 27.52 dB）；输入打乱仅降 &lt;b&gt;0.5 dB&lt;/b&gt;。我们完成了端到端复现：&lt;b&gt;25.95 dB / 62.7 秒 / 185 帧&lt;/b&gt;。&lt;/Text&gt;&#10;        &lt;/Box&gt;&#10;    &lt;/Box&gt;&#10;    &lt;Box style={{ padding: '16px 40px 0px 40px' }}&gt;&#10;        &lt;Text style={{ fontSize: 16, color: '#4A5568' }}&gt;关键词：三维高斯泼溅 · 无序采集 · 即时重建 · 协视图 · 回环闭合 · 渐进式层级&lt;/Text&gt;&#10;    &lt;/Box&gt;&#10;&lt;/Slide&gt;&#10;"/>
+        <p:cNvPr id="190" name="" descr="&lt;Slide style={{ width: '1280px', height: '720px', backgroundColor: '#FFFFFF', padding: '0px', flexDirection: 'column' }}&gt;&#10;    &lt;Box style={{ width: '1280px', height: '8px', backgroundColor: '#1E4FA8' }} /&gt;&#10;    &lt;Box style={{ padding: '34px 40px 0px 40px', flexDirection: 'row', justifyContent: 'space-between', alignItems: 'flex-end' }}&gt;&#10;        &lt;Text style={{ fontSize: 34, fontWeight: 'bold', color: '#1E4FA8' }}&gt;摘要&lt;/Text&gt;&#10;        &lt;Text style={{ fontSize: 15, color: '#8B97A8' }}&gt;02 / 15&lt;/Text&gt;&#10;    &lt;/Box&gt;&#10;    &lt;Box style={{ padding: '20px 40px 0px 40px', flexDirection: 'column', gap: 13 }}&gt;&#10;        &lt;Box style={{ backgroundColor: '#F0F5FC', borderLeft: '5px solid #1E4FA8', padding: '14px 20px', flexDirection: 'column' }}&gt;&#10;            &lt;Text style={{ fontSize: 22, fontWeight: 'bold', color: '#1E4FA8' }}&gt;问题&lt;/Text&gt;&#10;            &lt;Text style={{ fontSize: 22, color: '#1A2230', lineHeight: 1.5, marginTop: 6 }}&gt;3DGS 重建质量高、可实时渲染，但训练前必须由 SfM（COLMAP）离线解算相机位姿；SfM 要等&lt;b&gt;全部图像到齐&lt;/b&gt;，且对&lt;b&gt;乱序采集&lt;/b&gt;敏感。&lt;/Text&gt;&#10;        &lt;/Box&gt;&#10;        &lt;Box style={{ backgroundColor: '#F7F9FC', borderLeft: '5px solid #4A5568', padding: '14px 20px', flexDirection: 'column' }}&gt;&#10;            &lt;Text style={{ fontSize: 22, fontWeight: 'bold', color: '#4A5568' }}&gt;现状缺口&lt;/Text&gt;&#10;            &lt;Text style={{ fontSize: 22, color: '#1A2230', lineHeight: 1.5, marginTop: 6 }}&gt;离线 SfM + 3DGS 质量好、但慢且无现场反馈；SLAM 类增量重建能实时，却&lt;b&gt;假设图像有序&lt;/b&gt;——两者之间没人补齐。&lt;/Text&gt;&#10;        &lt;/Box&gt;&#10;        &lt;Box style={{ backgroundColor: '#F0F5FC', borderLeft: '5px solid #1E4FA8', padding: '14px 20px', flexDirection: 'column' }}&gt;&#10;            &lt;Text style={{ fontSize: 22, fontWeight: 'bold', color: '#1E4FA8' }}&gt;本文做法&lt;/Text&gt;&#10;            &lt;Text style={{ fontSize: 22, color: '#1A2230', lineHeight: 1.5, marginTop: 6 }}&gt;首个面向无序输入、具备全局一致性的即时反馈 3DGS 重建：两级快速匹配 + GPU 局部 BA + 簇级回环图传播 + 渐进式高斯层级。&lt;/Text&gt;&#10;        &lt;/Box&gt;&#10;        &lt;Box style={{ backgroundColor: '#F7F9FC', borderLeft: '5px solid #3D7BD9', padding: '14px 20px', flexDirection: 'column' }}&gt;&#10;            &lt;Text style={{ fontSize: 22, fontWeight: 'bold', color: '#3D7BD9' }}&gt;结果与复现&lt;/Text&gt;&#10;            &lt;Text style={{ fontSize: 22, color: '#1A2230', lineHeight: 1.5, marginTop: 6 }}&gt;MipNeRF360 上 &lt;b&gt;1 分 17 秒&lt;/b&gt;达到 &lt;b&gt;26.29 dB&lt;/b&gt;（离线参考 8 分 50 秒 / 27.52 dB）；输入打乱仅降 &lt;b&gt;0.5 dB&lt;/b&gt;。我们完成了端到端复现：&lt;b&gt;25.95 dB / 62.7 秒 / 185 帧&lt;/b&gt;。&lt;/Text&gt;&#10;        &lt;/Box&gt;&#10;    &lt;/Box&gt;&#10;    &lt;Box style={{ padding: '16px 40px 0px 40px' }}&gt;&#10;        &lt;Text style={{ fontSize: 16, color: '#4A5568' }}&gt;关键词：三维高斯泼溅 · 无序采集 · 即时重建 · 协视图 · 回环闭合 · 渐进式层级&lt;/Text&gt;&#10;    &lt;/Box&gt;&#10;&lt;/Slide&gt;&#10;"/>
         <p:cNvGrpSpPr/>
         <p:nvPr/>
       </p:nvGrpSpPr>
@@ -10821,7 +9573,7 @@
       </p:grpSpPr>
       <p:sp>
         <p:nvSpPr>
-          <p:cNvPr id="219" name=""/>
+          <p:cNvPr id="191" name=""/>
           <p:cNvSpPr/>
           <p:nvPr/>
         </p:nvSpPr>
@@ -10845,7 +9597,7 @@
       </p:sp>
       <p:sp>
         <p:nvSpPr>
-          <p:cNvPr id="220" name=""/>
+          <p:cNvPr id="192" name=""/>
           <p:cNvSpPr/>
           <p:nvPr/>
         </p:nvSpPr>
@@ -10869,7 +9621,7 @@
       </p:sp>
       <p:sp>
         <p:nvSpPr>
-          <p:cNvPr id="221" name="" descr="{&quot;isTemplate&quot;:true,&quot;type&quot;:&quot;text&quot;}"/>
+          <p:cNvPr id="193" name="" descr="{&quot;isTemplate&quot;:true,&quot;type&quot;:&quot;text&quot;}"/>
           <p:cNvSpPr txBox="1"/>
           <p:nvPr/>
         </p:nvSpPr>
@@ -10904,7 +9656,7 @@
       </p:sp>
       <p:sp>
         <p:nvSpPr>
-          <p:cNvPr id="222" name="" descr="{&quot;isTemplate&quot;:true,&quot;type&quot;:&quot;text&quot;}"/>
+          <p:cNvPr id="194" name="" descr="{&quot;isTemplate&quot;:true,&quot;type&quot;:&quot;text&quot;}"/>
           <p:cNvSpPr txBox="1"/>
           <p:nvPr/>
         </p:nvSpPr>
@@ -10939,7 +9691,7 @@
       </p:sp>
       <p:sp>
         <p:nvSpPr>
-          <p:cNvPr id="223" name=""/>
+          <p:cNvPr id="195" name=""/>
           <p:cNvSpPr/>
           <p:nvPr/>
         </p:nvSpPr>
@@ -10963,7 +9715,7 @@
       </p:sp>
       <p:sp>
         <p:nvSpPr>
-          <p:cNvPr id="224" name=""/>
+          <p:cNvPr id="196" name=""/>
           <p:cNvSpPr/>
           <p:nvPr/>
         </p:nvSpPr>
@@ -11003,7 +9755,7 @@
       </p:sp>
       <p:sp>
         <p:nvSpPr>
-          <p:cNvPr id="225" name="" descr="{&quot;isTemplate&quot;:true,&quot;type&quot;:&quot;text&quot;}"/>
+          <p:cNvPr id="197" name="" descr="{&quot;isTemplate&quot;:true,&quot;type&quot;:&quot;text&quot;}"/>
           <p:cNvSpPr txBox="1"/>
           <p:nvPr/>
         </p:nvSpPr>
@@ -11038,7 +9790,7 @@
       </p:sp>
       <p:sp>
         <p:nvSpPr>
-          <p:cNvPr id="226" name="" descr="{&quot;isTemplate&quot;:true,&quot;type&quot;:&quot;text&quot;}"/>
+          <p:cNvPr id="198" name="" descr="{&quot;isTemplate&quot;:true,&quot;type&quot;:&quot;text&quot;}"/>
           <p:cNvSpPr txBox="1"/>
           <p:nvPr/>
         </p:nvSpPr>
@@ -11185,7 +9937,7 @@
       </p:sp>
       <p:sp>
         <p:nvSpPr>
-          <p:cNvPr id="227" name=""/>
+          <p:cNvPr id="199" name=""/>
           <p:cNvSpPr/>
           <p:nvPr/>
         </p:nvSpPr>
@@ -11209,7 +9961,7 @@
       </p:sp>
       <p:sp>
         <p:nvSpPr>
-          <p:cNvPr id="228" name=""/>
+          <p:cNvPr id="200" name=""/>
           <p:cNvSpPr/>
           <p:nvPr/>
         </p:nvSpPr>
@@ -11249,7 +10001,7 @@
       </p:sp>
       <p:sp>
         <p:nvSpPr>
-          <p:cNvPr id="229" name="" descr="{&quot;isTemplate&quot;:true,&quot;type&quot;:&quot;text&quot;}"/>
+          <p:cNvPr id="201" name="" descr="{&quot;isTemplate&quot;:true,&quot;type&quot;:&quot;text&quot;}"/>
           <p:cNvSpPr txBox="1"/>
           <p:nvPr/>
         </p:nvSpPr>
@@ -11284,7 +10036,7 @@
       </p:sp>
       <p:sp>
         <p:nvSpPr>
-          <p:cNvPr id="230" name="" descr="{&quot;isTemplate&quot;:true,&quot;type&quot;:&quot;text&quot;}"/>
+          <p:cNvPr id="202" name="" descr="{&quot;isTemplate&quot;:true,&quot;type&quot;:&quot;text&quot;}"/>
           <p:cNvSpPr txBox="1"/>
           <p:nvPr/>
         </p:nvSpPr>
@@ -11379,7 +10131,7 @@
       </p:sp>
       <p:sp>
         <p:nvSpPr>
-          <p:cNvPr id="231" name=""/>
+          <p:cNvPr id="203" name=""/>
           <p:cNvSpPr/>
           <p:nvPr/>
         </p:nvSpPr>
@@ -11403,7 +10155,7 @@
       </p:sp>
       <p:sp>
         <p:nvSpPr>
-          <p:cNvPr id="232" name=""/>
+          <p:cNvPr id="204" name=""/>
           <p:cNvSpPr/>
           <p:nvPr/>
         </p:nvSpPr>
@@ -11443,7 +10195,7 @@
       </p:sp>
       <p:sp>
         <p:nvSpPr>
-          <p:cNvPr id="233" name="" descr="{&quot;isTemplate&quot;:true,&quot;type&quot;:&quot;text&quot;}"/>
+          <p:cNvPr id="205" name="" descr="{&quot;isTemplate&quot;:true,&quot;type&quot;:&quot;text&quot;}"/>
           <p:cNvSpPr txBox="1"/>
           <p:nvPr/>
         </p:nvSpPr>
@@ -11478,7 +10230,7 @@
       </p:sp>
       <p:sp>
         <p:nvSpPr>
-          <p:cNvPr id="234" name="" descr="{&quot;isTemplate&quot;:true,&quot;type&quot;:&quot;text&quot;}"/>
+          <p:cNvPr id="206" name="" descr="{&quot;isTemplate&quot;:true,&quot;type&quot;:&quot;text&quot;}"/>
           <p:cNvSpPr txBox="1"/>
           <p:nvPr/>
         </p:nvSpPr>
@@ -11595,7 +10347,7 @@
       </p:sp>
       <p:sp>
         <p:nvSpPr>
-          <p:cNvPr id="235" name=""/>
+          <p:cNvPr id="207" name=""/>
           <p:cNvSpPr/>
           <p:nvPr/>
         </p:nvSpPr>
@@ -11619,7 +10371,7 @@
       </p:sp>
       <p:sp>
         <p:nvSpPr>
-          <p:cNvPr id="236" name=""/>
+          <p:cNvPr id="208" name=""/>
           <p:cNvSpPr/>
           <p:nvPr/>
         </p:nvSpPr>
@@ -11659,7 +10411,7 @@
       </p:sp>
       <p:sp>
         <p:nvSpPr>
-          <p:cNvPr id="237" name="" descr="{&quot;isTemplate&quot;:true,&quot;type&quot;:&quot;text&quot;}"/>
+          <p:cNvPr id="209" name="" descr="{&quot;isTemplate&quot;:true,&quot;type&quot;:&quot;text&quot;}"/>
           <p:cNvSpPr txBox="1"/>
           <p:nvPr/>
         </p:nvSpPr>
@@ -11694,7 +10446,7 @@
       </p:sp>
       <p:sp>
         <p:nvSpPr>
-          <p:cNvPr id="238" name="" descr="{&quot;isTemplate&quot;:true,&quot;type&quot;:&quot;text&quot;}"/>
+          <p:cNvPr id="210" name="" descr="{&quot;isTemplate&quot;:true,&quot;type&quot;:&quot;text&quot;}"/>
           <p:cNvSpPr txBox="1"/>
           <p:nvPr/>
         </p:nvSpPr>
@@ -11971,7 +10723,7 @@
       </p:sp>
       <p:sp>
         <p:nvSpPr>
-          <p:cNvPr id="239" name="" descr="{&quot;isTemplate&quot;:true,&quot;type&quot;:&quot;text&quot;}"/>
+          <p:cNvPr id="211" name="" descr="{&quot;isTemplate&quot;:true,&quot;type&quot;:&quot;text&quot;}"/>
           <p:cNvSpPr txBox="1"/>
           <p:nvPr/>
         </p:nvSpPr>
@@ -12114,7 +10866,7 @@
   <p:cSld>
     <p:spTree>
       <p:nvGrpSpPr>
-        <p:cNvPr id="240" name="" descr="&lt;Slide style={{ width: '1280px', height: '720px', backgroundColor: '#FFFFFF', padding: '0px', flexDirection: 'column' }}&gt;&#10;    &lt;Box style={{ width: '1280px', height: '8px', backgroundColor: '#1E4FA8' }} /&gt;&#10;    &lt;Box style={{ padding: '34px 40px 0px 40px', flexDirection: 'row', justifyContent: 'space-between', alignItems: 'flex-end' }}&gt;&#10;        &lt;Text style={{ fontSize: 34, fontWeight: 'bold', color: '#1E4FA8' }}&gt;主要贡献点&lt;/Text&gt;&#10;        &lt;Text style={{ fontSize: 15, color: '#8B97A8' }}&gt;03 / 15&lt;/Text&gt;&#10;    &lt;/Box&gt;&#10;    &lt;Box style={{ padding: '22px 40px 0px 40px', flexDirection: 'row', gap: 20 }}&gt;&#10;        &lt;Box style={{ flex: 1, backgroundColor: '#F7F9FC', border: '1px solid #D6DCE5', borderRadius: 6, padding: '18px 20px', flexDirection: 'column' }}&gt;&#10;            &lt;Box style={{ flexDirection: 'row', alignItems: 'center', gap: 10 }}&gt;&#10;                &lt;Box style={{ width: '34px', height: '34px', backgroundColor: '#1E4FA8', borderRadius: 4, alignItems: 'center', justifyContent: 'center' }}&gt;&#10;                    &lt;Text style={{ fontSize: 20, fontWeight: 'bold', color: '#FFFFFF' }}&gt;1&lt;/Text&gt;&#10;                &lt;/Box&gt;&#10;                &lt;Text style={{ fontSize: 24, fontWeight: 'bold', color: '#1A2230' }}&gt;无序序列快速匹配&lt;/Text&gt;&#10;            &lt;/Box&gt;&#10;            &lt;Text style={{ fontSize: 22, color: '#1A2230', lineHeight: 1.55, marginTop: 12 }}&gt;视觉位置识别 → XFeat 粗筛 → LightGlue 精验，三级把匹配代价从 O(n²) 降到常数级。&lt;/Text&gt;&#10;            &lt;Text style={{ fontSize: 20, color: '#1E4FA8', fontWeight: 'bold', marginTop: 14 }}&gt;配加权协视图 + 高连通关键帧贪心选取&lt;/Text&gt;&#10;        &lt;/Box&gt;&#10;        &lt;Box style={{ flex: 1, backgroundColor: '#F7F9FC', border: '1px solid #D6DCE5', borderRadius: 6, padding: '18px 20px', flexDirection: 'column' }}&gt;&#10;            &lt;Box style={{ flexDirection: 'row', alignItems: 'center', gap: 10 }}&gt;&#10;                &lt;Box style={{ width: '34px', height: '34px', backgroundColor: '#1E4FA8', borderRadius: 4, alignItems: 'center', justifyContent: 'center' }}&gt;&#10;                    &lt;Text style={{ fontSize: 20, fontWeight: 'bold', color: '#FFFFFF' }}&gt;2&lt;/Text&gt;&#10;                &lt;/Box&gt;&#10;                &lt;Text style={{ fontSize: 24, fontWeight: 'bold', color: '#1A2230' }}&gt;GPU 局部重建&lt;/Text&gt;&#10;            &lt;/Box&gt;&#10;            &lt;Text style={{ fontSize: 22, color: '#1A2230', lineHeight: 1.55, marginTop: 12 }}&gt;自写 BA 核函数（稠密 Schur 补），20 关键帧 / 1 万路标点下比现有优化器快约 5 倍。&lt;/Text&gt;&#10;            &lt;Text style={{ fontSize: 20, color: '#1E4FA8', fontWeight: 'bold', marginTop: 14 }}&gt;分块深度对齐，让高斯贴住真实表面&lt;/Text&gt;&#10;        &lt;/Box&gt;&#10;    &lt;/Box&gt;&#10;    &lt;Box style={{ padding: '20px 40px 0px 40px', flexDirection: 'row', gap: 20 }}&gt;&#10;        &lt;Box style={{ flex: 1, backgroundColor: '#F7F9FC', border: '1px solid #D6DCE5', borderRadius: 6, padding: '18px 20px', flexDirection: 'column' }}&gt;&#10;            &lt;Box style={{ flexDirection: 'row', alignItems: 'center', gap: 10 }}&gt;&#10;                &lt;Box style={{ width: '34px', height: '34px', backgroundColor: '#1E4FA8', borderRadius: 4, alignItems: 'center', justifyContent: 'center' }}&gt;&#10;                    &lt;Text style={{ fontSize: 20, fontWeight: 'bold', color: '#FFFFFF' }}&gt;3&lt;/Text&gt;&#10;                &lt;/Box&gt;&#10;                &lt;Text style={{ fontSize: 24, fontWeight: 'bold', color: '#1A2230' }}&gt;簇级回环闭合&lt;/Text&gt;&#10;            &lt;/Box&gt;&#10;            &lt;Text style={{ fontSize: 22, color: '#1A2230', lineHeight: 1.55, marginTop: 12 }}&gt;用协视图&quot;跳数距离&quot;判回环；焊接窗口 BA + Dijkstra 主干路径测地插值，把 Sim(3) 修正传到全图。&lt;/Text&gt;&#10;            &lt;Text style={{ fontSize: 20, color: '#D9534F', fontWeight: 'bold', marginTop: 14 }}&gt;关键：无需第二次全局优化&lt;/Text&gt;&#10;        &lt;/Box&gt;&#10;        &lt;Box style={{ flex: 1, backgroundColor: '#F0F5FC', border: '1px solid #3D7BD9', borderRadius: 6, padding: '18px 20px', flexDirection: 'column' }}&gt;&#10;            &lt;Box style={{ flexDirection: 'row', alignItems: 'center', gap: 10 }}&gt;&#10;                &lt;Box style={{ width: '34px', height: '34px', backgroundColor: '#0E3F8C', borderRadius: 4, alignItems: 'center', justifyContent: 'center' }}&gt;&#10;                    &lt;Text style={{ fontSize: 20, fontWeight: 'bold', color: '#FFFFFF' }}&gt;4&lt;/Text&gt;&#10;                &lt;/Box&gt;&#10;                &lt;Text style={{ fontSize: 24, fontWeight: 'bold', color: '#1A2230' }}&gt;渐进式高斯层级&lt;/Text&gt;&#10;            &lt;/Box&gt;&#10;            &lt;Text style={{ fontSize: 22, color: '#1A2230', lineHeight: 1.55, marginTop: 12 }}&gt;按屏幕尺寸合并 / 回取，叶节点卸载到 CPU；4050 帧大场景显存仍控制在 12.8 GB 内。&lt;/Text&gt;&#10;            &lt;Text style={{ fontSize: 20, color: '#1E4FA8', fontWeight: 'bold', marginTop: 14 }}&gt;峰值高斯 &amp;lt; 370 万，层级达 8 层&lt;/Text&gt;&#10;        &lt;/Box&gt;&#10;    &lt;/Box&gt;&#10;&lt;/Slide&gt;&#10;"/>
+        <p:cNvPr id="212" name="" descr="&lt;Slide style={{ width: '1280px', height: '720px', backgroundColor: '#FFFFFF', padding: '0px', flexDirection: 'column' }}&gt;&#10;    &lt;Box style={{ width: '1280px', height: '8px', backgroundColor: '#1E4FA8' }} /&gt;&#10;    &lt;Box style={{ padding: '34px 40px 0px 40px', flexDirection: 'row', justifyContent: 'space-between', alignItems: 'flex-end' }}&gt;&#10;        &lt;Text style={{ fontSize: 34, fontWeight: 'bold', color: '#1E4FA8' }}&gt;主要贡献点&lt;/Text&gt;&#10;        &lt;Text style={{ fontSize: 15, color: '#8B97A8' }}&gt;03 / 15&lt;/Text&gt;&#10;    &lt;/Box&gt;&#10;    &lt;Box style={{ padding: '22px 40px 0px 40px', flexDirection: 'row', gap: 20 }}&gt;&#10;        &lt;Box style={{ flex: 1, backgroundColor: '#F7F9FC', border: '1px solid #D6DCE5', borderRadius: 6, padding: '18px 20px', flexDirection: 'column' }}&gt;&#10;            &lt;Box style={{ flexDirection: 'row', alignItems: 'center', gap: 10 }}&gt;&#10;                &lt;Box style={{ width: '34px', height: '34px', backgroundColor: '#1E4FA8', borderRadius: 4, alignItems: 'center', justifyContent: 'center' }}&gt;&#10;                    &lt;Text style={{ fontSize: 20, fontWeight: 'bold', color: '#FFFFFF' }}&gt;1&lt;/Text&gt;&#10;                &lt;/Box&gt;&#10;                &lt;Text style={{ fontSize: 24, fontWeight: 'bold', color: '#1A2230' }}&gt;无序序列快速匹配&lt;/Text&gt;&#10;            &lt;/Box&gt;&#10;            &lt;Text style={{ fontSize: 22, color: '#1A2230', lineHeight: 1.55, marginTop: 12 }}&gt;视觉位置识别 → XFeat 粗筛 → LightGlue 精验，三级把匹配代价从 O(n²) 降到常数级。&lt;/Text&gt;&#10;            &lt;Text style={{ fontSize: 20, color: '#1E4FA8', fontWeight: 'bold', marginTop: 14 }}&gt;配加权协视图 + 高连通关键帧贪心选取&lt;/Text&gt;&#10;        &lt;/Box&gt;&#10;        &lt;Box style={{ flex: 1, backgroundColor: '#F7F9FC', border: '1px solid #D6DCE5', borderRadius: 6, padding: '18px 20px', flexDirection: 'column' }}&gt;&#10;            &lt;Box style={{ flexDirection: 'row', alignItems: 'center', gap: 10 }}&gt;&#10;                &lt;Box style={{ width: '34px', height: '34px', backgroundColor: '#1E4FA8', borderRadius: 4, alignItems: 'center', justifyContent: 'center' }}&gt;&#10;                    &lt;Text style={{ fontSize: 20, fontWeight: 'bold', color: '#FFFFFF' }}&gt;2&lt;/Text&gt;&#10;                &lt;/Box&gt;&#10;                &lt;Text style={{ fontSize: 24, fontWeight: 'bold', color: '#1A2230' }}&gt;GPU 局部重建&lt;/Text&gt;&#10;            &lt;/Box&gt;&#10;            &lt;Text style={{ fontSize: 22, color: '#1A2230', lineHeight: 1.55, marginTop: 12 }}&gt;自写 BA 核函数（稠密 Schur 补），20 关键帧 / 1 万路标点下比现有优化器快约 5 倍。&lt;/Text&gt;&#10;            &lt;Text style={{ fontSize: 20, color: '#1E4FA8', fontWeight: 'bold', marginTop: 14 }}&gt;分块深度对齐，让高斯贴住真实表面&lt;/Text&gt;&#10;        &lt;/Box&gt;&#10;    &lt;/Box&gt;&#10;    &lt;Box style={{ padding: '20px 40px 0px 40px', flexDirection: 'row', gap: 20 }}&gt;&#10;        &lt;Box style={{ flex: 1, backgroundColor: '#F7F9FC', border: '1px solid #D6DCE5', borderRadius: 6, padding: '18px 20px', flexDirection: 'column' }}&gt;&#10;            &lt;Box style={{ flexDirection: 'row', alignItems: 'center', gap: 10 }}&gt;&#10;                &lt;Box style={{ width: '34px', height: '34px', backgroundColor: '#1E4FA8', borderRadius: 4, alignItems: 'center', justifyContent: 'center' }}&gt;&#10;                    &lt;Text style={{ fontSize: 20, fontWeight: 'bold', color: '#FFFFFF' }}&gt;3&lt;/Text&gt;&#10;                &lt;/Box&gt;&#10;                &lt;Text style={{ fontSize: 24, fontWeight: 'bold', color: '#1A2230' }}&gt;簇级回环闭合&lt;/Text&gt;&#10;            &lt;/Box&gt;&#10;            &lt;Text style={{ fontSize: 22, color: '#1A2230', lineHeight: 1.55, marginTop: 12 }}&gt;用协视图&quot;跳数距离&quot;判回环；焊接窗口 BA + Dijkstra 主干路径测地插值，把 Sim(3) 修正传到全图。&lt;/Text&gt;&#10;            &lt;Text style={{ fontSize: 20, color: '#D9534F', fontWeight: 'bold', marginTop: 14 }}&gt;关键：无需第二次全局优化&lt;/Text&gt;&#10;        &lt;/Box&gt;&#10;        &lt;Box style={{ flex: 1, backgroundColor: '#F0F5FC', border: '1px solid #3D7BD9', borderRadius: 6, padding: '18px 20px', flexDirection: 'column' }}&gt;&#10;            &lt;Box style={{ flexDirection: 'row', alignItems: 'center', gap: 10 }}&gt;&#10;                &lt;Box style={{ width: '34px', height: '34px', backgroundColor: '#0E3F8C', borderRadius: 4, alignItems: 'center', justifyContent: 'center' }}&gt;&#10;                    &lt;Text style={{ fontSize: 20, fontWeight: 'bold', color: '#FFFFFF' }}&gt;4&lt;/Text&gt;&#10;                &lt;/Box&gt;&#10;                &lt;Text style={{ fontSize: 24, fontWeight: 'bold', color: '#1A2230' }}&gt;渐进式高斯层级&lt;/Text&gt;&#10;            &lt;/Box&gt;&#10;            &lt;Text style={{ fontSize: 22, color: '#1A2230', lineHeight: 1.55, marginTop: 12 }}&gt;按屏幕尺寸合并 / 回取，叶节点卸载到 CPU；4050 帧大场景显存仍控制在 12.8 GB 内。&lt;/Text&gt;&#10;            &lt;Text style={{ fontSize: 20, color: '#1E4FA8', fontWeight: 'bold', marginTop: 14 }}&gt;峰值高斯 &amp;lt; 370 万，层级达 8 层&lt;/Text&gt;&#10;        &lt;/Box&gt;&#10;    &lt;/Box&gt;&#10;&lt;/Slide&gt;&#10;"/>
         <p:cNvGrpSpPr/>
         <p:nvPr/>
       </p:nvGrpSpPr>
@@ -12128,7 +10880,7 @@
       </p:grpSpPr>
       <p:sp>
         <p:nvSpPr>
-          <p:cNvPr id="241" name=""/>
+          <p:cNvPr id="213" name=""/>
           <p:cNvSpPr/>
           <p:nvPr/>
         </p:nvSpPr>
@@ -12152,7 +10904,7 @@
       </p:sp>
       <p:sp>
         <p:nvSpPr>
-          <p:cNvPr id="242" name=""/>
+          <p:cNvPr id="214" name=""/>
           <p:cNvSpPr/>
           <p:nvPr/>
         </p:nvSpPr>
@@ -12176,7 +10928,7 @@
       </p:sp>
       <p:sp>
         <p:nvSpPr>
-          <p:cNvPr id="243" name="" descr="{&quot;isTemplate&quot;:true,&quot;type&quot;:&quot;text&quot;}"/>
+          <p:cNvPr id="215" name="" descr="{&quot;isTemplate&quot;:true,&quot;type&quot;:&quot;text&quot;}"/>
           <p:cNvSpPr txBox="1"/>
           <p:nvPr/>
         </p:nvSpPr>
@@ -12211,7 +10963,7 @@
       </p:sp>
       <p:sp>
         <p:nvSpPr>
-          <p:cNvPr id="244" name="" descr="{&quot;isTemplate&quot;:true,&quot;type&quot;:&quot;text&quot;}"/>
+          <p:cNvPr id="216" name="" descr="{&quot;isTemplate&quot;:true,&quot;type&quot;:&quot;text&quot;}"/>
           <p:cNvSpPr txBox="1"/>
           <p:nvPr/>
         </p:nvSpPr>
@@ -12246,7 +10998,7 @@
       </p:sp>
       <p:sp>
         <p:nvSpPr>
-          <p:cNvPr id="245" name=""/>
+          <p:cNvPr id="217" name=""/>
           <p:cNvSpPr/>
           <p:nvPr/>
         </p:nvSpPr>
@@ -12277,7 +11029,7 @@
       </p:sp>
       <p:sp>
         <p:nvSpPr>
-          <p:cNvPr id="246" name=""/>
+          <p:cNvPr id="218" name=""/>
           <p:cNvSpPr/>
           <p:nvPr/>
         </p:nvSpPr>
@@ -12303,7 +11055,7 @@
       </p:sp>
       <p:sp>
         <p:nvSpPr>
-          <p:cNvPr id="247" name="" descr="{&quot;isTemplate&quot;:true,&quot;type&quot;:&quot;text&quot;}"/>
+          <p:cNvPr id="219" name="" descr="{&quot;isTemplate&quot;:true,&quot;type&quot;:&quot;text&quot;}"/>
           <p:cNvSpPr txBox="1"/>
           <p:nvPr/>
         </p:nvSpPr>
@@ -12338,7 +11090,7 @@
       </p:sp>
       <p:sp>
         <p:nvSpPr>
-          <p:cNvPr id="248" name="" descr="{&quot;isTemplate&quot;:true,&quot;type&quot;:&quot;text&quot;}"/>
+          <p:cNvPr id="220" name="" descr="{&quot;isTemplate&quot;:true,&quot;type&quot;:&quot;text&quot;}"/>
           <p:cNvSpPr txBox="1"/>
           <p:nvPr/>
         </p:nvSpPr>
@@ -12373,7 +11125,7 @@
       </p:sp>
       <p:sp>
         <p:nvSpPr>
-          <p:cNvPr id="249" name="" descr="{&quot;isTemplate&quot;:true,&quot;type&quot;:&quot;text&quot;}"/>
+          <p:cNvPr id="221" name="" descr="{&quot;isTemplate&quot;:true,&quot;type&quot;:&quot;text&quot;}"/>
           <p:cNvSpPr txBox="1"/>
           <p:nvPr/>
         </p:nvSpPr>
@@ -12470,7 +11222,7 @@
       </p:sp>
       <p:sp>
         <p:nvSpPr>
-          <p:cNvPr id="250" name="" descr="{&quot;isTemplate&quot;:true,&quot;type&quot;:&quot;text&quot;}"/>
+          <p:cNvPr id="222" name="" descr="{&quot;isTemplate&quot;:true,&quot;type&quot;:&quot;text&quot;}"/>
           <p:cNvSpPr txBox="1"/>
           <p:nvPr/>
         </p:nvSpPr>
@@ -12525,7 +11277,7 @@
       </p:sp>
       <p:sp>
         <p:nvSpPr>
-          <p:cNvPr id="251" name=""/>
+          <p:cNvPr id="223" name=""/>
           <p:cNvSpPr/>
           <p:nvPr/>
         </p:nvSpPr>
@@ -12556,7 +11308,7 @@
       </p:sp>
       <p:sp>
         <p:nvSpPr>
-          <p:cNvPr id="252" name=""/>
+          <p:cNvPr id="224" name=""/>
           <p:cNvSpPr/>
           <p:nvPr/>
         </p:nvSpPr>
@@ -12582,7 +11334,7 @@
       </p:sp>
       <p:sp>
         <p:nvSpPr>
-          <p:cNvPr id="253" name="" descr="{&quot;isTemplate&quot;:true,&quot;type&quot;:&quot;text&quot;}"/>
+          <p:cNvPr id="225" name="" descr="{&quot;isTemplate&quot;:true,&quot;type&quot;:&quot;text&quot;}"/>
           <p:cNvSpPr txBox="1"/>
           <p:nvPr/>
         </p:nvSpPr>
@@ -12617,7 +11369,7 @@
       </p:sp>
       <p:sp>
         <p:nvSpPr>
-          <p:cNvPr id="254" name="" descr="{&quot;isTemplate&quot;:true,&quot;type&quot;:&quot;text&quot;}"/>
+          <p:cNvPr id="226" name="" descr="{&quot;isTemplate&quot;:true,&quot;type&quot;:&quot;text&quot;}"/>
           <p:cNvSpPr txBox="1"/>
           <p:nvPr/>
         </p:nvSpPr>
@@ -12662,7 +11414,7 @@
       </p:sp>
       <p:sp>
         <p:nvSpPr>
-          <p:cNvPr id="255" name="" descr="{&quot;isTemplate&quot;:true,&quot;type&quot;:&quot;text&quot;}"/>
+          <p:cNvPr id="227" name="" descr="{&quot;isTemplate&quot;:true,&quot;type&quot;:&quot;text&quot;}"/>
           <p:cNvSpPr txBox="1"/>
           <p:nvPr/>
         </p:nvSpPr>
@@ -12799,7 +11551,7 @@
       </p:sp>
       <p:sp>
         <p:nvSpPr>
-          <p:cNvPr id="256" name="" descr="{&quot;isTemplate&quot;:true,&quot;type&quot;:&quot;text&quot;}"/>
+          <p:cNvPr id="228" name="" descr="{&quot;isTemplate&quot;:true,&quot;type&quot;:&quot;text&quot;}"/>
           <p:cNvSpPr txBox="1"/>
           <p:nvPr/>
         </p:nvSpPr>
@@ -12834,7 +11586,7 @@
       </p:sp>
       <p:sp>
         <p:nvSpPr>
-          <p:cNvPr id="257" name=""/>
+          <p:cNvPr id="229" name=""/>
           <p:cNvSpPr/>
           <p:nvPr/>
         </p:nvSpPr>
@@ -12865,7 +11617,7 @@
       </p:sp>
       <p:sp>
         <p:nvSpPr>
-          <p:cNvPr id="258" name=""/>
+          <p:cNvPr id="230" name=""/>
           <p:cNvSpPr/>
           <p:nvPr/>
         </p:nvSpPr>
@@ -12891,7 +11643,7 @@
       </p:sp>
       <p:sp>
         <p:nvSpPr>
-          <p:cNvPr id="259" name="" descr="{&quot;isTemplate&quot;:true,&quot;type&quot;:&quot;text&quot;}"/>
+          <p:cNvPr id="231" name="" descr="{&quot;isTemplate&quot;:true,&quot;type&quot;:&quot;text&quot;}"/>
           <p:cNvSpPr txBox="1"/>
           <p:nvPr/>
         </p:nvSpPr>
@@ -12926,7 +11678,7 @@
       </p:sp>
       <p:sp>
         <p:nvSpPr>
-          <p:cNvPr id="260" name="" descr="{&quot;isTemplate&quot;:true,&quot;type&quot;:&quot;text&quot;}"/>
+          <p:cNvPr id="232" name="" descr="{&quot;isTemplate&quot;:true,&quot;type&quot;:&quot;text&quot;}"/>
           <p:cNvSpPr txBox="1"/>
           <p:nvPr/>
         </p:nvSpPr>
@@ -12961,7 +11713,7 @@
       </p:sp>
       <p:sp>
         <p:nvSpPr>
-          <p:cNvPr id="261" name="" descr="{&quot;isTemplate&quot;:true,&quot;type&quot;:&quot;text&quot;}"/>
+          <p:cNvPr id="233" name="" descr="{&quot;isTemplate&quot;:true,&quot;type&quot;:&quot;text&quot;}"/>
           <p:cNvSpPr txBox="1"/>
           <p:nvPr/>
         </p:nvSpPr>
@@ -13078,7 +11830,7 @@
       </p:sp>
       <p:sp>
         <p:nvSpPr>
-          <p:cNvPr id="262" name="" descr="{&quot;isTemplate&quot;:true,&quot;type&quot;:&quot;text&quot;}"/>
+          <p:cNvPr id="234" name="" descr="{&quot;isTemplate&quot;:true,&quot;type&quot;:&quot;text&quot;}"/>
           <p:cNvSpPr txBox="1"/>
           <p:nvPr/>
         </p:nvSpPr>
@@ -13113,7 +11865,7 @@
       </p:sp>
       <p:sp>
         <p:nvSpPr>
-          <p:cNvPr id="263" name=""/>
+          <p:cNvPr id="235" name=""/>
           <p:cNvSpPr/>
           <p:nvPr/>
         </p:nvSpPr>
@@ -13144,7 +11896,7 @@
       </p:sp>
       <p:sp>
         <p:nvSpPr>
-          <p:cNvPr id="264" name=""/>
+          <p:cNvPr id="236" name=""/>
           <p:cNvSpPr/>
           <p:nvPr/>
         </p:nvSpPr>
@@ -13170,7 +11922,7 @@
       </p:sp>
       <p:sp>
         <p:nvSpPr>
-          <p:cNvPr id="265" name="" descr="{&quot;isTemplate&quot;:true,&quot;type&quot;:&quot;text&quot;}"/>
+          <p:cNvPr id="237" name="" descr="{&quot;isTemplate&quot;:true,&quot;type&quot;:&quot;text&quot;}"/>
           <p:cNvSpPr txBox="1"/>
           <p:nvPr/>
         </p:nvSpPr>
@@ -13205,7 +11957,7 @@
       </p:sp>
       <p:sp>
         <p:nvSpPr>
-          <p:cNvPr id="266" name="" descr="{&quot;isTemplate&quot;:true,&quot;type&quot;:&quot;text&quot;}"/>
+          <p:cNvPr id="238" name="" descr="{&quot;isTemplate&quot;:true,&quot;type&quot;:&quot;text&quot;}"/>
           <p:cNvSpPr txBox="1"/>
           <p:nvPr/>
         </p:nvSpPr>
@@ -13240,7 +11992,7 @@
       </p:sp>
       <p:sp>
         <p:nvSpPr>
-          <p:cNvPr id="267" name="" descr="{&quot;isTemplate&quot;:true,&quot;type&quot;:&quot;text&quot;}"/>
+          <p:cNvPr id="239" name="" descr="{&quot;isTemplate&quot;:true,&quot;type&quot;:&quot;text&quot;}"/>
           <p:cNvSpPr txBox="1"/>
           <p:nvPr/>
         </p:nvSpPr>
@@ -13357,7 +12109,7 @@
       </p:sp>
       <p:sp>
         <p:nvSpPr>
-          <p:cNvPr id="268" name="" descr="{&quot;isTemplate&quot;:true,&quot;type&quot;:&quot;text&quot;}"/>
+          <p:cNvPr id="240" name="" descr="{&quot;isTemplate&quot;:true,&quot;type&quot;:&quot;text&quot;}"/>
           <p:cNvSpPr txBox="1"/>
           <p:nvPr/>
         </p:nvSpPr>
@@ -13440,7 +12192,7 @@
   <p:cSld>
     <p:spTree>
       <p:nvGrpSpPr>
-        <p:cNvPr id="269" name="" descr="&lt;Slide style={{ width: '1280px', height: '720px', backgroundColor: '#FFFFFF', padding: '0px', flexDirection: 'column' }}&gt;&#10;    &lt;Box style={{ width: '1280px', height: '8px', backgroundColor: '#1E4FA8' }} /&gt;&#10;    &lt;Box style={{ padding: '30px 40px 0px 40px', flexDirection: 'row', justifyContent: 'space-between', alignItems: 'flex-end' }}&gt;&#10;        &lt;Text style={{ fontSize: 34, fontWeight: 'bold', color: '#1E4FA8' }}&gt;研究背景：两条路线，各自卡在一个前提上&lt;/Text&gt;&#10;        &lt;Text style={{ fontSize: 15, color: '#8B97A8' }}&gt;04 / 15&lt;/Text&gt;&#10;    &lt;/Box&gt;&#10;    &lt;Box style={{ padding: '16px 40px 0px 40px' }}&gt;&#10;        &lt;Text style={{ fontSize: 21, color: '#4A5568', lineHeight: 1.5 }}&gt;拿到&quot;一组照片 → 一个可漫游的 3D 场景&quot;，过去只有两条路可走。它们的分歧不在算法细节，而在&lt;b&gt;什么时候允许开始计算&lt;/b&gt;。&lt;/Text&gt;&#10;    &lt;/Box&gt;&#10;    &lt;Box style={{ padding: '16px 40px 0px 40px', flexDirection: 'row', gap: 24 }}&gt;&#10;        &lt;Box style={{ flex: 1, backgroundColor: '#F7F9FC', border: '1px solid #D6DCE5', borderRadius: 6, padding: '16px 20px', flexDirection: 'column' }}&gt;&#10;            &lt;Text style={{ fontSize: 26, fontWeight: 'bold', color: '#1A2230' }}&gt;路线一　离线 SfM + 3DGS&lt;/Text&gt;&#10;            &lt;Text style={{ fontSize: 19, color: '#4A5568', marginTop: 6 }}&gt;COLMAP / GLOMAP + 3DGS、H3DGS、Octree-GS&lt;/Text&gt;&#10;            &lt;Text style={{ fontSize: 21, color: '#1A2230', lineHeight: 1.55, marginTop: 12 }}&gt;先把所有照片两两匹配、三角化、全局 BA 解出位姿，再训练高斯。质量最高、全局一致，但&lt;b&gt;必须等图全部到齐&lt;/b&gt;，耗时从分钟到小时。&lt;/Text&gt;&#10;            &lt;Text style={{ fontSize: 21, color: '#1E4FA8', fontWeight: 'bold', marginTop: 12 }}&gt;前提：先有完整的照片集合&lt;/Text&gt;&#10;            &lt;Text style={{ fontSize: 21, color: '#D9534F', fontWeight: 'bold', marginTop: 4 }}&gt;代价：现场给不出任何反馈&lt;/Text&gt;&#10;        &lt;/Box&gt;&#10;        &lt;Box style={{ flex: 1, backgroundColor: '#F0F5FC', border: '1px solid #3D7BD9', borderRadius: 6, padding: '16px 20px', flexDirection: 'column' }}&gt;&#10;            &lt;Text style={{ fontSize: 26, fontWeight: 'bold', color: '#1A2230' }}&gt;路线二　增量 / 类 SLAM&lt;/Text&gt;&#10;            &lt;Text style={{ fontSize: 19, color: '#4A5568', marginTop: 6 }}&gt;Photo-SLAM、MonoGS、DROID-Splat、LongSplat&lt;/Text&gt;&#10;            &lt;Text style={{ fontSize: 21, color: '#1A2230', lineHeight: 1.55, marginTop: 12 }}&gt;边收边建、可交互。但新帧只与&lt;b&gt;时间上相邻&lt;/b&gt;的少数帧匹配（通常 5 帧窗口），一旦转身回访、或把两段序列拼起来，匹配就断了。&lt;/Text&gt;&#10;            &lt;Text style={{ fontSize: 21, color: '#1E4FA8', fontWeight: 'bold', marginTop: 12 }}&gt;前提：输入必须是连续视频&lt;/Text&gt;&#10;            &lt;Text style={{ fontSize: 21, color: '#D9534F', fontWeight: 'bold', marginTop: 4 }}&gt;代价：离开时间邻域就失效&lt;/Text&gt;&#10;        &lt;/Box&gt;&#10;    &lt;/Box&gt;&#10;    &lt;Box style={{ margin: '20px 40px 0px 40px', backgroundColor: '#1E4FA8', borderRadius: 6, padding: '16px 24px' }}&gt;&#10;        &lt;Text style={{ fontSize: 24, fontWeight: 'bold', color: '#FFFFFF', lineHeight: 1.5 }}&gt;两条路的前提是同一个东西：&lt;b&gt;帧序&lt;/b&gt;。一条等它全部确定，一条假设它天然有序——而真实拍摄两样都不满足。&lt;/Text&gt;&#10;    &lt;/Box&gt;&#10;    &lt;Box style={{ padding: '12px 40px 0px 40px' }}&gt;&#10;        &lt;Text style={{ fontSize: 17, color: '#8B97A8' }}&gt;真实采集几乎总是无序的：绕行、转身、回头补拍角落，覆盖更好，但让匹配与全局优化的代价陡增。&lt;/Text&gt;&#10;    &lt;/Box&gt;&#10;&lt;/Slide&gt;&#10;"/>
+        <p:cNvPr id="241" name="" descr="&lt;Slide style={{ width: '1280px', height: '720px', backgroundColor: '#FFFFFF', padding: '0px', flexDirection: 'column' }}&gt;&#10;    &lt;Box style={{ width: '1280px', height: '8px', backgroundColor: '#1E4FA8' }} /&gt;&#10;    &lt;Box style={{ padding: '30px 40px 0px 40px', flexDirection: 'row', justifyContent: 'space-between', alignItems: 'flex-end' }}&gt;&#10;        &lt;Text style={{ fontSize: 34, fontWeight: 'bold', color: '#1E4FA8' }}&gt;研究背景：两条路线，各自卡在一个前提上&lt;/Text&gt;&#10;        &lt;Text style={{ fontSize: 15, color: '#8B97A8' }}&gt;04 / 15&lt;/Text&gt;&#10;    &lt;/Box&gt;&#10;    &lt;Box style={{ padding: '16px 40px 0px 40px' }}&gt;&#10;        &lt;Text style={{ fontSize: 21, color: '#4A5568', lineHeight: 1.5 }}&gt;拿到&quot;一组照片 → 一个可漫游的 3D 场景&quot;，过去只有两条路可走。它们的分歧不在算法细节，而在&lt;b&gt;什么时候允许开始计算&lt;/b&gt;。&lt;/Text&gt;&#10;    &lt;/Box&gt;&#10;    &lt;Box style={{ padding: '16px 40px 0px 40px', flexDirection: 'row', gap: 24 }}&gt;&#10;        &lt;Box style={{ flex: 1, backgroundColor: '#F7F9FC', border: '1px solid #D6DCE5', borderRadius: 6, padding: '16px 20px', flexDirection: 'column' }}&gt;&#10;            &lt;Text style={{ fontSize: 26, fontWeight: 'bold', color: '#1A2230' }}&gt;路线一　离线 SfM + 3DGS&lt;/Text&gt;&#10;            &lt;Text style={{ fontSize: 19, color: '#4A5568', marginTop: 6 }}&gt;COLMAP / GLOMAP + 3DGS、H3DGS、Octree-GS&lt;/Text&gt;&#10;            &lt;Text style={{ fontSize: 21, color: '#1A2230', lineHeight: 1.55, marginTop: 12 }}&gt;先把所有照片两两匹配、三角化、全局 BA 解出位姿，再训练高斯。质量最高、全局一致，但&lt;b&gt;必须等图全部到齐&lt;/b&gt;，耗时从分钟到小时。&lt;/Text&gt;&#10;            &lt;Text style={{ fontSize: 21, color: '#1E4FA8', fontWeight: 'bold', marginTop: 12 }}&gt;前提：先有完整的照片集合&lt;/Text&gt;&#10;            &lt;Text style={{ fontSize: 21, color: '#D9534F', fontWeight: 'bold', marginTop: 4 }}&gt;代价：现场给不出任何反馈&lt;/Text&gt;&#10;        &lt;/Box&gt;&#10;        &lt;Box style={{ flex: 1, backgroundColor: '#F0F5FC', border: '1px solid #3D7BD9', borderRadius: 6, padding: '16px 20px', flexDirection: 'column' }}&gt;&#10;            &lt;Text style={{ fontSize: 26, fontWeight: 'bold', color: '#1A2230' }}&gt;路线二　增量 / 类 SLAM&lt;/Text&gt;&#10;            &lt;Text style={{ fontSize: 19, color: '#4A5568', marginTop: 6 }}&gt;Photo-SLAM、MonoGS、DROID-Splat、LongSplat&lt;/Text&gt;&#10;            &lt;Text style={{ fontSize: 21, color: '#1A2230', lineHeight: 1.55, marginTop: 12 }}&gt;边收边建、可交互。但新帧只与&lt;b&gt;时间上相邻&lt;/b&gt;的少数帧匹配（通常 5 帧窗口），一旦转身回访、或把两段序列拼起来，匹配就断了。&lt;/Text&gt;&#10;            &lt;Text style={{ fontSize: 21, color: '#1E4FA8', fontWeight: 'bold', marginTop: 12 }}&gt;前提：输入必须是连续视频&lt;/Text&gt;&#10;            &lt;Text style={{ fontSize: 21, color: '#D9534F', fontWeight: 'bold', marginTop: 4 }}&gt;代价：离开时间邻域就失效&lt;/Text&gt;&#10;        &lt;/Box&gt;&#10;    &lt;/Box&gt;&#10;    &lt;Box style={{ margin: '20px 40px 0px 40px', backgroundColor: '#1E4FA8', borderRadius: 6, padding: '16px 24px' }}&gt;&#10;        &lt;Text style={{ fontSize: 24, fontWeight: 'bold', color: '#FFFFFF', lineHeight: 1.5 }}&gt;两条路的前提是同一个东西：&lt;b&gt;帧序&lt;/b&gt;。一条等它全部确定，一条假设它天然有序——而真实拍摄两样都不满足。&lt;/Text&gt;&#10;    &lt;/Box&gt;&#10;    &lt;Box style={{ padding: '12px 40px 0px 40px' }}&gt;&#10;        &lt;Text style={{ fontSize: 17, color: '#8B97A8' }}&gt;真实采集几乎总是无序的：绕行、转身、回头补拍角落，覆盖更好，但让匹配与全局优化的代价陡增。&lt;/Text&gt;&#10;    &lt;/Box&gt;&#10;&lt;/Slide&gt;&#10;"/>
         <p:cNvGrpSpPr/>
         <p:nvPr/>
       </p:nvGrpSpPr>
@@ -13454,7 +12206,7 @@
       </p:grpSpPr>
       <p:sp>
         <p:nvSpPr>
-          <p:cNvPr id="270" name=""/>
+          <p:cNvPr id="242" name=""/>
           <p:cNvSpPr/>
           <p:nvPr/>
         </p:nvSpPr>
@@ -13478,7 +12230,7 @@
       </p:sp>
       <p:sp>
         <p:nvSpPr>
-          <p:cNvPr id="271" name=""/>
+          <p:cNvPr id="243" name=""/>
           <p:cNvSpPr/>
           <p:nvPr/>
         </p:nvSpPr>
@@ -13502,7 +12254,7 @@
       </p:sp>
       <p:sp>
         <p:nvSpPr>
-          <p:cNvPr id="272" name="" descr="{&quot;isTemplate&quot;:true,&quot;type&quot;:&quot;text&quot;}"/>
+          <p:cNvPr id="244" name="" descr="{&quot;isTemplate&quot;:true,&quot;type&quot;:&quot;text&quot;}"/>
           <p:cNvSpPr txBox="1"/>
           <p:nvPr/>
         </p:nvSpPr>
@@ -13537,7 +12289,7 @@
       </p:sp>
       <p:sp>
         <p:nvSpPr>
-          <p:cNvPr id="273" name="" descr="{&quot;isTemplate&quot;:true,&quot;type&quot;:&quot;text&quot;}"/>
+          <p:cNvPr id="245" name="" descr="{&quot;isTemplate&quot;:true,&quot;type&quot;:&quot;text&quot;}"/>
           <p:cNvSpPr txBox="1"/>
           <p:nvPr/>
         </p:nvSpPr>
@@ -13572,7 +12324,7 @@
       </p:sp>
       <p:sp>
         <p:nvSpPr>
-          <p:cNvPr id="274" name="" descr="{&quot;isTemplate&quot;:true,&quot;type&quot;:&quot;text&quot;}"/>
+          <p:cNvPr id="246" name="" descr="{&quot;isTemplate&quot;:true,&quot;type&quot;:&quot;text&quot;}"/>
           <p:cNvSpPr txBox="1"/>
           <p:nvPr/>
         </p:nvSpPr>
@@ -13707,7 +12459,7 @@
       </p:sp>
       <p:sp>
         <p:nvSpPr>
-          <p:cNvPr id="275" name=""/>
+          <p:cNvPr id="247" name=""/>
           <p:cNvSpPr/>
           <p:nvPr/>
         </p:nvSpPr>
@@ -13738,7 +12490,7 @@
       </p:sp>
       <p:sp>
         <p:nvSpPr>
-          <p:cNvPr id="276" name="" descr="{&quot;isTemplate&quot;:true,&quot;type&quot;:&quot;text&quot;}"/>
+          <p:cNvPr id="248" name="" descr="{&quot;isTemplate&quot;:true,&quot;type&quot;:&quot;text&quot;}"/>
           <p:cNvSpPr txBox="1"/>
           <p:nvPr/>
         </p:nvSpPr>
@@ -13783,7 +12535,7 @@
       </p:sp>
       <p:sp>
         <p:nvSpPr>
-          <p:cNvPr id="277" name="" descr="{&quot;isTemplate&quot;:true,&quot;type&quot;:&quot;text&quot;}"/>
+          <p:cNvPr id="249" name="" descr="{&quot;isTemplate&quot;:true,&quot;type&quot;:&quot;text&quot;}"/>
           <p:cNvSpPr txBox="1"/>
           <p:nvPr/>
         </p:nvSpPr>
@@ -13858,7 +12610,7 @@
       </p:sp>
       <p:sp>
         <p:nvSpPr>
-          <p:cNvPr id="278" name="" descr="{&quot;isTemplate&quot;:true,&quot;type&quot;:&quot;text&quot;}"/>
+          <p:cNvPr id="250" name="" descr="{&quot;isTemplate&quot;:true,&quot;type&quot;:&quot;text&quot;}"/>
           <p:cNvSpPr txBox="1"/>
           <p:nvPr/>
         </p:nvSpPr>
@@ -13935,7 +12687,7 @@
       </p:sp>
       <p:sp>
         <p:nvSpPr>
-          <p:cNvPr id="279" name="" descr="{&quot;isTemplate&quot;:true,&quot;type&quot;:&quot;text&quot;}"/>
+          <p:cNvPr id="251" name="" descr="{&quot;isTemplate&quot;:true,&quot;type&quot;:&quot;text&quot;}"/>
           <p:cNvSpPr txBox="1"/>
           <p:nvPr/>
         </p:nvSpPr>
@@ -13970,7 +12722,7 @@
       </p:sp>
       <p:sp>
         <p:nvSpPr>
-          <p:cNvPr id="280" name="" descr="{&quot;isTemplate&quot;:true,&quot;type&quot;:&quot;text&quot;}"/>
+          <p:cNvPr id="252" name="" descr="{&quot;isTemplate&quot;:true,&quot;type&quot;:&quot;text&quot;}"/>
           <p:cNvSpPr txBox="1"/>
           <p:nvPr/>
         </p:nvSpPr>
@@ -14005,7 +12757,7 @@
       </p:sp>
       <p:sp>
         <p:nvSpPr>
-          <p:cNvPr id="281" name=""/>
+          <p:cNvPr id="253" name=""/>
           <p:cNvSpPr/>
           <p:nvPr/>
         </p:nvSpPr>
@@ -14036,7 +12788,7 @@
       </p:sp>
       <p:sp>
         <p:nvSpPr>
-          <p:cNvPr id="282" name="" descr="{&quot;isTemplate&quot;:true,&quot;type&quot;:&quot;text&quot;}"/>
+          <p:cNvPr id="254" name="" descr="{&quot;isTemplate&quot;:true,&quot;type&quot;:&quot;text&quot;}"/>
           <p:cNvSpPr txBox="1"/>
           <p:nvPr/>
         </p:nvSpPr>
@@ -14101,7 +12853,7 @@
       </p:sp>
       <p:sp>
         <p:nvSpPr>
-          <p:cNvPr id="283" name="" descr="{&quot;isTemplate&quot;:true,&quot;type&quot;:&quot;text&quot;}"/>
+          <p:cNvPr id="255" name="" descr="{&quot;isTemplate&quot;:true,&quot;type&quot;:&quot;text&quot;}"/>
           <p:cNvSpPr txBox="1"/>
           <p:nvPr/>
         </p:nvSpPr>
@@ -14196,7 +12948,7 @@
       </p:sp>
       <p:sp>
         <p:nvSpPr>
-          <p:cNvPr id="284" name="" descr="{&quot;isTemplate&quot;:true,&quot;type&quot;:&quot;text&quot;}"/>
+          <p:cNvPr id="256" name="" descr="{&quot;isTemplate&quot;:true,&quot;type&quot;:&quot;text&quot;}"/>
           <p:cNvSpPr txBox="1"/>
           <p:nvPr/>
         </p:nvSpPr>
@@ -14273,7 +13025,7 @@
       </p:sp>
       <p:sp>
         <p:nvSpPr>
-          <p:cNvPr id="285" name="" descr="{&quot;isTemplate&quot;:true,&quot;type&quot;:&quot;text&quot;}"/>
+          <p:cNvPr id="257" name="" descr="{&quot;isTemplate&quot;:true,&quot;type&quot;:&quot;text&quot;}"/>
           <p:cNvSpPr txBox="1"/>
           <p:nvPr/>
         </p:nvSpPr>
@@ -14308,7 +13060,7 @@
       </p:sp>
       <p:sp>
         <p:nvSpPr>
-          <p:cNvPr id="286" name="" descr="{&quot;isTemplate&quot;:true,&quot;type&quot;:&quot;text&quot;}"/>
+          <p:cNvPr id="258" name="" descr="{&quot;isTemplate&quot;:true,&quot;type&quot;:&quot;text&quot;}"/>
           <p:cNvSpPr txBox="1"/>
           <p:nvPr/>
         </p:nvSpPr>
@@ -14343,7 +13095,7 @@
       </p:sp>
       <p:sp>
         <p:nvSpPr>
-          <p:cNvPr id="287" name=""/>
+          <p:cNvPr id="259" name=""/>
           <p:cNvSpPr/>
           <p:nvPr/>
         </p:nvSpPr>
@@ -14369,7 +13121,7 @@
       </p:sp>
       <p:sp>
         <p:nvSpPr>
-          <p:cNvPr id="288" name="" descr="{&quot;isTemplate&quot;:true,&quot;type&quot;:&quot;text&quot;}"/>
+          <p:cNvPr id="260" name="" descr="{&quot;isTemplate&quot;:true,&quot;type&quot;:&quot;text&quot;}"/>
           <p:cNvSpPr txBox="1"/>
           <p:nvPr/>
         </p:nvSpPr>
@@ -14426,7 +13178,7 @@
       </p:sp>
       <p:sp>
         <p:nvSpPr>
-          <p:cNvPr id="289" name="" descr="{&quot;isTemplate&quot;:true,&quot;type&quot;:&quot;text&quot;}"/>
+          <p:cNvPr id="261" name="" descr="{&quot;isTemplate&quot;:true,&quot;type&quot;:&quot;text&quot;}"/>
           <p:cNvSpPr txBox="1"/>
           <p:nvPr/>
         </p:nvSpPr>
@@ -14469,7 +13221,7 @@
   <p:cSld>
     <p:spTree>
       <p:nvGrpSpPr>
-        <p:cNvPr id="290" name="" descr="&lt;Slide style={{ width: '1280px', height: '720px', backgroundColor: '#FFFFFF', padding: '0px', flexDirection: 'column' }}&gt;&#10;    &lt;Box style={{ width: '1280px', height: '8px', backgroundColor: '#1E4FA8' }} /&gt;&#10;    &lt;Box style={{ padding: '30px 40px 0px 40px', flexDirection: 'row', justifyContent: 'space-between', alignItems: 'flex-end' }}&gt;&#10;        &lt;Text style={{ fontSize: 34, fontWeight: 'bold', color: '#1E4FA8' }}&gt;过去遇到的问题：等、乱、漂、爆&lt;/Text&gt;&#10;        &lt;Text style={{ fontSize: 15, color: '#8B97A8' }}&gt;05 / 15&lt;/Text&gt;&#10;    &lt;/Box&gt;&#10;    &lt;Box style={{ padding: '16px 40px 0px 40px' }}&gt;&#10;        &lt;Text style={{ fontSize: 21, color: '#4A5568', lineHeight: 1.5 }}&gt;如果拿手机去拍一个房间，这四件事几乎一定会遇到——它们不是算法&quot;不够准&quot;，而是&lt;b&gt;流程本身没有为现场反馈设计&lt;/b&gt;。&lt;/Text&gt;&#10;    &lt;/Box&gt;&#10;    &lt;Box style={{ padding: '16px 40px 0px 40px', flexDirection: 'row', gap: 20 }}&gt;&#10;        &lt;Box style={{ flex: 1, backgroundColor: '#F7F9FC', border: '1px solid #D6DCE5', borderRadius: 6, padding: '14px 18px', flexDirection: 'column' }}&gt;&#10;            &lt;Box style={{ flexDirection: 'row', alignItems: 'center', gap: 10 }}&gt;&#10;                &lt;Box style={{ width: '32px', height: '32px', backgroundColor: '#1E4FA8', borderRadius: 4, alignItems: 'center', justifyContent: 'center' }}&gt;&#10;                    &lt;Text style={{ fontSize: 19, fontWeight: 'bold', color: '#FFFFFF' }}&gt;1&lt;/Text&gt;&#10;                &lt;/Box&gt;&#10;                &lt;Text style={{ fontSize: 24, fontWeight: 'bold', color: '#1A2230' }}&gt;等：必须等图到齐&lt;/Text&gt;&#10;            &lt;/Box&gt;&#10;            &lt;Text style={{ fontSize: 20, color: '#1A2230', lineHeight: 1.5, marginTop: 10 }}&gt;离线流程要求全部图像就位才能开算。现场拍完不知道行不行，回家发现漏拍，只能整组重拍。&lt;/Text&gt;&#10;            &lt;Text style={{ fontSize: 19, color: '#D9534F', fontWeight: 'bold', marginTop: 10 }}&gt;返工成本最高&lt;/Text&gt;&#10;        &lt;/Box&gt;&#10;        &lt;Box style={{ flex: 1, backgroundColor: '#F7F9FC', border: '1px solid #D6DCE5', borderRadius: 6, padding: '14px 18px', flexDirection: 'column' }}&gt;&#10;            &lt;Box style={{ flexDirection: 'row', alignItems: 'center', gap: 10 }}&gt;&#10;                &lt;Box style={{ width: '32px', height: '32px', backgroundColor: '#1E4FA8', borderRadius: 4, alignItems: 'center', justifyContent: 'center' }}&gt;&#10;                    &lt;Text style={{ fontSize: 19, fontWeight: 'bold', color: '#FFFFFF' }}&gt;2&lt;/Text&gt;&#10;                &lt;/Box&gt;&#10;                &lt;Text style={{ fontSize: 24, fontWeight: 'bold', color: '#1A2230' }}&gt;乱：顺序不能用了&lt;/Text&gt;&#10;            &lt;/Box&gt;&#10;            &lt;Text style={{ fontSize: 20, color: '#1A2230', lineHeight: 1.5, marginTop: 10 }}&gt;随手拍的顺序与空间邻接无关，没法只比相邻帧，只能两两匹配：1000 张约 50 万对，耗时陡增。&lt;/Text&gt;&#10;            &lt;Text style={{ fontSize: 19, color: '#D9534F', fontWeight: 'bold', marginTop: 10 }}&gt;SfM 从分钟变小时&lt;/Text&gt;&#10;        &lt;/Box&gt;&#10;    &lt;/Box&gt;&#10;    &lt;Box style={{ padding: '14px 40px 0px 40px', flexDirection: 'row', gap: 20 }}&gt;&#10;        &lt;Box style={{ flex: 1, backgroundColor: '#F7F9FC', border: '1px solid #D6DCE5', borderRadius: 6, padding: '14px 18px', flexDirection: 'column' }}&gt;&#10;            &lt;Box style={{ flexDirection: 'row', alignItems: 'center', gap: 10 }}&gt;&#10;                &lt;Box style={{ width: '32px', height: '32px', backgroundColor: '#1E4FA8', borderRadius: 4, alignItems: 'center', justifyContent: 'center' }}&gt;&#10;                    &lt;Text style={{ fontSize: 19, fontWeight: 'bold', color: '#FFFFFF' }}&gt;3&lt;/Text&gt;&#10;                &lt;/Box&gt;&#10;                &lt;Text style={{ fontSize: 24, fontWeight: 'bold', color: '#1A2230' }}&gt;漂：回访时接不上&lt;/Text&gt;&#10;            &lt;/Box&gt;&#10;            &lt;Text style={{ fontSize: 20, color: '#1A2230', lineHeight: 1.5, marginTop: 10 }}&gt;边走边建误差累积，绕一圈回来发现首尾差半米。传统做法重跑一次全局 BA，几分钟起步。&lt;/Text&gt;&#10;            &lt;Text style={{ fontSize: 19, color: '#D9534F', fontWeight: 'bold', marginTop: 10 }}&gt;实时性当场归零&lt;/Text&gt;&#10;        &lt;/Box&gt;&#10;        &lt;Box style={{ flex: 1, backgroundColor: '#F7F9FC', border: '1px solid #D6DCE5', borderRadius: 6, padding: '14px 18px', flexDirection: 'column' }}&gt;&#10;            &lt;Box style={{ flexDirection: 'row', alignItems: 'center', gap: 10 }}&gt;&#10;                &lt;Box style={{ width: '32px', height: '32px', backgroundColor: '#1E4FA8', borderRadius: 4, alignItems: 'center', justifyContent: 'center' }}&gt;&#10;                    &lt;Text style={{ fontSize: 19, fontWeight: 'bold', color: '#FFFFFF' }}&gt;4&lt;/Text&gt;&#10;                &lt;/Box&gt;&#10;                &lt;Text style={{ fontSize: 24, fontWeight: 'bold', color: '#1A2230' }}&gt;爆：大场景显存&lt;/Text&gt;&#10;            &lt;/Box&gt;&#10;            &lt;Text style={{ fontSize: 20, color: '#1A2230', lineHeight: 1.5, marginTop: 10 }}&gt;高斯数随场景线性增长。论文实测：不开层级结构，CityWalk 到第 &lt;b&gt;795 / 4050&lt;/b&gt; 帧就 OOM。&lt;/Text&gt;&#10;            &lt;Text style={{ fontSize: 19, color: '#D9534F', fontWeight: 'bold', marginTop: 10 }}&gt;规模一上来就跑不完&lt;/Text&gt;&#10;        &lt;/Box&gt;&#10;    &lt;/Box&gt;&#10;    &lt;Box style={{ margin: '18px 40px 0px 40px', backgroundColor: '#1E4FA8', borderRadius: 6, padding: '14px 22px' }}&gt;&#10;        &lt;Text style={{ fontSize: 22, fontWeight: 'bold', color: '#FFFFFF', lineHeight: 1.5 }}&gt;四个现象收敛成三条必须同时成立的约束：即时（每帧数百毫秒）· 无序（不依赖帧序）· 全局一致（回环能修）。过去的方法最多同时满足两条。&lt;/Text&gt;&#10;    &lt;/Box&gt;&#10;&lt;/Slide&gt;&#10;"/>
+        <p:cNvPr id="262" name="" descr="&lt;Slide style={{ width: '1280px', height: '720px', backgroundColor: '#FFFFFF', padding: '0px', flexDirection: 'column' }}&gt;&#10;    &lt;Box style={{ width: '1280px', height: '8px', backgroundColor: '#1E4FA8' }} /&gt;&#10;    &lt;Box style={{ padding: '30px 40px 0px 40px', flexDirection: 'row', justifyContent: 'space-between', alignItems: 'flex-end' }}&gt;&#10;        &lt;Text style={{ fontSize: 34, fontWeight: 'bold', color: '#1E4FA8' }}&gt;过去遇到的问题：等、乱、漂、爆&lt;/Text&gt;&#10;        &lt;Text style={{ fontSize: 15, color: '#8B97A8' }}&gt;05 / 15&lt;/Text&gt;&#10;    &lt;/Box&gt;&#10;    &lt;Box style={{ padding: '16px 40px 0px 40px' }}&gt;&#10;        &lt;Text style={{ fontSize: 21, color: '#4A5568', lineHeight: 1.5 }}&gt;如果拿手机去拍一个房间，这四件事几乎一定会遇到——它们不是算法&quot;不够准&quot;，而是&lt;b&gt;流程本身没有为现场反馈设计&lt;/b&gt;。&lt;/Text&gt;&#10;    &lt;/Box&gt;&#10;    &lt;Box style={{ padding: '16px 40px 0px 40px', flexDirection: 'row', gap: 20 }}&gt;&#10;        &lt;Box style={{ flex: 1, backgroundColor: '#F7F9FC', border: '1px solid #D6DCE5', borderRadius: 6, padding: '14px 18px', flexDirection: 'column' }}&gt;&#10;            &lt;Box style={{ flexDirection: 'row', alignItems: 'center', gap: 10 }}&gt;&#10;                &lt;Box style={{ width: '32px', height: '32px', backgroundColor: '#1E4FA8', borderRadius: 4, alignItems: 'center', justifyContent: 'center' }}&gt;&#10;                    &lt;Text style={{ fontSize: 19, fontWeight: 'bold', color: '#FFFFFF' }}&gt;1&lt;/Text&gt;&#10;                &lt;/Box&gt;&#10;                &lt;Text style={{ fontSize: 24, fontWeight: 'bold', color: '#1A2230' }}&gt;等：必须等图到齐&lt;/Text&gt;&#10;            &lt;/Box&gt;&#10;            &lt;Text style={{ fontSize: 20, color: '#1A2230', lineHeight: 1.5, marginTop: 10 }}&gt;离线流程要求全部图像就位才能开算。现场拍完不知道行不行，回家发现漏拍，只能整组重拍。&lt;/Text&gt;&#10;            &lt;Text style={{ fontSize: 19, color: '#D9534F', fontWeight: 'bold', marginTop: 10 }}&gt;返工成本最高&lt;/Text&gt;&#10;        &lt;/Box&gt;&#10;        &lt;Box style={{ flex: 1, backgroundColor: '#F7F9FC', border: '1px solid #D6DCE5', borderRadius: 6, padding: '14px 18px', flexDirection: 'column' }}&gt;&#10;            &lt;Box style={{ flexDirection: 'row', alignItems: 'center', gap: 10 }}&gt;&#10;                &lt;Box style={{ width: '32px', height: '32px', backgroundColor: '#1E4FA8', borderRadius: 4, alignItems: 'center', justifyContent: 'center' }}&gt;&#10;                    &lt;Text style={{ fontSize: 19, fontWeight: 'bold', color: '#FFFFFF' }}&gt;2&lt;/Text&gt;&#10;                &lt;/Box&gt;&#10;                &lt;Text style={{ fontSize: 24, fontWeight: 'bold', color: '#1A2230' }}&gt;乱：顺序不能用了&lt;/Text&gt;&#10;            &lt;/Box&gt;&#10;            &lt;Text style={{ fontSize: 20, color: '#1A2230', lineHeight: 1.5, marginTop: 10 }}&gt;随手拍的顺序与空间邻接无关，没法只比相邻帧，只能两两匹配：1000 张约 50 万对，耗时陡增。&lt;/Text&gt;&#10;            &lt;Text style={{ fontSize: 19, color: '#D9534F', fontWeight: 'bold', marginTop: 10 }}&gt;SfM 从分钟变小时&lt;/Text&gt;&#10;        &lt;/Box&gt;&#10;    &lt;/Box&gt;&#10;    &lt;Box style={{ padding: '14px 40px 0px 40px', flexDirection: 'row', gap: 20 }}&gt;&#10;        &lt;Box style={{ flex: 1, backgroundColor: '#F7F9FC', border: '1px solid #D6DCE5', borderRadius: 6, padding: '14px 18px', flexDirection: 'column' }}&gt;&#10;            &lt;Box style={{ flexDirection: 'row', alignItems: 'center', gap: 10 }}&gt;&#10;                &lt;Box style={{ width: '32px', height: '32px', backgroundColor: '#1E4FA8', borderRadius: 4, alignItems: 'center', justifyContent: 'center' }}&gt;&#10;                    &lt;Text style={{ fontSize: 19, fontWeight: 'bold', color: '#FFFFFF' }}&gt;3&lt;/Text&gt;&#10;                &lt;/Box&gt;&#10;                &lt;Text style={{ fontSize: 24, fontWeight: 'bold', color: '#1A2230' }}&gt;漂：回访时接不上&lt;/Text&gt;&#10;            &lt;/Box&gt;&#10;            &lt;Text style={{ fontSize: 20, color: '#1A2230', lineHeight: 1.5, marginTop: 10 }}&gt;边走边建误差累积，绕一圈回来发现首尾差半米。传统做法重跑一次全局 BA，几分钟起步。&lt;/Text&gt;&#10;            &lt;Text style={{ fontSize: 19, color: '#D9534F', fontWeight: 'bold', marginTop: 10 }}&gt;实时性当场归零&lt;/Text&gt;&#10;        &lt;/Box&gt;&#10;        &lt;Box style={{ flex: 1, backgroundColor: '#F7F9FC', border: '1px solid #D6DCE5', borderRadius: 6, padding: '14px 18px', flexDirection: 'column' }}&gt;&#10;            &lt;Box style={{ flexDirection: 'row', alignItems: 'center', gap: 10 }}&gt;&#10;                &lt;Box style={{ width: '32px', height: '32px', backgroundColor: '#1E4FA8', borderRadius: 4, alignItems: 'center', justifyContent: 'center' }}&gt;&#10;                    &lt;Text style={{ fontSize: 19, fontWeight: 'bold', color: '#FFFFFF' }}&gt;4&lt;/Text&gt;&#10;                &lt;/Box&gt;&#10;                &lt;Text style={{ fontSize: 24, fontWeight: 'bold', color: '#1A2230' }}&gt;爆：大场景显存&lt;/Text&gt;&#10;            &lt;/Box&gt;&#10;            &lt;Text style={{ fontSize: 20, color: '#1A2230', lineHeight: 1.5, marginTop: 10 }}&gt;高斯数随场景线性增长。论文实测：不开层级结构，CityWalk 到第 &lt;b&gt;795 / 4050&lt;/b&gt; 帧就 OOM。&lt;/Text&gt;&#10;            &lt;Text style={{ fontSize: 19, color: '#D9534F', fontWeight: 'bold', marginTop: 10 }}&gt;规模一上来就跑不完&lt;/Text&gt;&#10;        &lt;/Box&gt;&#10;    &lt;/Box&gt;&#10;    &lt;Box style={{ margin: '18px 40px 0px 40px', backgroundColor: '#1E4FA8', borderRadius: 6, padding: '14px 22px' }}&gt;&#10;        &lt;Text style={{ fontSize: 22, fontWeight: 'bold', color: '#FFFFFF', lineHeight: 1.5 }}&gt;四个现象收敛成三条必须同时成立的约束：即时（每帧数百毫秒）· 无序（不依赖帧序）· 全局一致（回环能修）。过去的方法最多同时满足两条。&lt;/Text&gt;&#10;    &lt;/Box&gt;&#10;&lt;/Slide&gt;&#10;"/>
         <p:cNvGrpSpPr/>
         <p:nvPr/>
       </p:nvGrpSpPr>
@@ -14483,7 +13235,7 @@
       </p:grpSpPr>
       <p:sp>
         <p:nvSpPr>
-          <p:cNvPr id="291" name=""/>
+          <p:cNvPr id="263" name=""/>
           <p:cNvSpPr/>
           <p:nvPr/>
         </p:nvSpPr>
@@ -14507,7 +13259,7 @@
       </p:sp>
       <p:sp>
         <p:nvSpPr>
-          <p:cNvPr id="292" name=""/>
+          <p:cNvPr id="264" name=""/>
           <p:cNvSpPr/>
           <p:nvPr/>
         </p:nvSpPr>
@@ -14531,7 +13283,7 @@
       </p:sp>
       <p:sp>
         <p:nvSpPr>
-          <p:cNvPr id="293" name="" descr="{&quot;isTemplate&quot;:true,&quot;type&quot;:&quot;text&quot;}"/>
+          <p:cNvPr id="265" name="" descr="{&quot;isTemplate&quot;:true,&quot;type&quot;:&quot;text&quot;}"/>
           <p:cNvSpPr txBox="1"/>
           <p:nvPr/>
         </p:nvSpPr>
@@ -14566,7 +13318,7 @@
       </p:sp>
       <p:sp>
         <p:nvSpPr>
-          <p:cNvPr id="294" name="" descr="{&quot;isTemplate&quot;:true,&quot;type&quot;:&quot;text&quot;}"/>
+          <p:cNvPr id="266" name="" descr="{&quot;isTemplate&quot;:true,&quot;type&quot;:&quot;text&quot;}"/>
           <p:cNvSpPr txBox="1"/>
           <p:nvPr/>
         </p:nvSpPr>
@@ -14601,7 +13353,7 @@
       </p:sp>
       <p:sp>
         <p:nvSpPr>
-          <p:cNvPr id="295" name="" descr="{&quot;isTemplate&quot;:true,&quot;type&quot;:&quot;text&quot;}"/>
+          <p:cNvPr id="267" name="" descr="{&quot;isTemplate&quot;:true,&quot;type&quot;:&quot;text&quot;}"/>
           <p:cNvSpPr txBox="1"/>
           <p:nvPr/>
         </p:nvSpPr>
@@ -14696,7 +13448,7 @@
       </p:sp>
       <p:sp>
         <p:nvSpPr>
-          <p:cNvPr id="296" name=""/>
+          <p:cNvPr id="268" name=""/>
           <p:cNvSpPr/>
           <p:nvPr/>
         </p:nvSpPr>
@@ -14727,7 +13479,7 @@
       </p:sp>
       <p:sp>
         <p:nvSpPr>
-          <p:cNvPr id="297" name=""/>
+          <p:cNvPr id="269" name=""/>
           <p:cNvSpPr/>
           <p:nvPr/>
         </p:nvSpPr>
@@ -14753,7 +13505,7 @@
       </p:sp>
       <p:sp>
         <p:nvSpPr>
-          <p:cNvPr id="298" name="" descr="{&quot;isTemplate&quot;:true,&quot;type&quot;:&quot;text&quot;}"/>
+          <p:cNvPr id="270" name="" descr="{&quot;isTemplate&quot;:true,&quot;type&quot;:&quot;text&quot;}"/>
           <p:cNvSpPr txBox="1"/>
           <p:nvPr/>
         </p:nvSpPr>
@@ -14788,7 +13540,7 @@
       </p:sp>
       <p:sp>
         <p:nvSpPr>
-          <p:cNvPr id="299" name="" descr="{&quot;isTemplate&quot;:true,&quot;type&quot;:&quot;text&quot;}"/>
+          <p:cNvPr id="271" name="" descr="{&quot;isTemplate&quot;:true,&quot;type&quot;:&quot;text&quot;}"/>
           <p:cNvSpPr txBox="1"/>
           <p:nvPr/>
         </p:nvSpPr>
@@ -14823,7 +13575,7 @@
       </p:sp>
       <p:sp>
         <p:nvSpPr>
-          <p:cNvPr id="300" name="" descr="{&quot;isTemplate&quot;:true,&quot;type&quot;:&quot;text&quot;}"/>
+          <p:cNvPr id="272" name="" descr="{&quot;isTemplate&quot;:true,&quot;type&quot;:&quot;text&quot;}"/>
           <p:cNvSpPr txBox="1"/>
           <p:nvPr/>
         </p:nvSpPr>
@@ -14860,7 +13612,7 @@
       </p:sp>
       <p:sp>
         <p:nvSpPr>
-          <p:cNvPr id="301" name="" descr="{&quot;isTemplate&quot;:true,&quot;type&quot;:&quot;text&quot;}"/>
+          <p:cNvPr id="273" name="" descr="{&quot;isTemplate&quot;:true,&quot;type&quot;:&quot;text&quot;}"/>
           <p:cNvSpPr txBox="1"/>
           <p:nvPr/>
         </p:nvSpPr>
@@ -14895,7 +13647,7 @@
       </p:sp>
       <p:sp>
         <p:nvSpPr>
-          <p:cNvPr id="302" name=""/>
+          <p:cNvPr id="274" name=""/>
           <p:cNvSpPr/>
           <p:nvPr/>
         </p:nvSpPr>
@@ -14926,7 +13678,7 @@
       </p:sp>
       <p:sp>
         <p:nvSpPr>
-          <p:cNvPr id="303" name=""/>
+          <p:cNvPr id="275" name=""/>
           <p:cNvSpPr/>
           <p:nvPr/>
         </p:nvSpPr>
@@ -14952,7 +13704,7 @@
       </p:sp>
       <p:sp>
         <p:nvSpPr>
-          <p:cNvPr id="304" name="" descr="{&quot;isTemplate&quot;:true,&quot;type&quot;:&quot;text&quot;}"/>
+          <p:cNvPr id="276" name="" descr="{&quot;isTemplate&quot;:true,&quot;type&quot;:&quot;text&quot;}"/>
           <p:cNvSpPr txBox="1"/>
           <p:nvPr/>
         </p:nvSpPr>
@@ -14987,7 +13739,7 @@
       </p:sp>
       <p:sp>
         <p:nvSpPr>
-          <p:cNvPr id="305" name="" descr="{&quot;isTemplate&quot;:true,&quot;type&quot;:&quot;text&quot;}"/>
+          <p:cNvPr id="277" name="" descr="{&quot;isTemplate&quot;:true,&quot;type&quot;:&quot;text&quot;}"/>
           <p:cNvSpPr txBox="1"/>
           <p:nvPr/>
         </p:nvSpPr>
@@ -15022,7 +13774,7 @@
       </p:sp>
       <p:sp>
         <p:nvSpPr>
-          <p:cNvPr id="306" name="" descr="{&quot;isTemplate&quot;:true,&quot;type&quot;:&quot;text&quot;}"/>
+          <p:cNvPr id="278" name="" descr="{&quot;isTemplate&quot;:true,&quot;type&quot;:&quot;text&quot;}"/>
           <p:cNvSpPr txBox="1"/>
           <p:nvPr/>
         </p:nvSpPr>
@@ -15099,7 +13851,7 @@
       </p:sp>
       <p:sp>
         <p:nvSpPr>
-          <p:cNvPr id="307" name="" descr="{&quot;isTemplate&quot;:true,&quot;type&quot;:&quot;text&quot;}"/>
+          <p:cNvPr id="279" name="" descr="{&quot;isTemplate&quot;:true,&quot;type&quot;:&quot;text&quot;}"/>
           <p:cNvSpPr txBox="1"/>
           <p:nvPr/>
         </p:nvSpPr>
@@ -15144,7 +13896,7 @@
       </p:sp>
       <p:sp>
         <p:nvSpPr>
-          <p:cNvPr id="308" name=""/>
+          <p:cNvPr id="280" name=""/>
           <p:cNvSpPr/>
           <p:nvPr/>
         </p:nvSpPr>
@@ -15175,7 +13927,7 @@
       </p:sp>
       <p:sp>
         <p:nvSpPr>
-          <p:cNvPr id="309" name=""/>
+          <p:cNvPr id="281" name=""/>
           <p:cNvSpPr/>
           <p:nvPr/>
         </p:nvSpPr>
@@ -15201,7 +13953,7 @@
       </p:sp>
       <p:sp>
         <p:nvSpPr>
-          <p:cNvPr id="310" name="" descr="{&quot;isTemplate&quot;:true,&quot;type&quot;:&quot;text&quot;}"/>
+          <p:cNvPr id="282" name="" descr="{&quot;isTemplate&quot;:true,&quot;type&quot;:&quot;text&quot;}"/>
           <p:cNvSpPr txBox="1"/>
           <p:nvPr/>
         </p:nvSpPr>
@@ -15236,7 +13988,7 @@
       </p:sp>
       <p:sp>
         <p:nvSpPr>
-          <p:cNvPr id="311" name="" descr="{&quot;isTemplate&quot;:true,&quot;type&quot;:&quot;text&quot;}"/>
+          <p:cNvPr id="283" name="" descr="{&quot;isTemplate&quot;:true,&quot;type&quot;:&quot;text&quot;}"/>
           <p:cNvSpPr txBox="1"/>
           <p:nvPr/>
         </p:nvSpPr>
@@ -15271,7 +14023,7 @@
       </p:sp>
       <p:sp>
         <p:nvSpPr>
-          <p:cNvPr id="312" name="" descr="{&quot;isTemplate&quot;:true,&quot;type&quot;:&quot;text&quot;}"/>
+          <p:cNvPr id="284" name="" descr="{&quot;isTemplate&quot;:true,&quot;type&quot;:&quot;text&quot;}"/>
           <p:cNvSpPr txBox="1"/>
           <p:nvPr/>
         </p:nvSpPr>
@@ -15328,7 +14080,7 @@
       </p:sp>
       <p:sp>
         <p:nvSpPr>
-          <p:cNvPr id="313" name="" descr="{&quot;isTemplate&quot;:true,&quot;type&quot;:&quot;text&quot;}"/>
+          <p:cNvPr id="285" name="" descr="{&quot;isTemplate&quot;:true,&quot;type&quot;:&quot;text&quot;}"/>
           <p:cNvSpPr txBox="1"/>
           <p:nvPr/>
         </p:nvSpPr>
@@ -15363,7 +14115,7 @@
       </p:sp>
       <p:sp>
         <p:nvSpPr>
-          <p:cNvPr id="314" name=""/>
+          <p:cNvPr id="286" name=""/>
           <p:cNvSpPr/>
           <p:nvPr/>
         </p:nvSpPr>
@@ -15394,7 +14146,7 @@
       </p:sp>
       <p:sp>
         <p:nvSpPr>
-          <p:cNvPr id="315" name=""/>
+          <p:cNvPr id="287" name=""/>
           <p:cNvSpPr/>
           <p:nvPr/>
         </p:nvSpPr>
@@ -15420,7 +14172,7 @@
       </p:sp>
       <p:sp>
         <p:nvSpPr>
-          <p:cNvPr id="316" name="" descr="{&quot;isTemplate&quot;:true,&quot;type&quot;:&quot;text&quot;}"/>
+          <p:cNvPr id="288" name="" descr="{&quot;isTemplate&quot;:true,&quot;type&quot;:&quot;text&quot;}"/>
           <p:cNvSpPr txBox="1"/>
           <p:nvPr/>
         </p:nvSpPr>
@@ -15455,7 +14207,7 @@
       </p:sp>
       <p:sp>
         <p:nvSpPr>
-          <p:cNvPr id="317" name="" descr="{&quot;isTemplate&quot;:true,&quot;type&quot;:&quot;text&quot;}"/>
+          <p:cNvPr id="289" name="" descr="{&quot;isTemplate&quot;:true,&quot;type&quot;:&quot;text&quot;}"/>
           <p:cNvSpPr txBox="1"/>
           <p:nvPr/>
         </p:nvSpPr>
@@ -15490,7 +14242,7 @@
       </p:sp>
       <p:sp>
         <p:nvSpPr>
-          <p:cNvPr id="318" name="" descr="{&quot;isTemplate&quot;:true,&quot;type&quot;:&quot;text&quot;}"/>
+          <p:cNvPr id="290" name="" descr="{&quot;isTemplate&quot;:true,&quot;type&quot;:&quot;text&quot;}"/>
           <p:cNvSpPr txBox="1"/>
           <p:nvPr/>
         </p:nvSpPr>
@@ -15607,7 +14359,7 @@
       </p:sp>
       <p:sp>
         <p:nvSpPr>
-          <p:cNvPr id="319" name="" descr="{&quot;isTemplate&quot;:true,&quot;type&quot;:&quot;text&quot;}"/>
+          <p:cNvPr id="291" name="" descr="{&quot;isTemplate&quot;:true,&quot;type&quot;:&quot;text&quot;}"/>
           <p:cNvSpPr txBox="1"/>
           <p:nvPr/>
         </p:nvSpPr>
@@ -15642,7 +14394,7 @@
       </p:sp>
       <p:sp>
         <p:nvSpPr>
-          <p:cNvPr id="320" name=""/>
+          <p:cNvPr id="292" name=""/>
           <p:cNvSpPr/>
           <p:nvPr/>
         </p:nvSpPr>
@@ -15668,7 +14420,7 @@
       </p:sp>
       <p:sp>
         <p:nvSpPr>
-          <p:cNvPr id="321" name="" descr="{&quot;isTemplate&quot;:true,&quot;type&quot;:&quot;text&quot;}"/>
+          <p:cNvPr id="293" name="" descr="{&quot;isTemplate&quot;:true,&quot;type&quot;:&quot;text&quot;}"/>
           <p:cNvSpPr txBox="1"/>
           <p:nvPr/>
         </p:nvSpPr>
@@ -15753,7 +14505,7 @@
   <p:cSld>
     <p:spTree>
       <p:nvGrpSpPr>
-        <p:cNvPr id="322" name="" descr="&lt;Slide style={{ width: '1280px', height: '720px', backgroundColor: '#FFFFFF', padding: '0px', flexDirection: 'column' }}&gt;&#10;    &lt;Box style={{ width: '1280px', height: '8px', backgroundColor: '#1E4FA8' }} /&gt;&#10;    &lt;Box style={{ padding: '30px 40px 0px 40px', flexDirection: 'row', justifyContent: 'space-between', alignItems: 'flex-end' }}&gt;&#10;        &lt;Text style={{ fontSize: 34, fontWeight: 'bold', color: '#1E4FA8' }}&gt;方法总览：每来一个关键帧做六件事&lt;/Text&gt;&#10;        &lt;Text style={{ fontSize: 15, color: '#8B97A8' }}&gt;06 / 15&lt;/Text&gt;&#10;    &lt;/Box&gt;&#10;    &lt;Box style={{ padding: '14px 40px 0px 40px' }}&gt;&#10;        &lt;Text style={{ fontSize: 22, color: '#4A5568', lineHeight: 1.5 }}&gt;设计哲学一句话：&lt;b&gt;每帧做小事，偶尔做一次大事&lt;/b&gt;。前者保证实时，后者保证不漂。每一步都对应上一页四个问题中的一个。&lt;/Text&gt;&#10;    &lt;/Box&gt;&#10;    &lt;Box style={{ padding: '18px 40px 0px 40px', flexDirection: 'row', gap: 14 }}&gt;&#10;        &lt;Box style={{ flex: 1, minHeight: '158px', backgroundColor: '#F0F5FC', borderRadius: 6, padding: '16px 14px', flexDirection: 'column' }}&gt;&#10;            &lt;Text style={{ fontSize: 18, fontWeight: 'bold', color: '#1E4FA8' }}&gt;STEP 1&lt;/Text&gt;&#10;            &lt;Text style={{ fontSize: 23, fontWeight: 'bold', color: '#1A2230', marginTop: 7 }}&gt;两级匹配&lt;/Text&gt;&#10;            &lt;Text style={{ fontSize: 19, color: '#1A2230', lineHeight: 1.5, marginTop: 7 }}&gt;检索候选 → 局部特征 → 精验，得到可信帧对&lt;/Text&gt;&#10;            &lt;Text style={{ fontSize: 18, color: '#1D5FC0', fontWeight: 'bold', marginTop: 'auto' }}&gt;治&quot;乱&quot;&lt;/Text&gt;&#10;        &lt;/Box&gt;&#10;        &lt;Box style={{ flex: 1, minHeight: '158px', backgroundColor: '#F0F5FC', borderRadius: 6, padding: '16px 14px', flexDirection: 'column' }}&gt;&#10;            &lt;Text style={{ fontSize: 18, fontWeight: 'bold', color: '#1E4FA8' }}&gt;STEP 2&lt;/Text&gt;&#10;            &lt;Text style={{ fontSize: 23, fontWeight: 'bold', color: '#1A2230', marginTop: 7 }}&gt;更新协视图&lt;/Text&gt;&#10;            &lt;Text style={{ fontSize: 19, color: '#1A2230', lineHeight: 1.5, marginTop: 7 }}&gt;边权 = 内点数倒数，越可靠越&quot;近&quot;&lt;/Text&gt;&#10;            &lt;Text style={{ fontSize: 18, color: '#1D5FC0', fontWeight: 'bold', marginTop: 'auto' }}&gt;为后续提供&quot;距离&quot;&lt;/Text&gt;&#10;        &lt;/Box&gt;&#10;        &lt;Box style={{ flex: 1, minHeight: '158px', backgroundColor: '#F0F5FC', borderRadius: 6, padding: '16px 14px', flexDirection: 'column' }}&gt;&#10;            &lt;Text style={{ fontSize: 18, fontWeight: 'bold', color: '#1E4FA8' }}&gt;STEP 3&lt;/Text&gt;&#10;            &lt;Text style={{ fontSize: 23, fontWeight: 'bold', color: '#1A2230', marginTop: 7 }}&gt;回环检测&lt;/Text&gt;&#10;            &lt;Text style={{ fontSize: 19, color: '#1A2230', lineHeight: 1.5, marginTop: 7 }}&gt;簇间跳数 &amp;gt; 5 且有效对 &amp;gt; 2 才触发&lt;/Text&gt;&#10;            &lt;Text style={{ fontSize: 18, color: '#1D5FC0', fontWeight: 'bold', marginTop: 'auto' }}&gt;治&quot;漂&quot;·发现&lt;/Text&gt;&#10;        &lt;/Box&gt;&#10;    &lt;/Box&gt;&#10;    &lt;Box style={{ padding: '16px 40px 0px 40px', flexDirection: 'row', gap: 14 }}&gt;&#10;        &lt;Box style={{ flex: 1, minHeight: '158px', backgroundColor: '#F7F9FC', borderRadius: 6, padding: '16px 14px', flexDirection: 'column' }}&gt;&#10;            &lt;Text style={{ fontSize: 18, fontWeight: 'bold', color: '#1E4FA8' }}&gt;STEP 4&lt;/Text&gt;&#10;            &lt;Text style={{ fontSize: 23, fontWeight: 'bold', color: '#1A2230', marginTop: 7 }}&gt;局部 BA&lt;/Text&gt;&#10;            &lt;Text style={{ fontSize: 19, color: '#1A2230', lineHeight: 1.5, marginTop: 7 }}&gt;选 20 个高连通帧，GPU 上优化位姿&lt;/Text&gt;&#10;            &lt;Text style={{ fontSize: 18, color: '#1D5FC0', fontWeight: 'bold', marginTop: 'auto' }}&gt;治&quot;慢&quot;&lt;/Text&gt;&#10;        &lt;/Box&gt;&#10;        &lt;Box style={{ flex: 1, minHeight: '158px', backgroundColor: '#F7F9FC', borderRadius: 6, padding: '16px 14px', flexDirection: 'column' }}&gt;&#10;            &lt;Text style={{ fontSize: 18, fontWeight: 'bold', color: '#1E4FA8' }}&gt;STEP 5&lt;/Text&gt;&#10;            &lt;Text style={{ fontSize: 23, fontWeight: 'bold', color: '#1A2230', marginTop: 7 }}&gt;回环修正&lt;/Text&gt;&#10;            &lt;Text style={{ fontSize: 19, color: '#1A2230', lineHeight: 1.5, marginTop: 7 }}&gt;焊接 BA + 主干传播，位姿与高斯一起动&lt;/Text&gt;&#10;            &lt;Text style={{ fontSize: 18, color: '#1D5FC0', fontWeight: 'bold', marginTop: 'auto' }}&gt;治&quot;漂&quot;·修正&lt;/Text&gt;&#10;        &lt;/Box&gt;&#10;        &lt;Box style={{ flex: 1, minHeight: '158px', backgroundColor: '#F7F9FC', borderRadius: 6, padding: '16px 14px', flexDirection: 'column' }}&gt;&#10;            &lt;Text style={{ fontSize: 18, fontWeight: 'bold', color: '#1E4FA8' }}&gt;STEP 6&lt;/Text&gt;&#10;            &lt;Text style={{ fontSize: 23, fontWeight: 'bold', color: '#1A2230', marginTop: 7 }}&gt;投放与优化&lt;/Text&gt;&#10;            &lt;Text style={{ fontSize: 19, color: '#1A2230', lineHeight: 1.5, marginTop: 7 }}&gt;分块深度对齐投放，每帧固定 30 次迭代&lt;/Text&gt;&#10;            &lt;Text style={{ fontSize: 18, color: '#1D5FC0', fontWeight: 'bold', marginTop: 'auto' }}&gt;治&quot;爆&quot;（配层级）&lt;/Text&gt;&#10;        &lt;/Box&gt;&#10;    &lt;/Box&gt;&#10;    &lt;Box style={{ margin: '18px 40px 0px 40px', backgroundColor: '#F0F5FC', borderLeft: '5px solid #1E4FA8', padding: '15px 20px' }}&gt;&#10;        &lt;Text style={{ fontSize: 21, color: '#1A2230', lineHeight: 1.5 }}&gt;另有一处容错：匹配失败的帧先&quot;搁置&quot;，后续出现相似帧时再取出重试——乱序输入因此不必强求一次匹配成功。&lt;/Text&gt;&#10;    &lt;/Box&gt;&#10;    &lt;Box style={{ padding: '14px 40px 0px 40px' }}&gt;&#10;        &lt;Text style={{ fontSize: 17, color: '#8B97A8' }}&gt;六步中只有 STEP 3 与 STEP 5 是&quot;偶尔做一次的大事&quot;，其余每帧都跑；这也是实时性的来源。&lt;/Text&gt;&#10;    &lt;/Box&gt;&#10;&lt;/Slide&gt;&#10;"/>
+        <p:cNvPr id="294" name="" descr="&lt;Slide style={{ width: '1280px', height: '720px', backgroundColor: '#FFFFFF', padding: '0px', flexDirection: 'column' }}&gt;&#10;    &lt;Box style={{ width: '1280px', height: '8px', backgroundColor: '#1E4FA8' }} /&gt;&#10;    &lt;Box style={{ padding: '30px 40px 0px 40px', flexDirection: 'row', justifyContent: 'space-between', alignItems: 'flex-end' }}&gt;&#10;        &lt;Text style={{ fontSize: 34, fontWeight: 'bold', color: '#1E4FA8' }}&gt;方法总览：每来一个关键帧做六件事&lt;/Text&gt;&#10;        &lt;Text style={{ fontSize: 15, color: '#8B97A8' }}&gt;06 / 15&lt;/Text&gt;&#10;    &lt;/Box&gt;&#10;    &lt;Box style={{ padding: '14px 40px 0px 40px' }}&gt;&#10;        &lt;Text style={{ fontSize: 22, color: '#4A5568', lineHeight: 1.5 }}&gt;设计哲学一句话：&lt;b&gt;每帧做小事，偶尔做一次大事&lt;/b&gt;。前者保证实时，后者保证不漂。每一步都对应上一页四个问题中的一个。&lt;/Text&gt;&#10;    &lt;/Box&gt;&#10;    &lt;Box style={{ padding: '18px 40px 0px 40px', flexDirection: 'row', gap: 14 }}&gt;&#10;        &lt;Box style={{ flex: 1, minHeight: '158px', backgroundColor: '#F0F5FC', borderRadius: 6, padding: '16px 14px', flexDirection: 'column' }}&gt;&#10;            &lt;Text style={{ fontSize: 18, fontWeight: 'bold', color: '#1E4FA8' }}&gt;STEP 1&lt;/Text&gt;&#10;            &lt;Text style={{ fontSize: 23, fontWeight: 'bold', color: '#1A2230', marginTop: 7 }}&gt;两级匹配&lt;/Text&gt;&#10;            &lt;Text style={{ fontSize: 19, color: '#1A2230', lineHeight: 1.5, marginTop: 7 }}&gt;检索候选 → 局部特征 → 精验，得到可信帧对&lt;/Text&gt;&#10;            &lt;Text style={{ fontSize: 18, color: '#1D5FC0', fontWeight: 'bold', marginTop: 'auto' }}&gt;治&quot;乱&quot;&lt;/Text&gt;&#10;        &lt;/Box&gt;&#10;        &lt;Box style={{ flex: 1, minHeight: '158px', backgroundColor: '#F0F5FC', borderRadius: 6, padding: '16px 14px', flexDirection: 'column' }}&gt;&#10;            &lt;Text style={{ fontSize: 18, fontWeight: 'bold', color: '#1E4FA8' }}&gt;STEP 2&lt;/Text&gt;&#10;            &lt;Text style={{ fontSize: 23, fontWeight: 'bold', color: '#1A2230', marginTop: 7 }}&gt;更新协视图&lt;/Text&gt;&#10;            &lt;Text style={{ fontSize: 19, color: '#1A2230', lineHeight: 1.5, marginTop: 7 }}&gt;边权 = 内点数倒数，越可靠越&quot;近&quot;&lt;/Text&gt;&#10;            &lt;Text style={{ fontSize: 18, color: '#1D5FC0', fontWeight: 'bold', marginTop: 'auto' }}&gt;为后续提供&quot;距离&quot;&lt;/Text&gt;&#10;        &lt;/Box&gt;&#10;        &lt;Box style={{ flex: 1, minHeight: '158px', backgroundColor: '#F0F5FC', borderRadius: 6, padding: '16px 14px', flexDirection: 'column' }}&gt;&#10;            &lt;Text style={{ fontSize: 18, fontWeight: 'bold', color: '#1E4FA8' }}&gt;STEP 3&lt;/Text&gt;&#10;            &lt;Text style={{ fontSize: 23, fontWeight: 'bold', color: '#1A2230', marginTop: 7 }}&gt;回环检测&lt;/Text&gt;&#10;            &lt;Text style={{ fontSize: 19, color: '#1A2230', lineHeight: 1.5, marginTop: 7 }}&gt;簇间跳数 &amp;gt; 5 且有效对 &amp;gt; 2 才触发&lt;/Text&gt;&#10;            &lt;Text style={{ fontSize: 18, color: '#1D5FC0', fontWeight: 'bold', marginTop: 'auto' }}&gt;治&quot;漂&quot;·发现&lt;/Text&gt;&#10;        &lt;/Box&gt;&#10;    &lt;/Box&gt;&#10;    &lt;Box style={{ padding: '16px 40px 0px 40px', flexDirection: 'row', gap: 14 }}&gt;&#10;        &lt;Box style={{ flex: 1, minHeight: '158px', backgroundColor: '#F7F9FC', borderRadius: 6, padding: '16px 14px', flexDirection: 'column' }}&gt;&#10;            &lt;Text style={{ fontSize: 18, fontWeight: 'bold', color: '#1E4FA8' }}&gt;STEP 4&lt;/Text&gt;&#10;            &lt;Text style={{ fontSize: 23, fontWeight: 'bold', color: '#1A2230', marginTop: 7 }}&gt;局部 BA&lt;/Text&gt;&#10;            &lt;Text style={{ fontSize: 19, color: '#1A2230', lineHeight: 1.5, marginTop: 7 }}&gt;选 20 个高连通帧，GPU 上优化位姿&lt;/Text&gt;&#10;            &lt;Text style={{ fontSize: 18, color: '#1D5FC0', fontWeight: 'bold', marginTop: 'auto' }}&gt;治&quot;慢&quot;&lt;/Text&gt;&#10;        &lt;/Box&gt;&#10;        &lt;Box style={{ flex: 1, minHeight: '158px', backgroundColor: '#F7F9FC', borderRadius: 6, padding: '16px 14px', flexDirection: 'column' }}&gt;&#10;            &lt;Text style={{ fontSize: 18, fontWeight: 'bold', color: '#1E4FA8' }}&gt;STEP 5&lt;/Text&gt;&#10;            &lt;Text style={{ fontSize: 23, fontWeight: 'bold', color: '#1A2230', marginTop: 7 }}&gt;回环修正&lt;/Text&gt;&#10;            &lt;Text style={{ fontSize: 19, color: '#1A2230', lineHeight: 1.5, marginTop: 7 }}&gt;焊接 BA + 主干传播，位姿与高斯一起动&lt;/Text&gt;&#10;            &lt;Text style={{ fontSize: 18, color: '#1D5FC0', fontWeight: 'bold', marginTop: 'auto' }}&gt;治&quot;漂&quot;·修正&lt;/Text&gt;&#10;        &lt;/Box&gt;&#10;        &lt;Box style={{ flex: 1, minHeight: '158px', backgroundColor: '#F7F9FC', borderRadius: 6, padding: '16px 14px', flexDirection: 'column' }}&gt;&#10;            &lt;Text style={{ fontSize: 18, fontWeight: 'bold', color: '#1E4FA8' }}&gt;STEP 6&lt;/Text&gt;&#10;            &lt;Text style={{ fontSize: 23, fontWeight: 'bold', color: '#1A2230', marginTop: 7 }}&gt;投放与优化&lt;/Text&gt;&#10;            &lt;Text style={{ fontSize: 19, color: '#1A2230', lineHeight: 1.5, marginTop: 7 }}&gt;分块深度对齐投放，每帧固定 30 次迭代&lt;/Text&gt;&#10;            &lt;Text style={{ fontSize: 18, color: '#1D5FC0', fontWeight: 'bold', marginTop: 'auto' }}&gt;治&quot;爆&quot;（配层级）&lt;/Text&gt;&#10;        &lt;/Box&gt;&#10;    &lt;/Box&gt;&#10;    &lt;Box style={{ margin: '18px 40px 0px 40px', backgroundColor: '#F0F5FC', borderLeft: '5px solid #1E4FA8', padding: '15px 20px' }}&gt;&#10;        &lt;Text style={{ fontSize: 21, color: '#1A2230', lineHeight: 1.5 }}&gt;另有一处容错：匹配失败的帧先&quot;搁置&quot;，后续出现相似帧时再取出重试——乱序输入因此不必强求一次匹配成功。&lt;/Text&gt;&#10;    &lt;/Box&gt;&#10;    &lt;Box style={{ padding: '14px 40px 0px 40px' }}&gt;&#10;        &lt;Text style={{ fontSize: 17, color: '#8B97A8' }}&gt;六步中只有 STEP 3 与 STEP 5 是&quot;偶尔做一次的大事&quot;，其余每帧都跑；这也是实时性的来源。&lt;/Text&gt;&#10;    &lt;/Box&gt;&#10;&lt;/Slide&gt;&#10;"/>
         <p:cNvGrpSpPr/>
         <p:nvPr/>
       </p:nvGrpSpPr>
@@ -15767,7 +14519,7 @@
       </p:grpSpPr>
       <p:sp>
         <p:nvSpPr>
-          <p:cNvPr id="323" name=""/>
+          <p:cNvPr id="295" name=""/>
           <p:cNvSpPr/>
           <p:nvPr/>
         </p:nvSpPr>
@@ -15791,7 +14543,7 @@
       </p:sp>
       <p:sp>
         <p:nvSpPr>
-          <p:cNvPr id="324" name=""/>
+          <p:cNvPr id="296" name=""/>
           <p:cNvSpPr/>
           <p:nvPr/>
         </p:nvSpPr>
@@ -15815,7 +14567,7 @@
       </p:sp>
       <p:sp>
         <p:nvSpPr>
-          <p:cNvPr id="325" name="" descr="{&quot;isTemplate&quot;:true,&quot;type&quot;:&quot;text&quot;}"/>
+          <p:cNvPr id="297" name="" descr="{&quot;isTemplate&quot;:true,&quot;type&quot;:&quot;text&quot;}"/>
           <p:cNvSpPr txBox="1"/>
           <p:nvPr/>
         </p:nvSpPr>
@@ -15850,7 +14602,7 @@
       </p:sp>
       <p:sp>
         <p:nvSpPr>
-          <p:cNvPr id="326" name="" descr="{&quot;isTemplate&quot;:true,&quot;type&quot;:&quot;text&quot;}"/>
+          <p:cNvPr id="298" name="" descr="{&quot;isTemplate&quot;:true,&quot;type&quot;:&quot;text&quot;}"/>
           <p:cNvSpPr txBox="1"/>
           <p:nvPr/>
         </p:nvSpPr>
@@ -15885,7 +14637,7 @@
       </p:sp>
       <p:sp>
         <p:nvSpPr>
-          <p:cNvPr id="327" name="" descr="{&quot;isTemplate&quot;:true,&quot;type&quot;:&quot;text&quot;}"/>
+          <p:cNvPr id="299" name="" descr="{&quot;isTemplate&quot;:true,&quot;type&quot;:&quot;text&quot;}"/>
           <p:cNvSpPr txBox="1"/>
           <p:nvPr/>
         </p:nvSpPr>
@@ -15940,7 +14692,7 @@
       </p:sp>
       <p:sp>
         <p:nvSpPr>
-          <p:cNvPr id="328" name=""/>
+          <p:cNvPr id="300" name=""/>
           <p:cNvSpPr/>
           <p:nvPr/>
         </p:nvSpPr>
@@ -15966,7 +14718,7 @@
       </p:sp>
       <p:sp>
         <p:nvSpPr>
-          <p:cNvPr id="329" name="" descr="{&quot;isTemplate&quot;:true,&quot;type&quot;:&quot;text&quot;}"/>
+          <p:cNvPr id="301" name="" descr="{&quot;isTemplate&quot;:true,&quot;type&quot;:&quot;text&quot;}"/>
           <p:cNvSpPr txBox="1"/>
           <p:nvPr/>
         </p:nvSpPr>
@@ -16001,7 +14753,7 @@
       </p:sp>
       <p:sp>
         <p:nvSpPr>
-          <p:cNvPr id="330" name="" descr="{&quot;isTemplate&quot;:true,&quot;type&quot;:&quot;text&quot;}"/>
+          <p:cNvPr id="302" name="" descr="{&quot;isTemplate&quot;:true,&quot;type&quot;:&quot;text&quot;}"/>
           <p:cNvSpPr txBox="1"/>
           <p:nvPr/>
         </p:nvSpPr>
@@ -16036,7 +14788,7 @@
       </p:sp>
       <p:sp>
         <p:nvSpPr>
-          <p:cNvPr id="331" name="" descr="{&quot;isTemplate&quot;:true,&quot;type&quot;:&quot;text&quot;}"/>
+          <p:cNvPr id="303" name="" descr="{&quot;isTemplate&quot;:true,&quot;type&quot;:&quot;text&quot;}"/>
           <p:cNvSpPr txBox="1"/>
           <p:nvPr/>
         </p:nvSpPr>
@@ -16113,7 +14865,7 @@
       </p:sp>
       <p:sp>
         <p:nvSpPr>
-          <p:cNvPr id="332" name="" descr="{&quot;isTemplate&quot;:true,&quot;type&quot;:&quot;text&quot;}"/>
+          <p:cNvPr id="304" name="" descr="{&quot;isTemplate&quot;:true,&quot;type&quot;:&quot;text&quot;}"/>
           <p:cNvSpPr txBox="1"/>
           <p:nvPr/>
         </p:nvSpPr>
@@ -16178,7 +14930,7 @@
       </p:sp>
       <p:sp>
         <p:nvSpPr>
-          <p:cNvPr id="333" name=""/>
+          <p:cNvPr id="305" name=""/>
           <p:cNvSpPr/>
           <p:nvPr/>
         </p:nvSpPr>
@@ -16204,7 +14956,7 @@
       </p:sp>
       <p:sp>
         <p:nvSpPr>
-          <p:cNvPr id="334" name="" descr="{&quot;isTemplate&quot;:true,&quot;type&quot;:&quot;text&quot;}"/>
+          <p:cNvPr id="306" name="" descr="{&quot;isTemplate&quot;:true,&quot;type&quot;:&quot;text&quot;}"/>
           <p:cNvSpPr txBox="1"/>
           <p:nvPr/>
         </p:nvSpPr>
@@ -16239,7 +14991,7 @@
       </p:sp>
       <p:sp>
         <p:nvSpPr>
-          <p:cNvPr id="335" name="" descr="{&quot;isTemplate&quot;:true,&quot;type&quot;:&quot;text&quot;}"/>
+          <p:cNvPr id="307" name="" descr="{&quot;isTemplate&quot;:true,&quot;type&quot;:&quot;text&quot;}"/>
           <p:cNvSpPr txBox="1"/>
           <p:nvPr/>
         </p:nvSpPr>
@@ -16274,7 +15026,7 @@
       </p:sp>
       <p:sp>
         <p:nvSpPr>
-          <p:cNvPr id="336" name="" descr="{&quot;isTemplate&quot;:true,&quot;type&quot;:&quot;text&quot;}"/>
+          <p:cNvPr id="308" name="" descr="{&quot;isTemplate&quot;:true,&quot;type&quot;:&quot;text&quot;}"/>
           <p:cNvSpPr txBox="1"/>
           <p:nvPr/>
         </p:nvSpPr>
@@ -16359,7 +15111,7 @@
       </p:sp>
       <p:sp>
         <p:nvSpPr>
-          <p:cNvPr id="337" name="" descr="{&quot;isTemplate&quot;:true,&quot;type&quot;:&quot;text&quot;}"/>
+          <p:cNvPr id="309" name="" descr="{&quot;isTemplate&quot;:true,&quot;type&quot;:&quot;text&quot;}"/>
           <p:cNvSpPr txBox="1"/>
           <p:nvPr/>
         </p:nvSpPr>
@@ -16424,7 +15176,7 @@
       </p:sp>
       <p:sp>
         <p:nvSpPr>
-          <p:cNvPr id="338" name=""/>
+          <p:cNvPr id="310" name=""/>
           <p:cNvSpPr/>
           <p:nvPr/>
         </p:nvSpPr>
@@ -16450,7 +15202,7 @@
       </p:sp>
       <p:sp>
         <p:nvSpPr>
-          <p:cNvPr id="339" name="" descr="{&quot;isTemplate&quot;:true,&quot;type&quot;:&quot;text&quot;}"/>
+          <p:cNvPr id="311" name="" descr="{&quot;isTemplate&quot;:true,&quot;type&quot;:&quot;text&quot;}"/>
           <p:cNvSpPr txBox="1"/>
           <p:nvPr/>
         </p:nvSpPr>
@@ -16485,7 +15237,7 @@
       </p:sp>
       <p:sp>
         <p:nvSpPr>
-          <p:cNvPr id="340" name="" descr="{&quot;isTemplate&quot;:true,&quot;type&quot;:&quot;text&quot;}"/>
+          <p:cNvPr id="312" name="" descr="{&quot;isTemplate&quot;:true,&quot;type&quot;:&quot;text&quot;}"/>
           <p:cNvSpPr txBox="1"/>
           <p:nvPr/>
         </p:nvSpPr>
@@ -16520,7 +15272,7 @@
       </p:sp>
       <p:sp>
         <p:nvSpPr>
-          <p:cNvPr id="341" name="" descr="{&quot;isTemplate&quot;:true,&quot;type&quot;:&quot;text&quot;}"/>
+          <p:cNvPr id="313" name="" descr="{&quot;isTemplate&quot;:true,&quot;type&quot;:&quot;text&quot;}"/>
           <p:cNvSpPr txBox="1"/>
           <p:nvPr/>
         </p:nvSpPr>
@@ -16595,7 +15347,7 @@
       </p:sp>
       <p:sp>
         <p:nvSpPr>
-          <p:cNvPr id="342" name="" descr="{&quot;isTemplate&quot;:true,&quot;type&quot;:&quot;text&quot;}"/>
+          <p:cNvPr id="314" name="" descr="{&quot;isTemplate&quot;:true,&quot;type&quot;:&quot;text&quot;}"/>
           <p:cNvSpPr txBox="1"/>
           <p:nvPr/>
         </p:nvSpPr>
@@ -16670,7 +15422,7 @@
       </p:sp>
       <p:sp>
         <p:nvSpPr>
-          <p:cNvPr id="343" name=""/>
+          <p:cNvPr id="315" name=""/>
           <p:cNvSpPr/>
           <p:nvPr/>
         </p:nvSpPr>
@@ -16696,7 +15448,7 @@
       </p:sp>
       <p:sp>
         <p:nvSpPr>
-          <p:cNvPr id="344" name="" descr="{&quot;isTemplate&quot;:true,&quot;type&quot;:&quot;text&quot;}"/>
+          <p:cNvPr id="316" name="" descr="{&quot;isTemplate&quot;:true,&quot;type&quot;:&quot;text&quot;}"/>
           <p:cNvSpPr txBox="1"/>
           <p:nvPr/>
         </p:nvSpPr>
@@ -16731,7 +15483,7 @@
       </p:sp>
       <p:sp>
         <p:nvSpPr>
-          <p:cNvPr id="345" name="" descr="{&quot;isTemplate&quot;:true,&quot;type&quot;:&quot;text&quot;}"/>
+          <p:cNvPr id="317" name="" descr="{&quot;isTemplate&quot;:true,&quot;type&quot;:&quot;text&quot;}"/>
           <p:cNvSpPr txBox="1"/>
           <p:nvPr/>
         </p:nvSpPr>
@@ -16776,7 +15528,7 @@
       </p:sp>
       <p:sp>
         <p:nvSpPr>
-          <p:cNvPr id="346" name="" descr="{&quot;isTemplate&quot;:true,&quot;type&quot;:&quot;text&quot;}"/>
+          <p:cNvPr id="318" name="" descr="{&quot;isTemplate&quot;:true,&quot;type&quot;:&quot;text&quot;}"/>
           <p:cNvSpPr txBox="1"/>
           <p:nvPr/>
         </p:nvSpPr>
@@ -16851,7 +15603,7 @@
       </p:sp>
       <p:sp>
         <p:nvSpPr>
-          <p:cNvPr id="347" name="" descr="{&quot;isTemplate&quot;:true,&quot;type&quot;:&quot;text&quot;}"/>
+          <p:cNvPr id="319" name="" descr="{&quot;isTemplate&quot;:true,&quot;type&quot;:&quot;text&quot;}"/>
           <p:cNvSpPr txBox="1"/>
           <p:nvPr/>
         </p:nvSpPr>
@@ -16916,7 +15668,7 @@
       </p:sp>
       <p:sp>
         <p:nvSpPr>
-          <p:cNvPr id="348" name=""/>
+          <p:cNvPr id="320" name=""/>
           <p:cNvSpPr/>
           <p:nvPr/>
         </p:nvSpPr>
@@ -16942,7 +15694,7 @@
       </p:sp>
       <p:sp>
         <p:nvSpPr>
-          <p:cNvPr id="349" name="" descr="{&quot;isTemplate&quot;:true,&quot;type&quot;:&quot;text&quot;}"/>
+          <p:cNvPr id="321" name="" descr="{&quot;isTemplate&quot;:true,&quot;type&quot;:&quot;text&quot;}"/>
           <p:cNvSpPr txBox="1"/>
           <p:nvPr/>
         </p:nvSpPr>
@@ -16977,7 +15729,7 @@
       </p:sp>
       <p:sp>
         <p:nvSpPr>
-          <p:cNvPr id="350" name="" descr="{&quot;isTemplate&quot;:true,&quot;type&quot;:&quot;text&quot;}"/>
+          <p:cNvPr id="322" name="" descr="{&quot;isTemplate&quot;:true,&quot;type&quot;:&quot;text&quot;}"/>
           <p:cNvSpPr txBox="1"/>
           <p:nvPr/>
         </p:nvSpPr>
@@ -17012,7 +15764,7 @@
       </p:sp>
       <p:sp>
         <p:nvSpPr>
-          <p:cNvPr id="351" name="" descr="{&quot;isTemplate&quot;:true,&quot;type&quot;:&quot;text&quot;}"/>
+          <p:cNvPr id="323" name="" descr="{&quot;isTemplate&quot;:true,&quot;type&quot;:&quot;text&quot;}"/>
           <p:cNvSpPr txBox="1"/>
           <p:nvPr/>
         </p:nvSpPr>
@@ -17067,7 +15819,7 @@
       </p:sp>
       <p:sp>
         <p:nvSpPr>
-          <p:cNvPr id="352" name="" descr="{&quot;isTemplate&quot;:true,&quot;type&quot;:&quot;text&quot;}"/>
+          <p:cNvPr id="324" name="" descr="{&quot;isTemplate&quot;:true,&quot;type&quot;:&quot;text&quot;}"/>
           <p:cNvSpPr txBox="1"/>
           <p:nvPr/>
         </p:nvSpPr>
@@ -17142,7 +15894,7 @@
       </p:sp>
       <p:sp>
         <p:nvSpPr>
-          <p:cNvPr id="353" name=""/>
+          <p:cNvPr id="325" name=""/>
           <p:cNvSpPr/>
           <p:nvPr/>
         </p:nvSpPr>
@@ -17168,7 +15920,7 @@
       </p:sp>
       <p:sp>
         <p:nvSpPr>
-          <p:cNvPr id="354" name="" descr="{&quot;isTemplate&quot;:true,&quot;type&quot;:&quot;text&quot;}"/>
+          <p:cNvPr id="326" name="" descr="{&quot;isTemplate&quot;:true,&quot;type&quot;:&quot;text&quot;}"/>
           <p:cNvSpPr txBox="1"/>
           <p:nvPr/>
         </p:nvSpPr>
@@ -17203,7 +15955,7 @@
       </p:sp>
       <p:sp>
         <p:nvSpPr>
-          <p:cNvPr id="355" name="" descr="{&quot;isTemplate&quot;:true,&quot;type&quot;:&quot;text&quot;}"/>
+          <p:cNvPr id="327" name="" descr="{&quot;isTemplate&quot;:true,&quot;type&quot;:&quot;text&quot;}"/>
           <p:cNvSpPr txBox="1"/>
           <p:nvPr/>
         </p:nvSpPr>
@@ -17238,7 +15990,7 @@
       </p:sp>
       <p:sp>
         <p:nvSpPr>
-          <p:cNvPr id="356" name="" descr="{&quot;isTemplate&quot;:true,&quot;type&quot;:&quot;text&quot;}"/>
+          <p:cNvPr id="328" name="" descr="{&quot;isTemplate&quot;:true,&quot;type&quot;:&quot;text&quot;}"/>
           <p:cNvSpPr txBox="1"/>
           <p:nvPr/>
         </p:nvSpPr>
@@ -17293,7 +16045,7 @@
       </p:sp>
       <p:sp>
         <p:nvSpPr>
-          <p:cNvPr id="357" name="" descr="{&quot;isTemplate&quot;:true,&quot;type&quot;:&quot;text&quot;}"/>
+          <p:cNvPr id="329" name="" descr="{&quot;isTemplate&quot;:true,&quot;type&quot;:&quot;text&quot;}"/>
           <p:cNvSpPr txBox="1"/>
           <p:nvPr/>
         </p:nvSpPr>
@@ -17368,7 +16120,7 @@
       </p:sp>
       <p:sp>
         <p:nvSpPr>
-          <p:cNvPr id="358" name=""/>
+          <p:cNvPr id="330" name=""/>
           <p:cNvSpPr/>
           <p:nvPr/>
         </p:nvSpPr>
@@ -17392,7 +16144,7 @@
       </p:sp>
       <p:sp>
         <p:nvSpPr>
-          <p:cNvPr id="359" name=""/>
+          <p:cNvPr id="331" name=""/>
           <p:cNvSpPr/>
           <p:nvPr/>
         </p:nvSpPr>
@@ -17432,7 +16184,7 @@
       </p:sp>
       <p:sp>
         <p:nvSpPr>
-          <p:cNvPr id="360" name="" descr="{&quot;isTemplate&quot;:true,&quot;type&quot;:&quot;text&quot;}"/>
+          <p:cNvPr id="332" name="" descr="{&quot;isTemplate&quot;:true,&quot;type&quot;:&quot;text&quot;}"/>
           <p:cNvSpPr txBox="1"/>
           <p:nvPr/>
         </p:nvSpPr>
@@ -17507,7 +16259,7 @@
       </p:sp>
       <p:sp>
         <p:nvSpPr>
-          <p:cNvPr id="361" name="" descr="{&quot;isTemplate&quot;:true,&quot;type&quot;:&quot;text&quot;}"/>
+          <p:cNvPr id="333" name="" descr="{&quot;isTemplate&quot;:true,&quot;type&quot;:&quot;text&quot;}"/>
           <p:cNvSpPr txBox="1"/>
           <p:nvPr/>
         </p:nvSpPr>
@@ -17630,7 +16382,7 @@
   <p:cSld>
     <p:spTree>
       <p:nvGrpSpPr>
-        <p:cNvPr id="362" name="" descr="&lt;Slide style={{ width: '1280px', height: '720px', backgroundColor: '#FFFFFF', padding: '0px', flexDirection: 'column' }}&gt;&#10;    &lt;Box style={{ width: '1280px', height: '8px', backgroundColor: '#1E4FA8' }} /&gt;&#10;    &lt;Box style={{ padding: '26px 40px 0px 40px', flexDirection: 'row', justifyContent: 'space-between', alignItems: 'flex-end' }}&gt;&#10;        &lt;Text style={{ fontSize: 34, fontWeight: 'bold', color: '#1E4FA8' }}&gt;算法地图：七步重建链，用在哪、算什么、管什么&lt;/Text&gt;&#10;        &lt;Text style={{ fontSize: 15, color: '#8B97A8' }}&gt;07 / 15&lt;/Text&gt;&#10;    &lt;/Box&gt;&#10;    &lt;Box style={{ padding: '10px 40px 0px 40px' }}&gt;&#10;        &lt;Text style={{ fontSize: 20, color: '#4A5568', lineHeight: 1.4 }}&gt;位姿重建真正发生在 &lt;b&gt;第 5 步&lt;/b&gt;：前三步只为它准备可信观测，第 4 步划定它的变量范围，第 6 步修它累积的漂移，第 7 步才轮到高斯。&lt;/Text&gt;&#10;    &lt;/Box&gt;&#10;&#10;    &lt;Box style={{ padding: '12px 40px 0px 40px', flexDirection: 'row', gap: 10 }}&gt;&#10;        &lt;Box style={{ flex: 1, height: 46, backgroundColor: '#F0F5FC', borderRadius: 4, alignItems: 'center', justifyContent: 'center' }}&gt;&#10;            &lt;Text style={{ fontSize: 19, fontWeight: 'bold', color: '#1E4FA8' }}&gt;① 检索&lt;/Text&gt;&#10;        &lt;/Box&gt;&#10;        &lt;Box style={{ flex: 1, height: 46, backgroundColor: '#F0F5FC', borderRadius: 4, alignItems: 'center', justifyContent: 'center' }}&gt;&#10;            &lt;Text style={{ fontSize: 19, fontWeight: 'bold', color: '#1E4FA8' }}&gt;② 粗筛&lt;/Text&gt;&#10;        &lt;/Box&gt;&#10;        &lt;Box style={{ flex: 1, height: 46, backgroundColor: '#F0F5FC', borderRadius: 4, alignItems: 'center', justifyContent: 'center' }}&gt;&#10;            &lt;Text style={{ fontSize: 19, fontWeight: 'bold', color: '#1E4FA8' }}&gt;③ 建边&lt;/Text&gt;&#10;        &lt;/Box&gt;&#10;        &lt;Box style={{ flex: 1, height: 46, backgroundColor: '#F0F5FC', borderRadius: 4, alignItems: 'center', justifyContent: 'center' }}&gt;&#10;            &lt;Text style={{ fontSize: 19, fontWeight: 'bold', color: '#1E4FA8' }}&gt;④ 选窗&lt;/Text&gt;&#10;        &lt;/Box&gt;&#10;        &lt;Box style={{ flex: 1, height: 46, backgroundColor: '#1E4FA8', borderRadius: 4, alignItems: 'center', justifyContent: 'center' }}&gt;&#10;            &lt;Text style={{ fontSize: 19, fontWeight: 'bold', color: '#FFFFFF' }}&gt;⑤ 局部 BA&lt;/Text&gt;&#10;        &lt;/Box&gt;&#10;        &lt;Box style={{ flex: 1, height: 46, backgroundColor: '#F0F5FC', borderRadius: 4, alignItems: 'center', justifyContent: 'center' }}&gt;&#10;            &lt;Text style={{ fontSize: 19, fontWeight: 'bold', color: '#1E4FA8' }}&gt;⑥ 纠偏&lt;/Text&gt;&#10;        &lt;/Box&gt;&#10;        &lt;Box style={{ flex: 1, height: 46, backgroundColor: '#F0F5FC', borderRadius: 4, alignItems: 'center', justifyContent: 'center' }}&gt;&#10;            &lt;Text style={{ fontSize: 19, fontWeight: 'bold', color: '#1E4FA8' }}&gt;⑦ 落位&lt;/Text&gt;&#10;        &lt;/Box&gt;&#10;    &lt;/Box&gt;&#10;&#10;    &lt;Box style={{ padding: '12px 40px 0px 40px', flexDirection: 'column' }}&gt;&#10;        &lt;Box style={{ flexDirection: 'row', backgroundColor: '#1E4FA8', padding: '10px 14px' }}&gt;&#10;            &lt;Text style={{ width: '44px', fontSize: 18, fontWeight: 'bold', color: '#FFFFFF' }}&gt;步&lt;/Text&gt;&#10;            &lt;Text style={{ width: '258px', fontSize: 18, fontWeight: 'bold', color: '#FFFFFF' }}&gt;算法&lt;/Text&gt;&#10;            &lt;Text style={{ flex: 2.2, fontSize: 18, fontWeight: 'bold', color: '#FFFFFF' }}&gt;核心公式 / 判据&lt;/Text&gt;&#10;            &lt;Text style={{ flex: 2.4, fontSize: 18, fontWeight: 'bold', color: '#FFFFFF' }}&gt;在重建中的作用&lt;/Text&gt;&#10;        &lt;/Box&gt;&#10;        &lt;Box style={{ flexDirection: 'row', alignItems: 'center', minHeight: 58, padding: '10px 14px', borderBottom: '1px solid #D6DCE5' }}&gt;&#10;            &lt;Text style={{ width: '44px', fontSize: 18, fontWeight: 'bold', color: '#1E4FA8' }}&gt;①&lt;/Text&gt;&#10;            &lt;Text style={{ width: '258px', fontSize: 18, color: '#1A2230' }}&gt;MegaLoc 全局描述子&lt;/Text&gt;&#10;            &lt;Text style={{ flex: 2.2, fontSize: 18, color: '#1A2230' }}&gt;s = d_i · d_j，取 top-K = 20&lt;/Text&gt;&#10;            &lt;Text style={{ flex: 2.4, fontSize: 18, color: '#1A2230' }}&gt;从全部历史帧里找&quot;可能同处&quot;的候选，与帧序无关&lt;/Text&gt;&#10;        &lt;/Box&gt;&#10;        &lt;Box style={{ flexDirection: 'row', alignItems: 'center', minHeight: 58, padding: '10px 14px', backgroundColor: '#F7F9FC', borderBottom: '1px solid #D6DCE5' }}&gt;&#10;            &lt;Text style={{ width: '44px', fontSize: 18, fontWeight: 'bold', color: '#1E4FA8' }}&gt;②&lt;/Text&gt;&#10;            &lt;Text style={{ width: '258px', fontSize: 18, color: '#1A2230' }}&gt;XFeat 局部特征穷举&lt;/Text&gt;&#10;            &lt;Text style={{ flex: 2.2, fontSize: 18, color: '#1A2230' }}&gt;K' = top-5 |M_ij|（按内点数）&lt;/Text&gt;&#10;            &lt;Text style={{ flex: 2.4, fontSize: 18, color: '#1A2230' }}&gt;淘汰&quot;外观像、但没对上点&quot;的候选&lt;/Text&gt;&#10;        &lt;/Box&gt;&#10;        &lt;Box style={{ flexDirection: 'row', alignItems: 'center', minHeight: 58, padding: '10px 14px', borderBottom: '1px solid #D6DCE5' }}&gt;&#10;            &lt;Text style={{ width: '44px', fontSize: 18, fontWeight: 'bold', color: '#1E4FA8' }}&gt;③&lt;/Text&gt;&#10;            &lt;Text style={{ width: '258px', fontSize: 18, color: '#1A2230' }}&gt;LightGlue + RANSAC&lt;/Text&gt;&#10;            &lt;Text style={{ flex: 2.2, fontSize: 18, color: '#1A2230' }}&gt;|M_ij| &amp;gt; τ_m = 500 才建边；w_ij = 1/|M_ij|&lt;/Text&gt;&#10;            &lt;Text style={{ flex: 2.4, fontSize: 18, color: '#1A2230' }}&gt;唯一产生共视约束的一步，结果写入协视图&lt;/Text&gt;&#10;        &lt;/Box&gt;&#10;        &lt;Box style={{ flexDirection: 'row', alignItems: 'center', minHeight: 58, padding: '10px 14px', backgroundColor: '#F7F9FC', borderBottom: '1px solid #D6DCE5' }}&gt;&#10;            &lt;Text style={{ width: '44px', fontSize: 18, fontWeight: 'bold', color: '#1E4FA8' }}&gt;④&lt;/Text&gt;&#10;            &lt;Text style={{ width: '258px', fontSize: 18, color: '#1A2230' }}&gt;协视图贪心扩张（式 1）&lt;/Text&gt;&#10;            &lt;Text style={{ flex: 2.2, fontSize: 18, color: '#1A2230' }}&gt;S ← S ∪ argmax Σ_j |M_ij|，至 20 帧&lt;/Text&gt;&#10;            &lt;Text style={{ flex: 2.4, fontSize: 18, color: '#1A2230' }}&gt;划定 BA 的变量范围：最该一起优化的 20 帧&lt;/Text&gt;&#10;        &lt;/Box&gt;&#10;        &lt;Box style={{ flexDirection: 'row', alignItems: 'center', minHeight: 58, padding: '10px 14px', backgroundColor: '#E8F0FB', borderTop: '1px solid #3D7BD9', borderBottom: '1px solid #3D7BD9' }}&gt;&#10;            &lt;Text style={{ width: '44px', fontSize: 18, fontWeight: 'bold', color: '#1E4FA8' }}&gt;⑤&lt;/Text&gt;&#10;            &lt;Text style={{ width: '258px', fontSize: 18, fontWeight: 'bold', color: '#1A2230' }}&gt;GPU 局部 BA（LM + Schur）&lt;/Text&gt;&#10;            &lt;Text style={{ flex: 2.2, fontSize: 18, fontWeight: 'bold', color: '#1A2230' }}&gt;min Σ ρ( ||u_ij − π(T_i, X_j)||² )&lt;/Text&gt;&#10;            &lt;Text style={{ flex: 2.4, fontSize: 18, fontWeight: 'bold', color: '#1A2230' }}&gt;真正解出位姿 T_i 与三维点 X_j——重建本体&lt;/Text&gt;&#10;        &lt;/Box&gt;&#10;        &lt;Box style={{ flexDirection: 'row', alignItems: 'center', minHeight: 58, padding: '10px 14px', borderBottom: '1px solid #D6DCE5' }}&gt;&#10;            &lt;Text style={{ width: '44px', fontSize: 18, fontWeight: 'bold', color: '#1E4FA8' }}&gt;⑥&lt;/Text&gt;&#10;            &lt;Text style={{ width: '258px', fontSize: 18, color: '#1A2230' }}&gt;簇级回环 + 图传播&lt;/Text&gt;&#10;            &lt;Text style={{ flex: 2.2, fontSize: 18, color: '#1A2230' }}&gt;跳数 = 加权图距 &amp;gt; 10 触发；T_Δ = T_a^opt(T_a^init)^-1&lt;/Text&gt;&#10;            &lt;Text style={{ flex: 2.4, fontSize: 18, color: '#1A2230' }}&gt;两簇各扩 N/2 帧焊接，得 Sim(3) 后沿主干摊回&lt;/Text&gt;&#10;        &lt;/Box&gt;&#10;        &lt;Box style={{ flexDirection: 'row', alignItems: 'center', minHeight: 58, padding: '10px 14px', backgroundColor: '#F7F9FC' }}&gt;&#10;            &lt;Text style={{ width: '44px', fontSize: 18, fontWeight: 'bold', color: '#1E4FA8' }}&gt;⑦&lt;/Text&gt;&#10;            &lt;Text style={{ width: '258px', fontSize: 18, color: '#1A2230' }}&gt;分块深度对齐 + 渐进层级&lt;/Text&gt;&#10;            &lt;Text style={{ flex: 2.2, fontSize: 18, color: '#1A2230' }}&gt;size &amp;lt; τ_l 且可并数 &amp;gt; max(10%, 20 万) → kNN 加权合并&lt;/Text&gt;&#10;            &lt;Text style={{ flex: 2.4, fontSize: 18, color: '#1A2230' }}&gt;位姿定后才投放高斯；层级只压显存，不改位姿&lt;/Text&gt;&#10;        &lt;/Box&gt;&#10;    &lt;/Box&gt;&#10;&#10;    &lt;Box style={{ padding: '12px 40px 0px 40px' }}&gt;&#10;        &lt;Text style={{ fontSize: 16, color: '#8B97A8', lineHeight: 1.45 }}&gt;加粗行是位姿求解本身，第 ⑥ 步会对已求出的位姿再整体修正一次。符号：u 像素观测、π 投影、ρ 鲁棒核、T 相机位姿、X 路标点。&lt;/Text&gt;&#10;        &lt;Text style={{ fontSize: 16, color: '#8B97A8', lineHeight: 1.45, marginTop: 3 }}&gt;① 的 VPR 论文写 MixVPR，开源代码因许可原因换为 MegaLoc；τ_m = 500，τ_l = 0.5 px，N = 20，K = 20。&lt;/Text&gt;&#10;    &lt;/Box&gt;&#10;&lt;/Slide&gt;&#10;"/>
+        <p:cNvPr id="334" name="" descr="&lt;Slide style={{ width: '1280px', height: '720px', backgroundColor: '#FFFFFF', padding: '0px', flexDirection: 'column' }}&gt;&#10;    &lt;Box style={{ width: '1280px', height: '8px', backgroundColor: '#1E4FA8' }} /&gt;&#10;    &lt;Box style={{ padding: '26px 40px 0px 40px', flexDirection: 'row', justifyContent: 'space-between', alignItems: 'flex-end' }}&gt;&#10;        &lt;Text style={{ fontSize: 34, fontWeight: 'bold', color: '#1E4FA8' }}&gt;算法地图：七步重建链，用在哪、算什么、管什么&lt;/Text&gt;&#10;        &lt;Text style={{ fontSize: 15, color: '#8B97A8' }}&gt;07 / 15&lt;/Text&gt;&#10;    &lt;/Box&gt;&#10;    &lt;Box style={{ padding: '10px 40px 0px 40px' }}&gt;&#10;        &lt;Text style={{ fontSize: 20, color: '#4A5568', lineHeight: 1.4 }}&gt;位姿重建真正发生在 &lt;b&gt;第 5 步&lt;/b&gt;：前三步只为它准备可信观测，第 4 步划定它的变量范围，第 6 步修它累积的漂移，第 7 步才轮到高斯。&lt;/Text&gt;&#10;    &lt;/Box&gt;&#10;&#10;    &lt;Box style={{ padding: '12px 40px 0px 40px', flexDirection: 'row', gap: 10 }}&gt;&#10;        &lt;Box style={{ flex: 1, height: 46, backgroundColor: '#F0F5FC', borderRadius: 4, alignItems: 'center', justifyContent: 'center' }}&gt;&#10;            &lt;Text style={{ fontSize: 19, fontWeight: 'bold', color: '#1E4FA8' }}&gt;① 检索&lt;/Text&gt;&#10;        &lt;/Box&gt;&#10;        &lt;Box style={{ flex: 1, height: 46, backgroundColor: '#F0F5FC', borderRadius: 4, alignItems: 'center', justifyContent: 'center' }}&gt;&#10;            &lt;Text style={{ fontSize: 19, fontWeight: 'bold', color: '#1E4FA8' }}&gt;② 粗筛&lt;/Text&gt;&#10;        &lt;/Box&gt;&#10;        &lt;Box style={{ flex: 1, height: 46, backgroundColor: '#F0F5FC', borderRadius: 4, alignItems: 'center', justifyContent: 'center' }}&gt;&#10;            &lt;Text style={{ fontSize: 19, fontWeight: 'bold', color: '#1E4FA8' }}&gt;③ 建边&lt;/Text&gt;&#10;        &lt;/Box&gt;&#10;        &lt;Box style={{ flex: 1, height: 46, backgroundColor: '#F0F5FC', borderRadius: 4, alignItems: 'center', justifyContent: 'center' }}&gt;&#10;            &lt;Text style={{ fontSize: 19, fontWeight: 'bold', color: '#1E4FA8' }}&gt;④ 选窗&lt;/Text&gt;&#10;        &lt;/Box&gt;&#10;        &lt;Box style={{ flex: 1, height: 46, backgroundColor: '#1E4FA8', borderRadius: 4, alignItems: 'center', justifyContent: 'center' }}&gt;&#10;            &lt;Text style={{ fontSize: 19, fontWeight: 'bold', color: '#FFFFFF' }}&gt;⑤ 局部 BA&lt;/Text&gt;&#10;        &lt;/Box&gt;&#10;        &lt;Box style={{ flex: 1, height: 46, backgroundColor: '#F0F5FC', borderRadius: 4, alignItems: 'center', justifyContent: 'center' }}&gt;&#10;            &lt;Text style={{ fontSize: 19, fontWeight: 'bold', color: '#1E4FA8' }}&gt;⑥ 纠偏&lt;/Text&gt;&#10;        &lt;/Box&gt;&#10;        &lt;Box style={{ flex: 1, height: 46, backgroundColor: '#F0F5FC', borderRadius: 4, alignItems: 'center', justifyContent: 'center' }}&gt;&#10;            &lt;Text style={{ fontSize: 19, fontWeight: 'bold', color: '#1E4FA8' }}&gt;⑦ 落位&lt;/Text&gt;&#10;        &lt;/Box&gt;&#10;    &lt;/Box&gt;&#10;&#10;    &lt;Box style={{ padding: '12px 40px 0px 40px', flexDirection: 'column' }}&gt;&#10;        &lt;Box style={{ flexDirection: 'row', backgroundColor: '#1E4FA8', padding: '10px 14px' }}&gt;&#10;            &lt;Text style={{ width: '44px', fontSize: 18, fontWeight: 'bold', color: '#FFFFFF' }}&gt;步&lt;/Text&gt;&#10;            &lt;Text style={{ width: '258px', fontSize: 18, fontWeight: 'bold', color: '#FFFFFF' }}&gt;算法&lt;/Text&gt;&#10;            &lt;Text style={{ flex: 2.2, fontSize: 18, fontWeight: 'bold', color: '#FFFFFF' }}&gt;核心公式 / 判据&lt;/Text&gt;&#10;            &lt;Text style={{ flex: 2.4, fontSize: 18, fontWeight: 'bold', color: '#FFFFFF' }}&gt;在重建中的作用&lt;/Text&gt;&#10;        &lt;/Box&gt;&#10;        &lt;Box style={{ flexDirection: 'row', alignItems: 'center', minHeight: 58, padding: '10px 14px', borderBottom: '1px solid #D6DCE5' }}&gt;&#10;            &lt;Text style={{ width: '44px', fontSize: 18, fontWeight: 'bold', color: '#1E4FA8' }}&gt;①&lt;/Text&gt;&#10;            &lt;Text style={{ width: '258px', fontSize: 18, color: '#1A2230' }}&gt;MegaLoc 全局描述子&lt;/Text&gt;&#10;            &lt;Text style={{ flex: 2.2, fontSize: 18, color: '#1A2230' }}&gt;s = d_i · d_j，取 top-K = 20&lt;/Text&gt;&#10;            &lt;Text style={{ flex: 2.4, fontSize: 18, color: '#1A2230' }}&gt;从全部历史帧里找&quot;可能同处&quot;的候选，与帧序无关&lt;/Text&gt;&#10;        &lt;/Box&gt;&#10;        &lt;Box style={{ flexDirection: 'row', alignItems: 'center', minHeight: 58, padding: '10px 14px', backgroundColor: '#F7F9FC', borderBottom: '1px solid #D6DCE5' }}&gt;&#10;            &lt;Text style={{ width: '44px', fontSize: 18, fontWeight: 'bold', color: '#1E4FA8' }}&gt;②&lt;/Text&gt;&#10;            &lt;Text style={{ width: '258px', fontSize: 18, color: '#1A2230' }}&gt;XFeat 局部特征穷举&lt;/Text&gt;&#10;            &lt;Text style={{ flex: 2.2, fontSize: 18, color: '#1A2230' }}&gt;K' = top-5 |M_ij|（按内点数）&lt;/Text&gt;&#10;            &lt;Text style={{ flex: 2.4, fontSize: 18, color: '#1A2230' }}&gt;淘汰&quot;外观像、但没对上点&quot;的候选&lt;/Text&gt;&#10;        &lt;/Box&gt;&#10;        &lt;Box style={{ flexDirection: 'row', alignItems: 'center', minHeight: 58, padding: '10px 14px', borderBottom: '1px solid #D6DCE5' }}&gt;&#10;            &lt;Text style={{ width: '44px', fontSize: 18, fontWeight: 'bold', color: '#1E4FA8' }}&gt;③&lt;/Text&gt;&#10;            &lt;Text style={{ width: '258px', fontSize: 18, color: '#1A2230' }}&gt;LightGlue + RANSAC&lt;/Text&gt;&#10;            &lt;Text style={{ flex: 2.2, fontSize: 18, color: '#1A2230' }}&gt;|M_ij| &amp;gt; τ_m = 500 才建边；w_ij = 1/|M_ij|&lt;/Text&gt;&#10;            &lt;Text style={{ flex: 2.4, fontSize: 18, color: '#1A2230' }}&gt;唯一产生共视约束的一步，结果写入协视图&lt;/Text&gt;&#10;        &lt;/Box&gt;&#10;        &lt;Box style={{ flexDirection: 'row', alignItems: 'center', minHeight: 58, padding: '10px 14px', backgroundColor: '#F7F9FC', borderBottom: '1px solid #D6DCE5' }}&gt;&#10;            &lt;Text style={{ width: '44px', fontSize: 18, fontWeight: 'bold', color: '#1E4FA8' }}&gt;④&lt;/Text&gt;&#10;            &lt;Text style={{ width: '258px', fontSize: 18, color: '#1A2230' }}&gt;协视图贪心扩张（式 1）&lt;/Text&gt;&#10;            &lt;Text style={{ flex: 2.2, fontSize: 18, color: '#1A2230' }}&gt;S ← S ∪ argmax Σ_j |M_ij|，至 20 帧&lt;/Text&gt;&#10;            &lt;Text style={{ flex: 2.4, fontSize: 18, color: '#1A2230' }}&gt;划定 BA 的变量范围：最该一起优化的 20 帧&lt;/Text&gt;&#10;        &lt;/Box&gt;&#10;        &lt;Box style={{ flexDirection: 'row', alignItems: 'center', minHeight: 58, padding: '10px 14px', backgroundColor: '#E8F0FB', borderTop: '1px solid #3D7BD9', borderBottom: '1px solid #3D7BD9' }}&gt;&#10;            &lt;Text style={{ width: '44px', fontSize: 18, fontWeight: 'bold', color: '#1E4FA8' }}&gt;⑤&lt;/Text&gt;&#10;            &lt;Text style={{ width: '258px', fontSize: 18, fontWeight: 'bold', color: '#1A2230' }}&gt;GPU 局部 BA（LM + Schur）&lt;/Text&gt;&#10;            &lt;Text style={{ flex: 2.2, fontSize: 18, fontWeight: 'bold', color: '#1A2230' }}&gt;min Σ ρ( ||u_ij − π(T_i, X_j)||² )&lt;/Text&gt;&#10;            &lt;Text style={{ flex: 2.4, fontSize: 18, fontWeight: 'bold', color: '#1A2230' }}&gt;真正解出位姿 T_i 与三维点 X_j——重建本体&lt;/Text&gt;&#10;        &lt;/Box&gt;&#10;        &lt;Box style={{ flexDirection: 'row', alignItems: 'center', minHeight: 58, padding: '10px 14px', borderBottom: '1px solid #D6DCE5' }}&gt;&#10;            &lt;Text style={{ width: '44px', fontSize: 18, fontWeight: 'bold', color: '#1E4FA8' }}&gt;⑥&lt;/Text&gt;&#10;            &lt;Text style={{ width: '258px', fontSize: 18, color: '#1A2230' }}&gt;簇级回环 + 图传播&lt;/Text&gt;&#10;            &lt;Text style={{ flex: 2.2, fontSize: 18, color: '#1A2230' }}&gt;跳数 = 加权图距 &amp;gt; 10 触发；T_Δ = T_a^opt(T_a^init)^-1&lt;/Text&gt;&#10;            &lt;Text style={{ flex: 2.4, fontSize: 18, color: '#1A2230' }}&gt;两簇各扩 N/2 帧焊接，得 Sim(3) 后沿主干摊回&lt;/Text&gt;&#10;        &lt;/Box&gt;&#10;        &lt;Box style={{ flexDirection: 'row', alignItems: 'center', minHeight: 58, padding: '10px 14px', backgroundColor: '#F7F9FC' }}&gt;&#10;            &lt;Text style={{ width: '44px', fontSize: 18, fontWeight: 'bold', color: '#1E4FA8' }}&gt;⑦&lt;/Text&gt;&#10;            &lt;Text style={{ width: '258px', fontSize: 18, color: '#1A2230' }}&gt;分块深度对齐 + 渐进层级&lt;/Text&gt;&#10;            &lt;Text style={{ flex: 2.2, fontSize: 18, color: '#1A2230' }}&gt;size &amp;lt; τ_l 且可并数 &amp;gt; max(10%, 20 万) → kNN 加权合并&lt;/Text&gt;&#10;            &lt;Text style={{ flex: 2.4, fontSize: 18, color: '#1A2230' }}&gt;位姿定后才投放高斯；层级只压显存，不改位姿&lt;/Text&gt;&#10;        &lt;/Box&gt;&#10;    &lt;/Box&gt;&#10;&#10;    &lt;Box style={{ padding: '12px 40px 0px 40px' }}&gt;&#10;        &lt;Text style={{ fontSize: 16, color: '#8B97A8', lineHeight: 1.45 }}&gt;加粗行是位姿求解本身，第 ⑥ 步会对已求出的位姿再整体修正一次。符号：u 像素观测、π 投影、ρ 鲁棒核、T 相机位姿、X 路标点。&lt;/Text&gt;&#10;        &lt;Text style={{ fontSize: 16, color: '#8B97A8', lineHeight: 1.45, marginTop: 3 }}&gt;① 的 VPR 论文写 MixVPR，开源代码因许可原因换为 MegaLoc；τ_m = 500，τ_l = 0.5 px，N = 20，K = 20。&lt;/Text&gt;&#10;    &lt;/Box&gt;&#10;&lt;/Slide&gt;&#10;"/>
         <p:cNvGrpSpPr/>
         <p:nvPr/>
       </p:nvGrpSpPr>
@@ -17644,7 +16396,7 @@
       </p:grpSpPr>
       <p:sp>
         <p:nvSpPr>
-          <p:cNvPr id="363" name=""/>
+          <p:cNvPr id="335" name=""/>
           <p:cNvSpPr/>
           <p:nvPr/>
         </p:nvSpPr>
@@ -17668,7 +16420,7 @@
       </p:sp>
       <p:sp>
         <p:nvSpPr>
-          <p:cNvPr id="364" name=""/>
+          <p:cNvPr id="336" name=""/>
           <p:cNvSpPr/>
           <p:nvPr/>
         </p:nvSpPr>
@@ -17692,7 +16444,7 @@
       </p:sp>
       <p:sp>
         <p:nvSpPr>
-          <p:cNvPr id="365" name="" descr="{&quot;isTemplate&quot;:true,&quot;type&quot;:&quot;text&quot;}"/>
+          <p:cNvPr id="337" name="" descr="{&quot;isTemplate&quot;:true,&quot;type&quot;:&quot;text&quot;}"/>
           <p:cNvSpPr txBox="1"/>
           <p:nvPr/>
         </p:nvSpPr>
@@ -17727,7 +16479,7 @@
       </p:sp>
       <p:sp>
         <p:nvSpPr>
-          <p:cNvPr id="366" name="" descr="{&quot;isTemplate&quot;:true,&quot;type&quot;:&quot;text&quot;}"/>
+          <p:cNvPr id="338" name="" descr="{&quot;isTemplate&quot;:true,&quot;type&quot;:&quot;text&quot;}"/>
           <p:cNvSpPr txBox="1"/>
           <p:nvPr/>
         </p:nvSpPr>
@@ -17762,7 +16514,7 @@
       </p:sp>
       <p:sp>
         <p:nvSpPr>
-          <p:cNvPr id="367" name="" descr="{&quot;isTemplate&quot;:true,&quot;type&quot;:&quot;text&quot;}"/>
+          <p:cNvPr id="339" name="" descr="{&quot;isTemplate&quot;:true,&quot;type&quot;:&quot;text&quot;}"/>
           <p:cNvSpPr txBox="1"/>
           <p:nvPr/>
         </p:nvSpPr>
@@ -17907,7 +16659,7 @@
       </p:sp>
       <p:sp>
         <p:nvSpPr>
-          <p:cNvPr id="368" name=""/>
+          <p:cNvPr id="340" name=""/>
           <p:cNvSpPr/>
           <p:nvPr/>
         </p:nvSpPr>
@@ -17933,7 +16685,7 @@
       </p:sp>
       <p:sp>
         <p:nvSpPr>
-          <p:cNvPr id="369" name="" descr="{&quot;isTemplate&quot;:true,&quot;type&quot;:&quot;text&quot;}"/>
+          <p:cNvPr id="341" name="" descr="{&quot;isTemplate&quot;:true,&quot;type&quot;:&quot;text&quot;}"/>
           <p:cNvSpPr txBox="1"/>
           <p:nvPr/>
         </p:nvSpPr>
@@ -17978,7 +16730,7 @@
       </p:sp>
       <p:sp>
         <p:nvSpPr>
-          <p:cNvPr id="370" name=""/>
+          <p:cNvPr id="342" name=""/>
           <p:cNvSpPr/>
           <p:nvPr/>
         </p:nvSpPr>
@@ -18004,7 +16756,7 @@
       </p:sp>
       <p:sp>
         <p:nvSpPr>
-          <p:cNvPr id="371" name="" descr="{&quot;isTemplate&quot;:true,&quot;type&quot;:&quot;text&quot;}"/>
+          <p:cNvPr id="343" name="" descr="{&quot;isTemplate&quot;:true,&quot;type&quot;:&quot;text&quot;}"/>
           <p:cNvSpPr txBox="1"/>
           <p:nvPr/>
         </p:nvSpPr>
@@ -18049,7 +16801,7 @@
       </p:sp>
       <p:sp>
         <p:nvSpPr>
-          <p:cNvPr id="372" name=""/>
+          <p:cNvPr id="344" name=""/>
           <p:cNvSpPr/>
           <p:nvPr/>
         </p:nvSpPr>
@@ -18075,7 +16827,7 @@
       </p:sp>
       <p:sp>
         <p:nvSpPr>
-          <p:cNvPr id="373" name="" descr="{&quot;isTemplate&quot;:true,&quot;type&quot;:&quot;text&quot;}"/>
+          <p:cNvPr id="345" name="" descr="{&quot;isTemplate&quot;:true,&quot;type&quot;:&quot;text&quot;}"/>
           <p:cNvSpPr txBox="1"/>
           <p:nvPr/>
         </p:nvSpPr>
@@ -18120,7 +16872,7 @@
       </p:sp>
       <p:sp>
         <p:nvSpPr>
-          <p:cNvPr id="374" name=""/>
+          <p:cNvPr id="346" name=""/>
           <p:cNvSpPr/>
           <p:nvPr/>
         </p:nvSpPr>
@@ -18146,7 +16898,7 @@
       </p:sp>
       <p:sp>
         <p:nvSpPr>
-          <p:cNvPr id="375" name="" descr="{&quot;isTemplate&quot;:true,&quot;type&quot;:&quot;text&quot;}"/>
+          <p:cNvPr id="347" name="" descr="{&quot;isTemplate&quot;:true,&quot;type&quot;:&quot;text&quot;}"/>
           <p:cNvSpPr txBox="1"/>
           <p:nvPr/>
         </p:nvSpPr>
@@ -18191,7 +16943,7 @@
       </p:sp>
       <p:sp>
         <p:nvSpPr>
-          <p:cNvPr id="376" name=""/>
+          <p:cNvPr id="348" name=""/>
           <p:cNvSpPr/>
           <p:nvPr/>
         </p:nvSpPr>
@@ -18217,7 +16969,7 @@
       </p:sp>
       <p:sp>
         <p:nvSpPr>
-          <p:cNvPr id="377" name="" descr="{&quot;isTemplate&quot;:true,&quot;type&quot;:&quot;text&quot;}"/>
+          <p:cNvPr id="349" name="" descr="{&quot;isTemplate&quot;:true,&quot;type&quot;:&quot;text&quot;}"/>
           <p:cNvSpPr txBox="1"/>
           <p:nvPr/>
         </p:nvSpPr>
@@ -18272,7 +17024,7 @@
       </p:sp>
       <p:sp>
         <p:nvSpPr>
-          <p:cNvPr id="378" name=""/>
+          <p:cNvPr id="350" name=""/>
           <p:cNvSpPr/>
           <p:nvPr/>
         </p:nvSpPr>
@@ -18298,7 +17050,7 @@
       </p:sp>
       <p:sp>
         <p:nvSpPr>
-          <p:cNvPr id="379" name="" descr="{&quot;isTemplate&quot;:true,&quot;type&quot;:&quot;text&quot;}"/>
+          <p:cNvPr id="351" name="" descr="{&quot;isTemplate&quot;:true,&quot;type&quot;:&quot;text&quot;}"/>
           <p:cNvSpPr txBox="1"/>
           <p:nvPr/>
         </p:nvSpPr>
@@ -18343,7 +17095,7 @@
       </p:sp>
       <p:sp>
         <p:nvSpPr>
-          <p:cNvPr id="380" name=""/>
+          <p:cNvPr id="352" name=""/>
           <p:cNvSpPr/>
           <p:nvPr/>
         </p:nvSpPr>
@@ -18369,7 +17121,7 @@
       </p:sp>
       <p:sp>
         <p:nvSpPr>
-          <p:cNvPr id="381" name="" descr="{&quot;isTemplate&quot;:true,&quot;type&quot;:&quot;text&quot;}"/>
+          <p:cNvPr id="353" name="" descr="{&quot;isTemplate&quot;:true,&quot;type&quot;:&quot;text&quot;}"/>
           <p:cNvSpPr txBox="1"/>
           <p:nvPr/>
         </p:nvSpPr>
@@ -18414,7 +17166,7 @@
       </p:sp>
       <p:sp>
         <p:nvSpPr>
-          <p:cNvPr id="382" name=""/>
+          <p:cNvPr id="354" name=""/>
           <p:cNvSpPr/>
           <p:nvPr/>
         </p:nvSpPr>
@@ -18438,7 +17190,7 @@
       </p:sp>
       <p:sp>
         <p:nvSpPr>
-          <p:cNvPr id="383" name="" descr="{&quot;isTemplate&quot;:true,&quot;type&quot;:&quot;text&quot;}"/>
+          <p:cNvPr id="355" name="" descr="{&quot;isTemplate&quot;:true,&quot;type&quot;:&quot;text&quot;}"/>
           <p:cNvSpPr txBox="1"/>
           <p:nvPr/>
         </p:nvSpPr>
@@ -18473,7 +17225,7 @@
       </p:sp>
       <p:sp>
         <p:nvSpPr>
-          <p:cNvPr id="384" name="" descr="{&quot;isTemplate&quot;:true,&quot;type&quot;:&quot;text&quot;}"/>
+          <p:cNvPr id="356" name="" descr="{&quot;isTemplate&quot;:true,&quot;type&quot;:&quot;text&quot;}"/>
           <p:cNvSpPr txBox="1"/>
           <p:nvPr/>
         </p:nvSpPr>
@@ -18508,7 +17260,7 @@
       </p:sp>
       <p:sp>
         <p:nvSpPr>
-          <p:cNvPr id="385" name="" descr="{&quot;isTemplate&quot;:true,&quot;type&quot;:&quot;text&quot;}"/>
+          <p:cNvPr id="357" name="" descr="{&quot;isTemplate&quot;:true,&quot;type&quot;:&quot;text&quot;}"/>
           <p:cNvSpPr txBox="1"/>
           <p:nvPr/>
         </p:nvSpPr>
@@ -18563,7 +17315,7 @@
       </p:sp>
       <p:sp>
         <p:nvSpPr>
-          <p:cNvPr id="386" name="" descr="{&quot;isTemplate&quot;:true,&quot;type&quot;:&quot;text&quot;}"/>
+          <p:cNvPr id="358" name="" descr="{&quot;isTemplate&quot;:true,&quot;type&quot;:&quot;text&quot;}"/>
           <p:cNvSpPr txBox="1"/>
           <p:nvPr/>
         </p:nvSpPr>
@@ -18598,7 +17350,7 @@
       </p:sp>
       <p:sp>
         <p:nvSpPr>
-          <p:cNvPr id="387" name=""/>
+          <p:cNvPr id="359" name=""/>
           <p:cNvSpPr/>
           <p:nvPr/>
         </p:nvSpPr>
@@ -18638,7 +17390,7 @@
       </p:sp>
       <p:sp>
         <p:nvSpPr>
-          <p:cNvPr id="388" name="" descr="{&quot;isTemplate&quot;:true,&quot;type&quot;:&quot;text&quot;}"/>
+          <p:cNvPr id="360" name="" descr="{&quot;isTemplate&quot;:true,&quot;type&quot;:&quot;text&quot;}"/>
           <p:cNvSpPr txBox="1"/>
           <p:nvPr/>
         </p:nvSpPr>
@@ -18673,7 +17425,7 @@
       </p:sp>
       <p:sp>
         <p:nvSpPr>
-          <p:cNvPr id="389" name="" descr="{&quot;isTemplate&quot;:true,&quot;type&quot;:&quot;text&quot;}"/>
+          <p:cNvPr id="361" name="" descr="{&quot;isTemplate&quot;:true,&quot;type&quot;:&quot;text&quot;}"/>
           <p:cNvSpPr txBox="1"/>
           <p:nvPr/>
         </p:nvSpPr>
@@ -18718,7 +17470,7 @@
       </p:sp>
       <p:sp>
         <p:nvSpPr>
-          <p:cNvPr id="390" name="" descr="{&quot;isTemplate&quot;:true,&quot;type&quot;:&quot;text&quot;}"/>
+          <p:cNvPr id="362" name="" descr="{&quot;isTemplate&quot;:true,&quot;type&quot;:&quot;text&quot;}"/>
           <p:cNvSpPr txBox="1"/>
           <p:nvPr/>
         </p:nvSpPr>
@@ -18773,7 +17525,7 @@
       </p:sp>
       <p:sp>
         <p:nvSpPr>
-          <p:cNvPr id="391" name="" descr="{&quot;isTemplate&quot;:true,&quot;type&quot;:&quot;text&quot;}"/>
+          <p:cNvPr id="363" name="" descr="{&quot;isTemplate&quot;:true,&quot;type&quot;:&quot;text&quot;}"/>
           <p:cNvSpPr txBox="1"/>
           <p:nvPr/>
         </p:nvSpPr>
@@ -18848,7 +17600,7 @@
       </p:sp>
       <p:sp>
         <p:nvSpPr>
-          <p:cNvPr id="392" name=""/>
+          <p:cNvPr id="364" name=""/>
           <p:cNvSpPr/>
           <p:nvPr/>
         </p:nvSpPr>
@@ -18872,7 +17624,7 @@
       </p:sp>
       <p:sp>
         <p:nvSpPr>
-          <p:cNvPr id="393" name=""/>
+          <p:cNvPr id="365" name=""/>
           <p:cNvSpPr/>
           <p:nvPr/>
         </p:nvSpPr>
@@ -18912,7 +17664,7 @@
       </p:sp>
       <p:sp>
         <p:nvSpPr>
-          <p:cNvPr id="394" name="" descr="{&quot;isTemplate&quot;:true,&quot;type&quot;:&quot;text&quot;}"/>
+          <p:cNvPr id="366" name="" descr="{&quot;isTemplate&quot;:true,&quot;type&quot;:&quot;text&quot;}"/>
           <p:cNvSpPr txBox="1"/>
           <p:nvPr/>
         </p:nvSpPr>
@@ -18947,7 +17699,7 @@
       </p:sp>
       <p:sp>
         <p:nvSpPr>
-          <p:cNvPr id="395" name="" descr="{&quot;isTemplate&quot;:true,&quot;type&quot;:&quot;text&quot;}"/>
+          <p:cNvPr id="367" name="" descr="{&quot;isTemplate&quot;:true,&quot;type&quot;:&quot;text&quot;}"/>
           <p:cNvSpPr txBox="1"/>
           <p:nvPr/>
         </p:nvSpPr>
@@ -18992,7 +17744,7 @@
       </p:sp>
       <p:sp>
         <p:nvSpPr>
-          <p:cNvPr id="396" name="" descr="{&quot;isTemplate&quot;:true,&quot;type&quot;:&quot;text&quot;}"/>
+          <p:cNvPr id="368" name="" descr="{&quot;isTemplate&quot;:true,&quot;type&quot;:&quot;text&quot;}"/>
           <p:cNvSpPr txBox="1"/>
           <p:nvPr/>
         </p:nvSpPr>
@@ -19037,7 +17789,7 @@
       </p:sp>
       <p:sp>
         <p:nvSpPr>
-          <p:cNvPr id="397" name="" descr="{&quot;isTemplate&quot;:true,&quot;type&quot;:&quot;text&quot;}"/>
+          <p:cNvPr id="369" name="" descr="{&quot;isTemplate&quot;:true,&quot;type&quot;:&quot;text&quot;}"/>
           <p:cNvSpPr txBox="1"/>
           <p:nvPr/>
         </p:nvSpPr>
@@ -19112,7 +17864,7 @@
       </p:sp>
       <p:sp>
         <p:nvSpPr>
-          <p:cNvPr id="398" name=""/>
+          <p:cNvPr id="370" name=""/>
           <p:cNvSpPr/>
           <p:nvPr/>
         </p:nvSpPr>
@@ -19152,7 +17904,7 @@
       </p:sp>
       <p:sp>
         <p:nvSpPr>
-          <p:cNvPr id="399" name="" descr="{&quot;isTemplate&quot;:true,&quot;type&quot;:&quot;text&quot;}"/>
+          <p:cNvPr id="371" name="" descr="{&quot;isTemplate&quot;:true,&quot;type&quot;:&quot;text&quot;}"/>
           <p:cNvSpPr txBox="1"/>
           <p:nvPr/>
         </p:nvSpPr>
@@ -19187,7 +17939,7 @@
       </p:sp>
       <p:sp>
         <p:nvSpPr>
-          <p:cNvPr id="400" name="" descr="{&quot;isTemplate&quot;:true,&quot;type&quot;:&quot;text&quot;}"/>
+          <p:cNvPr id="372" name="" descr="{&quot;isTemplate&quot;:true,&quot;type&quot;:&quot;text&quot;}"/>
           <p:cNvSpPr txBox="1"/>
           <p:nvPr/>
         </p:nvSpPr>
@@ -19222,7 +17974,7 @@
       </p:sp>
       <p:sp>
         <p:nvSpPr>
-          <p:cNvPr id="401" name="" descr="{&quot;isTemplate&quot;:true,&quot;type&quot;:&quot;text&quot;}"/>
+          <p:cNvPr id="373" name="" descr="{&quot;isTemplate&quot;:true,&quot;type&quot;:&quot;text&quot;}"/>
           <p:cNvSpPr txBox="1"/>
           <p:nvPr/>
         </p:nvSpPr>
@@ -19277,7 +18029,7 @@
       </p:sp>
       <p:sp>
         <p:nvSpPr>
-          <p:cNvPr id="402" name="" descr="{&quot;isTemplate&quot;:true,&quot;type&quot;:&quot;text&quot;}"/>
+          <p:cNvPr id="374" name="" descr="{&quot;isTemplate&quot;:true,&quot;type&quot;:&quot;text&quot;}"/>
           <p:cNvSpPr txBox="1"/>
           <p:nvPr/>
         </p:nvSpPr>
@@ -19312,7 +18064,7 @@
       </p:sp>
       <p:sp>
         <p:nvSpPr>
-          <p:cNvPr id="403" name=""/>
+          <p:cNvPr id="375" name=""/>
           <p:cNvSpPr/>
           <p:nvPr/>
         </p:nvSpPr>
@@ -19336,7 +18088,7 @@
       </p:sp>
       <p:sp>
         <p:nvSpPr>
-          <p:cNvPr id="404" name=""/>
+          <p:cNvPr id="376" name=""/>
           <p:cNvSpPr/>
           <p:nvPr/>
         </p:nvSpPr>
@@ -19376,7 +18128,7 @@
       </p:sp>
       <p:sp>
         <p:nvSpPr>
-          <p:cNvPr id="405" name="" descr="{&quot;isTemplate&quot;:true,&quot;type&quot;:&quot;text&quot;}"/>
+          <p:cNvPr id="377" name="" descr="{&quot;isTemplate&quot;:true,&quot;type&quot;:&quot;text&quot;}"/>
           <p:cNvSpPr txBox="1"/>
           <p:nvPr/>
         </p:nvSpPr>
@@ -19411,7 +18163,7 @@
       </p:sp>
       <p:sp>
         <p:nvSpPr>
-          <p:cNvPr id="406" name="" descr="{&quot;isTemplate&quot;:true,&quot;type&quot;:&quot;text&quot;}"/>
+          <p:cNvPr id="378" name="" descr="{&quot;isTemplate&quot;:true,&quot;type&quot;:&quot;text&quot;}"/>
           <p:cNvSpPr txBox="1"/>
           <p:nvPr/>
         </p:nvSpPr>
@@ -19466,7 +18218,7 @@
       </p:sp>
       <p:sp>
         <p:nvSpPr>
-          <p:cNvPr id="407" name="" descr="{&quot;isTemplate&quot;:true,&quot;type&quot;:&quot;text&quot;}"/>
+          <p:cNvPr id="379" name="" descr="{&quot;isTemplate&quot;:true,&quot;type&quot;:&quot;text&quot;}"/>
           <p:cNvSpPr txBox="1"/>
           <p:nvPr/>
         </p:nvSpPr>
@@ -19531,7 +18283,7 @@
       </p:sp>
       <p:sp>
         <p:nvSpPr>
-          <p:cNvPr id="408" name="" descr="{&quot;isTemplate&quot;:true,&quot;type&quot;:&quot;text&quot;}"/>
+          <p:cNvPr id="380" name="" descr="{&quot;isTemplate&quot;:true,&quot;type&quot;:&quot;text&quot;}"/>
           <p:cNvSpPr txBox="1"/>
           <p:nvPr/>
         </p:nvSpPr>
@@ -19606,7 +18358,7 @@
       </p:sp>
       <p:sp>
         <p:nvSpPr>
-          <p:cNvPr id="409" name=""/>
+          <p:cNvPr id="381" name=""/>
           <p:cNvSpPr/>
           <p:nvPr/>
         </p:nvSpPr>
@@ -19630,7 +18382,7 @@
       </p:sp>
       <p:sp>
         <p:nvSpPr>
-          <p:cNvPr id="410" name=""/>
+          <p:cNvPr id="382" name=""/>
           <p:cNvSpPr/>
           <p:nvPr/>
         </p:nvSpPr>
@@ -19670,7 +18422,7 @@
       </p:sp>
       <p:sp>
         <p:nvSpPr>
-          <p:cNvPr id="411" name=""/>
+          <p:cNvPr id="383" name=""/>
           <p:cNvSpPr/>
           <p:nvPr/>
         </p:nvSpPr>
@@ -19710,7 +18462,7 @@
       </p:sp>
       <p:sp>
         <p:nvSpPr>
-          <p:cNvPr id="412" name="" descr="{&quot;isTemplate&quot;:true,&quot;type&quot;:&quot;text&quot;}"/>
+          <p:cNvPr id="384" name="" descr="{&quot;isTemplate&quot;:true,&quot;type&quot;:&quot;text&quot;}"/>
           <p:cNvSpPr txBox="1"/>
           <p:nvPr/>
         </p:nvSpPr>
@@ -19745,7 +18497,7 @@
       </p:sp>
       <p:sp>
         <p:nvSpPr>
-          <p:cNvPr id="413" name="" descr="{&quot;isTemplate&quot;:true,&quot;type&quot;:&quot;text&quot;}"/>
+          <p:cNvPr id="385" name="" descr="{&quot;isTemplate&quot;:true,&quot;type&quot;:&quot;text&quot;}"/>
           <p:cNvSpPr txBox="1"/>
           <p:nvPr/>
         </p:nvSpPr>
@@ -19830,7 +18582,7 @@
       </p:sp>
       <p:sp>
         <p:nvSpPr>
-          <p:cNvPr id="414" name="" descr="{&quot;isTemplate&quot;:true,&quot;type&quot;:&quot;text&quot;}"/>
+          <p:cNvPr id="386" name="" descr="{&quot;isTemplate&quot;:true,&quot;type&quot;:&quot;text&quot;}"/>
           <p:cNvSpPr txBox="1"/>
           <p:nvPr/>
         </p:nvSpPr>
@@ -19865,7 +18617,7 @@
       </p:sp>
       <p:sp>
         <p:nvSpPr>
-          <p:cNvPr id="415" name="" descr="{&quot;isTemplate&quot;:true,&quot;type&quot;:&quot;text&quot;}"/>
+          <p:cNvPr id="387" name="" descr="{&quot;isTemplate&quot;:true,&quot;type&quot;:&quot;text&quot;}"/>
           <p:cNvSpPr txBox="1"/>
           <p:nvPr/>
         </p:nvSpPr>
@@ -19940,7 +18692,7 @@
       </p:sp>
       <p:sp>
         <p:nvSpPr>
-          <p:cNvPr id="416" name=""/>
+          <p:cNvPr id="388" name=""/>
           <p:cNvSpPr/>
           <p:nvPr/>
         </p:nvSpPr>
@@ -19980,7 +18732,7 @@
       </p:sp>
       <p:sp>
         <p:nvSpPr>
-          <p:cNvPr id="417" name="" descr="{&quot;isTemplate&quot;:true,&quot;type&quot;:&quot;text&quot;}"/>
+          <p:cNvPr id="389" name="" descr="{&quot;isTemplate&quot;:true,&quot;type&quot;:&quot;text&quot;}"/>
           <p:cNvSpPr txBox="1"/>
           <p:nvPr/>
         </p:nvSpPr>
@@ -20015,7 +18767,7 @@
       </p:sp>
       <p:sp>
         <p:nvSpPr>
-          <p:cNvPr id="418" name="" descr="{&quot;isTemplate&quot;:true,&quot;type&quot;:&quot;text&quot;}"/>
+          <p:cNvPr id="390" name="" descr="{&quot;isTemplate&quot;:true,&quot;type&quot;:&quot;text&quot;}"/>
           <p:cNvSpPr txBox="1"/>
           <p:nvPr/>
         </p:nvSpPr>
@@ -20070,7 +18822,7 @@
       </p:sp>
       <p:sp>
         <p:nvSpPr>
-          <p:cNvPr id="419" name="" descr="{&quot;isTemplate&quot;:true,&quot;type&quot;:&quot;text&quot;}"/>
+          <p:cNvPr id="391" name="" descr="{&quot;isTemplate&quot;:true,&quot;type&quot;:&quot;text&quot;}"/>
           <p:cNvSpPr txBox="1"/>
           <p:nvPr/>
         </p:nvSpPr>
@@ -20157,7 +18909,7 @@
       </p:sp>
       <p:sp>
         <p:nvSpPr>
-          <p:cNvPr id="420" name="" descr="{&quot;isTemplate&quot;:true,&quot;type&quot;:&quot;text&quot;}"/>
+          <p:cNvPr id="392" name="" descr="{&quot;isTemplate&quot;:true,&quot;type&quot;:&quot;text&quot;}"/>
           <p:cNvSpPr txBox="1"/>
           <p:nvPr/>
         </p:nvSpPr>
@@ -20232,7 +18984,7 @@
       </p:sp>
       <p:sp>
         <p:nvSpPr>
-          <p:cNvPr id="421" name=""/>
+          <p:cNvPr id="393" name=""/>
           <p:cNvSpPr/>
           <p:nvPr/>
         </p:nvSpPr>
@@ -20256,7 +19008,7 @@
       </p:sp>
       <p:sp>
         <p:nvSpPr>
-          <p:cNvPr id="422" name="" descr="{&quot;isTemplate&quot;:true,&quot;type&quot;:&quot;text&quot;}"/>
+          <p:cNvPr id="394" name="" descr="{&quot;isTemplate&quot;:true,&quot;type&quot;:&quot;text&quot;}"/>
           <p:cNvSpPr txBox="1"/>
           <p:nvPr/>
         </p:nvSpPr>
@@ -20291,7 +19043,7 @@
       </p:sp>
       <p:sp>
         <p:nvSpPr>
-          <p:cNvPr id="423" name="" descr="{&quot;isTemplate&quot;:true,&quot;type&quot;:&quot;text&quot;}"/>
+          <p:cNvPr id="395" name="" descr="{&quot;isTemplate&quot;:true,&quot;type&quot;:&quot;text&quot;}"/>
           <p:cNvSpPr txBox="1"/>
           <p:nvPr/>
         </p:nvSpPr>
@@ -20346,7 +19098,7 @@
       </p:sp>
       <p:sp>
         <p:nvSpPr>
-          <p:cNvPr id="424" name="" descr="{&quot;isTemplate&quot;:true,&quot;type&quot;:&quot;text&quot;}"/>
+          <p:cNvPr id="396" name="" descr="{&quot;isTemplate&quot;:true,&quot;type&quot;:&quot;text&quot;}"/>
           <p:cNvSpPr txBox="1"/>
           <p:nvPr/>
         </p:nvSpPr>
@@ -20433,7 +19185,7 @@
       </p:sp>
       <p:sp>
         <p:nvSpPr>
-          <p:cNvPr id="425" name="" descr="{&quot;isTemplate&quot;:true,&quot;type&quot;:&quot;text&quot;}"/>
+          <p:cNvPr id="397" name="" descr="{&quot;isTemplate&quot;:true,&quot;type&quot;:&quot;text&quot;}"/>
           <p:cNvSpPr txBox="1"/>
           <p:nvPr/>
         </p:nvSpPr>
@@ -20468,7 +19220,7 @@
       </p:sp>
       <p:sp>
         <p:nvSpPr>
-          <p:cNvPr id="426" name="" descr="{&quot;isTemplate&quot;:true,&quot;type&quot;:&quot;text&quot;}"/>
+          <p:cNvPr id="398" name="" descr="{&quot;isTemplate&quot;:true,&quot;type&quot;:&quot;text&quot;}"/>
           <p:cNvSpPr txBox="1"/>
           <p:nvPr/>
         </p:nvSpPr>
@@ -20623,7 +19375,7 @@
       </p:sp>
       <p:sp>
         <p:nvSpPr>
-          <p:cNvPr id="427" name="" descr="{&quot;isTemplate&quot;:true,&quot;type&quot;:&quot;text&quot;}"/>
+          <p:cNvPr id="399" name="" descr="{&quot;isTemplate&quot;:true,&quot;type&quot;:&quot;text&quot;}"/>
           <p:cNvSpPr txBox="1"/>
           <p:nvPr/>
         </p:nvSpPr>
@@ -20816,7 +19568,7 @@
   <p:cSld>
     <p:spTree>
       <p:nvGrpSpPr>
-        <p:cNvPr id="428" name="" descr="&lt;Slide style={{ width: '1280px', height: '720px', backgroundColor: '#FFFFFF', padding: '0px', flexDirection: 'column' }}&gt;&#10;    &lt;Box style={{ width: '1280px', height: '8px', backgroundColor: '#1E4FA8' }} /&gt;&#10;    &lt;Box style={{ padding: '30px 40px 0px 40px', flexDirection: 'row', justifyContent: 'space-between', alignItems: 'flex-end' }}&gt;&#10;        &lt;Text style={{ fontSize: 34, fontWeight: 'bold', color: '#1E4FA8' }}&gt;关键方式①：两级匹配 + 加权协视图&lt;/Text&gt;&#10;        &lt;Text style={{ fontSize: 15, color: '#8B97A8' }}&gt;08 / 15&lt;/Text&gt;&#10;    &lt;/Box&gt;&#10;    &lt;Box style={{ padding: '18px 40px 0px 40px', flexDirection: 'column', gap: 0 }}&gt;&#10;        &lt;Box style={{ flexDirection: 'row', backgroundColor: '#1E4FA8', padding: '12px 16px' }}&gt;&#10;            &lt;Text style={{ width: '90px', fontSize: 20, fontWeight: 'bold', color: '#FFFFFF' }}&gt;层级&lt;/Text&gt;&#10;            &lt;Text style={{ flex: 2, fontSize: 20, fontWeight: 'bold', color: '#FFFFFF' }}&gt;方法&lt;/Text&gt;&#10;            &lt;Text style={{ flex: 3, fontSize: 20, fontWeight: 'bold', color: '#FFFFFF' }}&gt;作用&lt;/Text&gt;&#10;            &lt;Text style={{ flex: 1.6, fontSize: 20, fontWeight: 'bold', color: '#FFFFFF' }}&gt;代价&lt;/Text&gt;&#10;        &lt;/Box&gt;&#10;        &lt;Box style={{ flexDirection: 'row', padding: '13px 16px', borderBottom: '1px solid #D6DCE5' }}&gt;&#10;            &lt;Text style={{ width: '90px', fontSize: 20, fontWeight: 'bold', color: '#1E4FA8' }}&gt;1&lt;/Text&gt;&#10;            &lt;Text style={{ flex: 2, fontSize: 20, color: '#1A2230' }}&gt;视觉位置识别（全局描述子）&lt;/Text&gt;&#10;            &lt;Text style={{ flex: 3, fontSize: 20, color: '#1A2230' }}&gt;余弦相似度排序，取 top-20 候选&lt;/Text&gt;&#10;            &lt;Text style={{ flex: 1.6, fontSize: 20, color: '#1A2230' }}&gt;≈1 ms / 1000 对&lt;/Text&gt;&#10;        &lt;/Box&gt;&#10;        &lt;Box style={{ flexDirection: 'row', padding: '13px 16px', backgroundColor: '#F7F9FC', borderBottom: '1px solid #D6DCE5' }}&gt;&#10;            &lt;Text style={{ width: '90px', fontSize: 20, fontWeight: 'bold', color: '#1E4FA8' }}&gt;2&lt;/Text&gt;&#10;            &lt;Text style={{ flex: 2, fontSize: 20, color: '#1A2230' }}&gt;XFeat 轻量局部特征&lt;/Text&gt;&#10;            &lt;Text style={{ flex: 3, fontSize: 20, color: '#1A2230' }}&gt;按内点数从 20 中保留 5 个&lt;/Text&gt;&#10;            &lt;Text style={{ flex: 1.6, fontSize: 20, color: '#1A2230' }}&gt;≈0.5 ms / 对&lt;/Text&gt;&#10;        &lt;/Box&gt;&#10;        &lt;Box style={{ flexDirection: 'row', padding: '13px 16px', borderBottom: '1px solid #D6DCE5' }}&gt;&#10;            &lt;Text style={{ width: '90px', fontSize: 20, fontWeight: 'bold', color: '#1E4FA8' }}&gt;3&lt;/Text&gt;&#10;            &lt;Text style={{ flex: 2, fontSize: 20, color: '#1A2230' }}&gt;LightGlue + RANSAC&lt;/Text&gt;&#10;            &lt;Text style={{ flex: 3, fontSize: 20, color: '#1A2230' }}&gt;精确验证，内点数 &amp;gt; 500 才接受&lt;/Text&gt;&#10;            &lt;Text style={{ flex: 1.6, fontSize: 20, color: '#1A2230' }}&gt;≈4 ms / 对&lt;/Text&gt;&#10;        &lt;/Box&gt;&#10;    &lt;/Box&gt;&#10;    &lt;Box style={{ padding: '18px 40px 0px 40px', flexDirection: 'row', gap: 18 }}&gt;&#10;        &lt;Box style={{ flex: 1, backgroundColor: '#F0F5FC', borderRadius: 6, padding: '14px 18px', flexDirection: 'column' }}&gt;&#10;            &lt;Text style={{ fontSize: 22, fontWeight: 'bold', color: '#1E4FA8' }}&gt;加权协视图&lt;/Text&gt;&#10;            &lt;Text style={{ fontSize: 21, color: '#1A2230', lineHeight: 1.5, marginTop: 8 }}&gt;边权取内点数倒数 w = 1/#inliers：内点越多、边越&quot;短&quot;。于是图上的最短路 = 最可靠的位姿链。&lt;/Text&gt;&#10;        &lt;/Box&gt;&#10;        &lt;Box style={{ flex: 1, backgroundColor: '#F0F5FC', borderRadius: 6, padding: '14px 18px', flexDirection: 'column' }}&gt;&#10;            &lt;Text style={{ fontSize: 22, fontWeight: 'bold', color: '#1E4FA8' }}&gt;消融：这一环最关键&lt;/Text&gt;&#10;            &lt;Text style={{ fontSize: 21, color: '#1A2230', lineHeight: 1.5, marginTop: 8 }}&gt;去掉位置识别只比相邻 5 帧：PSNR 26.29 → &lt;b&gt;24.78 dB&lt;/b&gt;；改成优化最后 20 帧：→ &lt;b&gt;24.56 dB&lt;/b&gt;。&lt;/Text&gt;&#10;        &lt;/Box&gt;&#10;    &lt;/Box&gt;&#10;    &lt;Box style={{ padding: '12px 40px 0px 40px' }}&gt;&#10;        &lt;Text style={{ fontSize: 17, color: '#8B97A8' }}&gt;候选集逐级收缩：1000 对 → 20 → 5 → 1，精确匹配只作用在极小候选上，这是&quot;无序也能快&quot;的根本原因。&lt;/Text&gt;&#10;    &lt;/Box&gt;&#10;&lt;/Slide&gt;&#10;"/>
+        <p:cNvPr id="400" name="" descr="&lt;Slide style={{ width: '1280px', height: '720px', backgroundColor: '#FFFFFF', padding: '0px', flexDirection: 'column' }}&gt;&#10;    &lt;Box style={{ width: '1280px', height: '8px', backgroundColor: '#1E4FA8' }} /&gt;&#10;    &lt;Box style={{ padding: '30px 40px 0px 40px', flexDirection: 'row', justifyContent: 'space-between', alignItems: 'flex-end' }}&gt;&#10;        &lt;Text style={{ fontSize: 34, fontWeight: 'bold', color: '#1E4FA8' }}&gt;关键方式①：两级匹配 + 加权协视图&lt;/Text&gt;&#10;        &lt;Text style={{ fontSize: 15, color: '#8B97A8' }}&gt;08 / 15&lt;/Text&gt;&#10;    &lt;/Box&gt;&#10;    &lt;Box style={{ padding: '18px 40px 0px 40px', flexDirection: 'column', gap: 0 }}&gt;&#10;        &lt;Box style={{ flexDirection: 'row', backgroundColor: '#1E4FA8', padding: '12px 16px' }}&gt;&#10;            &lt;Text style={{ width: '90px', fontSize: 20, fontWeight: 'bold', color: '#FFFFFF' }}&gt;层级&lt;/Text&gt;&#10;            &lt;Text style={{ flex: 2, fontSize: 20, fontWeight: 'bold', color: '#FFFFFF' }}&gt;方法&lt;/Text&gt;&#10;            &lt;Text style={{ flex: 3, fontSize: 20, fontWeight: 'bold', color: '#FFFFFF' }}&gt;作用&lt;/Text&gt;&#10;            &lt;Text style={{ flex: 1.6, fontSize: 20, fontWeight: 'bold', color: '#FFFFFF' }}&gt;代价&lt;/Text&gt;&#10;        &lt;/Box&gt;&#10;        &lt;Box style={{ flexDirection: 'row', padding: '13px 16px', borderBottom: '1px solid #D6DCE5' }}&gt;&#10;            &lt;Text style={{ width: '90px', fontSize: 20, fontWeight: 'bold', color: '#1E4FA8' }}&gt;1&lt;/Text&gt;&#10;            &lt;Text style={{ flex: 2, fontSize: 20, color: '#1A2230' }}&gt;视觉位置识别（全局描述子）&lt;/Text&gt;&#10;            &lt;Text style={{ flex: 3, fontSize: 20, color: '#1A2230' }}&gt;余弦相似度排序，取 top-20 候选&lt;/Text&gt;&#10;            &lt;Text style={{ flex: 1.6, fontSize: 20, color: '#1A2230' }}&gt;≈1 ms / 1000 对&lt;/Text&gt;&#10;        &lt;/Box&gt;&#10;        &lt;Box style={{ flexDirection: 'row', padding: '13px 16px', backgroundColor: '#F7F9FC', borderBottom: '1px solid #D6DCE5' }}&gt;&#10;            &lt;Text style={{ width: '90px', fontSize: 20, fontWeight: 'bold', color: '#1E4FA8' }}&gt;2&lt;/Text&gt;&#10;            &lt;Text style={{ flex: 2, fontSize: 20, color: '#1A2230' }}&gt;XFeat 轻量局部特征&lt;/Text&gt;&#10;            &lt;Text style={{ flex: 3, fontSize: 20, color: '#1A2230' }}&gt;按内点数从 20 中保留 5 个&lt;/Text&gt;&#10;            &lt;Text style={{ flex: 1.6, fontSize: 20, color: '#1A2230' }}&gt;≈0.5 ms / 对&lt;/Text&gt;&#10;        &lt;/Box&gt;&#10;        &lt;Box style={{ flexDirection: 'row', padding: '13px 16px', borderBottom: '1px solid #D6DCE5' }}&gt;&#10;            &lt;Text style={{ width: '90px', fontSize: 20, fontWeight: 'bold', color: '#1E4FA8' }}&gt;3&lt;/Text&gt;&#10;            &lt;Text style={{ flex: 2, fontSize: 20, color: '#1A2230' }}&gt;LightGlue + RANSAC&lt;/Text&gt;&#10;            &lt;Text style={{ flex: 3, fontSize: 20, color: '#1A2230' }}&gt;精确验证，内点数 &amp;gt; 500 才接受&lt;/Text&gt;&#10;            &lt;Text style={{ flex: 1.6, fontSize: 20, color: '#1A2230' }}&gt;≈4 ms / 对&lt;/Text&gt;&#10;        &lt;/Box&gt;&#10;    &lt;/Box&gt;&#10;    &lt;Box style={{ padding: '18px 40px 0px 40px', flexDirection: 'row', gap: 18 }}&gt;&#10;        &lt;Box style={{ flex: 1, backgroundColor: '#F0F5FC', borderRadius: 6, padding: '14px 18px', flexDirection: 'column' }}&gt;&#10;            &lt;Text style={{ fontSize: 22, fontWeight: 'bold', color: '#1E4FA8' }}&gt;加权协视图&lt;/Text&gt;&#10;            &lt;Text style={{ fontSize: 21, color: '#1A2230', lineHeight: 1.5, marginTop: 8 }}&gt;边权取内点数倒数 w = 1/#inliers：内点越多、边越&quot;短&quot;。于是图上的最短路 = 最可靠的位姿链。&lt;/Text&gt;&#10;        &lt;/Box&gt;&#10;        &lt;Box style={{ flex: 1, backgroundColor: '#F0F5FC', borderRadius: 6, padding: '14px 18px', flexDirection: 'column' }}&gt;&#10;            &lt;Text style={{ fontSize: 22, fontWeight: 'bold', color: '#1E4FA8' }}&gt;消融：这一环最关键&lt;/Text&gt;&#10;            &lt;Text style={{ fontSize: 21, color: '#1A2230', lineHeight: 1.5, marginTop: 8 }}&gt;去掉位置识别只比相邻 5 帧：PSNR 26.29 → &lt;b&gt;24.78 dB&lt;/b&gt;；改成优化最后 20 帧：→ &lt;b&gt;24.56 dB&lt;/b&gt;。&lt;/Text&gt;&#10;        &lt;/Box&gt;&#10;    &lt;/Box&gt;&#10;    &lt;Box style={{ padding: '12px 40px 0px 40px' }}&gt;&#10;        &lt;Text style={{ fontSize: 17, color: '#8B97A8' }}&gt;候选集逐级收缩：1000 对 → 20 → 5 → 1，精确匹配只作用在极小候选上，这是&quot;无序也能快&quot;的根本原因。&lt;/Text&gt;&#10;    &lt;/Box&gt;&#10;&lt;/Slide&gt;&#10;"/>
         <p:cNvGrpSpPr/>
         <p:nvPr/>
       </p:nvGrpSpPr>
@@ -20830,7 +19582,7 @@
       </p:grpSpPr>
       <p:sp>
         <p:nvSpPr>
-          <p:cNvPr id="429" name=""/>
+          <p:cNvPr id="401" name=""/>
           <p:cNvSpPr/>
           <p:nvPr/>
         </p:nvSpPr>
@@ -20854,7 +19606,7 @@
       </p:sp>
       <p:sp>
         <p:nvSpPr>
-          <p:cNvPr id="430" name=""/>
+          <p:cNvPr id="402" name=""/>
           <p:cNvSpPr/>
           <p:nvPr/>
         </p:nvSpPr>
@@ -20878,7 +19630,7 @@
       </p:sp>
       <p:sp>
         <p:nvSpPr>
-          <p:cNvPr id="431" name="" descr="{&quot;isTemplate&quot;:true,&quot;type&quot;:&quot;text&quot;}"/>
+          <p:cNvPr id="403" name="" descr="{&quot;isTemplate&quot;:true,&quot;type&quot;:&quot;text&quot;}"/>
           <p:cNvSpPr txBox="1"/>
           <p:nvPr/>
         </p:nvSpPr>
@@ -20933,7 +19685,7 @@
       </p:sp>
       <p:sp>
         <p:nvSpPr>
-          <p:cNvPr id="432" name="" descr="{&quot;isTemplate&quot;:true,&quot;type&quot;:&quot;text&quot;}"/>
+          <p:cNvPr id="404" name="" descr="{&quot;isTemplate&quot;:true,&quot;type&quot;:&quot;text&quot;}"/>
           <p:cNvSpPr txBox="1"/>
           <p:nvPr/>
         </p:nvSpPr>
@@ -20968,7 +19720,7 @@
       </p:sp>
       <p:sp>
         <p:nvSpPr>
-          <p:cNvPr id="433" name=""/>
+          <p:cNvPr id="405" name=""/>
           <p:cNvSpPr/>
           <p:nvPr/>
         </p:nvSpPr>
@@ -20992,7 +19744,7 @@
       </p:sp>
       <p:sp>
         <p:nvSpPr>
-          <p:cNvPr id="434" name="" descr="{&quot;isTemplate&quot;:true,&quot;type&quot;:&quot;text&quot;}"/>
+          <p:cNvPr id="406" name="" descr="{&quot;isTemplate&quot;:true,&quot;type&quot;:&quot;text&quot;}"/>
           <p:cNvSpPr txBox="1"/>
           <p:nvPr/>
         </p:nvSpPr>
@@ -21027,7 +19779,7 @@
       </p:sp>
       <p:sp>
         <p:nvSpPr>
-          <p:cNvPr id="435" name="" descr="{&quot;isTemplate&quot;:true,&quot;type&quot;:&quot;text&quot;}"/>
+          <p:cNvPr id="407" name="" descr="{&quot;isTemplate&quot;:true,&quot;type&quot;:&quot;text&quot;}"/>
           <p:cNvSpPr txBox="1"/>
           <p:nvPr/>
         </p:nvSpPr>
@@ -21062,7 +19814,7 @@
       </p:sp>
       <p:sp>
         <p:nvSpPr>
-          <p:cNvPr id="436" name="" descr="{&quot;isTemplate&quot;:true,&quot;type&quot;:&quot;text&quot;}"/>
+          <p:cNvPr id="408" name="" descr="{&quot;isTemplate&quot;:true,&quot;type&quot;:&quot;text&quot;}"/>
           <p:cNvSpPr txBox="1"/>
           <p:nvPr/>
         </p:nvSpPr>
@@ -21097,7 +19849,7 @@
       </p:sp>
       <p:sp>
         <p:nvSpPr>
-          <p:cNvPr id="437" name="" descr="{&quot;isTemplate&quot;:true,&quot;type&quot;:&quot;text&quot;}"/>
+          <p:cNvPr id="409" name="" descr="{&quot;isTemplate&quot;:true,&quot;type&quot;:&quot;text&quot;}"/>
           <p:cNvSpPr txBox="1"/>
           <p:nvPr/>
         </p:nvSpPr>
@@ -21132,7 +19884,7 @@
       </p:sp>
       <p:sp>
         <p:nvSpPr>
-          <p:cNvPr id="438" name=""/>
+          <p:cNvPr id="410" name=""/>
           <p:cNvSpPr/>
           <p:nvPr/>
         </p:nvSpPr>
@@ -21172,7 +19924,7 @@
       </p:sp>
       <p:sp>
         <p:nvSpPr>
-          <p:cNvPr id="439" name="" descr="{&quot;isTemplate&quot;:true,&quot;type&quot;:&quot;text&quot;}"/>
+          <p:cNvPr id="411" name="" descr="{&quot;isTemplate&quot;:true,&quot;type&quot;:&quot;text&quot;}"/>
           <p:cNvSpPr txBox="1"/>
           <p:nvPr/>
         </p:nvSpPr>
@@ -21207,7 +19959,7 @@
       </p:sp>
       <p:sp>
         <p:nvSpPr>
-          <p:cNvPr id="440" name="" descr="{&quot;isTemplate&quot;:true,&quot;type&quot;:&quot;text&quot;}"/>
+          <p:cNvPr id="412" name="" descr="{&quot;isTemplate&quot;:true,&quot;type&quot;:&quot;text&quot;}"/>
           <p:cNvSpPr txBox="1"/>
           <p:nvPr/>
         </p:nvSpPr>
@@ -21242,7 +19994,7 @@
       </p:sp>
       <p:sp>
         <p:nvSpPr>
-          <p:cNvPr id="441" name="" descr="{&quot;isTemplate&quot;:true,&quot;type&quot;:&quot;text&quot;}"/>
+          <p:cNvPr id="413" name="" descr="{&quot;isTemplate&quot;:true,&quot;type&quot;:&quot;text&quot;}"/>
           <p:cNvSpPr txBox="1"/>
           <p:nvPr/>
         </p:nvSpPr>
@@ -21297,7 +20049,7 @@
       </p:sp>
       <p:sp>
         <p:nvSpPr>
-          <p:cNvPr id="442" name="" descr="{&quot;isTemplate&quot;:true,&quot;type&quot;:&quot;text&quot;}"/>
+          <p:cNvPr id="414" name="" descr="{&quot;isTemplate&quot;:true,&quot;type&quot;:&quot;text&quot;}"/>
           <p:cNvSpPr txBox="1"/>
           <p:nvPr/>
         </p:nvSpPr>
@@ -21342,7 +20094,7 @@
       </p:sp>
       <p:sp>
         <p:nvSpPr>
-          <p:cNvPr id="443" name=""/>
+          <p:cNvPr id="415" name=""/>
           <p:cNvSpPr/>
           <p:nvPr/>
         </p:nvSpPr>
@@ -21366,7 +20118,7 @@
       </p:sp>
       <p:sp>
         <p:nvSpPr>
-          <p:cNvPr id="444" name=""/>
+          <p:cNvPr id="416" name=""/>
           <p:cNvSpPr/>
           <p:nvPr/>
         </p:nvSpPr>
@@ -21406,7 +20158,7 @@
       </p:sp>
       <p:sp>
         <p:nvSpPr>
-          <p:cNvPr id="445" name="" descr="{&quot;isTemplate&quot;:true,&quot;type&quot;:&quot;text&quot;}"/>
+          <p:cNvPr id="417" name="" descr="{&quot;isTemplate&quot;:true,&quot;type&quot;:&quot;text&quot;}"/>
           <p:cNvSpPr txBox="1"/>
           <p:nvPr/>
         </p:nvSpPr>
@@ -21441,7 +20193,7 @@
       </p:sp>
       <p:sp>
         <p:nvSpPr>
-          <p:cNvPr id="446" name="" descr="{&quot;isTemplate&quot;:true,&quot;type&quot;:&quot;text&quot;}"/>
+          <p:cNvPr id="418" name="" descr="{&quot;isTemplate&quot;:true,&quot;type&quot;:&quot;text&quot;}"/>
           <p:cNvSpPr txBox="1"/>
           <p:nvPr/>
         </p:nvSpPr>
@@ -21486,7 +20238,7 @@
       </p:sp>
       <p:sp>
         <p:nvSpPr>
-          <p:cNvPr id="447" name="" descr="{&quot;isTemplate&quot;:true,&quot;type&quot;:&quot;text&quot;}"/>
+          <p:cNvPr id="419" name="" descr="{&quot;isTemplate&quot;:true,&quot;type&quot;:&quot;text&quot;}"/>
           <p:cNvSpPr txBox="1"/>
           <p:nvPr/>
         </p:nvSpPr>
@@ -21561,7 +20313,7 @@
       </p:sp>
       <p:sp>
         <p:nvSpPr>
-          <p:cNvPr id="448" name="" descr="{&quot;isTemplate&quot;:true,&quot;type&quot;:&quot;text&quot;}"/>
+          <p:cNvPr id="420" name="" descr="{&quot;isTemplate&quot;:true,&quot;type&quot;:&quot;text&quot;}"/>
           <p:cNvSpPr txBox="1"/>
           <p:nvPr/>
         </p:nvSpPr>
@@ -21606,7 +20358,7 @@
       </p:sp>
       <p:sp>
         <p:nvSpPr>
-          <p:cNvPr id="449" name=""/>
+          <p:cNvPr id="421" name=""/>
           <p:cNvSpPr/>
           <p:nvPr/>
         </p:nvSpPr>
@@ -21646,7 +20398,7 @@
       </p:sp>
       <p:sp>
         <p:nvSpPr>
-          <p:cNvPr id="450" name="" descr="{&quot;isTemplate&quot;:true,&quot;type&quot;:&quot;text&quot;}"/>
+          <p:cNvPr id="422" name="" descr="{&quot;isTemplate&quot;:true,&quot;type&quot;:&quot;text&quot;}"/>
           <p:cNvSpPr txBox="1"/>
           <p:nvPr/>
         </p:nvSpPr>
@@ -21681,7 +20433,7 @@
       </p:sp>
       <p:sp>
         <p:nvSpPr>
-          <p:cNvPr id="451" name="" descr="{&quot;isTemplate&quot;:true,&quot;type&quot;:&quot;text&quot;}"/>
+          <p:cNvPr id="423" name="" descr="{&quot;isTemplate&quot;:true,&quot;type&quot;:&quot;text&quot;}"/>
           <p:cNvSpPr txBox="1"/>
           <p:nvPr/>
         </p:nvSpPr>
@@ -21716,7 +20468,7 @@
       </p:sp>
       <p:sp>
         <p:nvSpPr>
-          <p:cNvPr id="452" name="" descr="{&quot;isTemplate&quot;:true,&quot;type&quot;:&quot;text&quot;}"/>
+          <p:cNvPr id="424" name="" descr="{&quot;isTemplate&quot;:true,&quot;type&quot;:&quot;text&quot;}"/>
           <p:cNvSpPr txBox="1"/>
           <p:nvPr/>
         </p:nvSpPr>
@@ -21771,7 +20523,7 @@
       </p:sp>
       <p:sp>
         <p:nvSpPr>
-          <p:cNvPr id="453" name="" descr="{&quot;isTemplate&quot;:true,&quot;type&quot;:&quot;text&quot;}"/>
+          <p:cNvPr id="425" name="" descr="{&quot;isTemplate&quot;:true,&quot;type&quot;:&quot;text&quot;}"/>
           <p:cNvSpPr txBox="1"/>
           <p:nvPr/>
         </p:nvSpPr>
@@ -21816,7 +20568,7 @@
       </p:sp>
       <p:sp>
         <p:nvSpPr>
-          <p:cNvPr id="454" name=""/>
+          <p:cNvPr id="426" name=""/>
           <p:cNvSpPr/>
           <p:nvPr/>
         </p:nvSpPr>
@@ -21842,7 +20594,7 @@
       </p:sp>
       <p:sp>
         <p:nvSpPr>
-          <p:cNvPr id="455" name="" descr="{&quot;isTemplate&quot;:true,&quot;type&quot;:&quot;text&quot;}"/>
+          <p:cNvPr id="427" name="" descr="{&quot;isTemplate&quot;:true,&quot;type&quot;:&quot;text&quot;}"/>
           <p:cNvSpPr txBox="1"/>
           <p:nvPr/>
         </p:nvSpPr>
@@ -21877,7 +20629,7 @@
       </p:sp>
       <p:sp>
         <p:nvSpPr>
-          <p:cNvPr id="456" name="" descr="{&quot;isTemplate&quot;:true,&quot;type&quot;:&quot;text&quot;}"/>
+          <p:cNvPr id="428" name="" descr="{&quot;isTemplate&quot;:true,&quot;type&quot;:&quot;text&quot;}"/>
           <p:cNvSpPr txBox="1"/>
           <p:nvPr/>
         </p:nvSpPr>
@@ -21994,7 +20746,7 @@
       </p:sp>
       <p:sp>
         <p:nvSpPr>
-          <p:cNvPr id="457" name=""/>
+          <p:cNvPr id="429" name=""/>
           <p:cNvSpPr/>
           <p:nvPr/>
         </p:nvSpPr>
@@ -22020,7 +20772,7 @@
       </p:sp>
       <p:sp>
         <p:nvSpPr>
-          <p:cNvPr id="458" name="" descr="{&quot;isTemplate&quot;:true,&quot;type&quot;:&quot;text&quot;}"/>
+          <p:cNvPr id="430" name="" descr="{&quot;isTemplate&quot;:true,&quot;type&quot;:&quot;text&quot;}"/>
           <p:cNvSpPr txBox="1"/>
           <p:nvPr/>
         </p:nvSpPr>
@@ -22055,7 +20807,7 @@
       </p:sp>
       <p:sp>
         <p:nvSpPr>
-          <p:cNvPr id="459" name="" descr="{&quot;isTemplate&quot;:true,&quot;type&quot;:&quot;text&quot;}"/>
+          <p:cNvPr id="431" name="" descr="{&quot;isTemplate&quot;:true,&quot;type&quot;:&quot;text&quot;}"/>
           <p:cNvSpPr txBox="1"/>
           <p:nvPr/>
         </p:nvSpPr>
@@ -22192,7 +20944,7 @@
       </p:sp>
       <p:sp>
         <p:nvSpPr>
-          <p:cNvPr id="460" name="" descr="{&quot;isTemplate&quot;:true,&quot;type&quot;:&quot;text&quot;}"/>
+          <p:cNvPr id="432" name="" descr="{&quot;isTemplate&quot;:true,&quot;type&quot;:&quot;text&quot;}"/>
           <p:cNvSpPr txBox="1"/>
           <p:nvPr/>
         </p:nvSpPr>
@@ -22315,7 +21067,7 @@
   <p:cSld>
     <p:spTree>
       <p:nvGrpSpPr>
-        <p:cNvPr id="461" name="" descr="&lt;Slide style={{ width: '1280px', height: '720px', backgroundColor: '#FFFFFF', padding: '0px', flexDirection: 'column' }}&gt;&#10;    &lt;Box style={{ width: '1280px', height: '8px', backgroundColor: '#1E4FA8' }} /&gt;&#10;    &lt;Box style={{ padding: '30px 40px 0px 40px', flexDirection: 'row', justifyContent: 'space-between', alignItems: 'flex-end' }}&gt;&#10;        &lt;Text style={{ fontSize: 34, fontWeight: 'bold', color: '#1E4FA8' }}&gt;关键方式②③：局部 BA 与图传播回环&lt;/Text&gt;&#10;        &lt;Text style={{ fontSize: 15, color: '#8B97A8' }}&gt;09 / 15&lt;/Text&gt;&#10;    &lt;/Box&gt;&#10;    &lt;Box style={{ padding: '16px 40px 0px 40px', flexDirection: 'row', gap: 20 }}&gt;&#10;        &lt;Box style={{ flex: 1, backgroundColor: '#F7F9FC', border: '1px solid #D6DCE5', borderRadius: 6, padding: '16px 18px', flexDirection: 'column' }}&gt;&#10;            &lt;Text style={{ fontSize: 25, fontWeight: 'bold', color: '#1A2230' }}&gt;GPU 局部重建&lt;/Text&gt;&#10;            &lt;Text style={{ fontSize: 21, color: '#1A2230', lineHeight: 1.55, marginTop: 10 }}&gt;关键帧 &lt;b&gt;N=20&lt;/b&gt;（SLAM 通常只用 5 帧时间窗），路标点固定 &lt;b&gt;1 万&lt;/b&gt;，按被观测次数采样。&lt;/Text&gt;&#10;            &lt;Text style={{ fontSize: 21, color: '#1A2230', lineHeight: 1.55, marginTop: 8 }}&gt;每个路标只允许被协视性选出的固定子集观测，避免观测数随帧数二次增长。&lt;/Text&gt;&#10;            &lt;Text style={{ fontSize: 21, color: '#1A2230', lineHeight: 1.55, marginTop: 8 }}&gt;自写核函数算残差与雅可比，稠密 Schur 补求解。&lt;/Text&gt;&#10;            &lt;Text style={{ fontSize: 22, fontWeight: 'bold', color: '#1E4FA8', marginTop: 12 }}&gt;比 g2o / CUDA-BA 快约 5 倍&lt;/Text&gt;&#10;            &lt;Text style={{ fontSize: 21, color: '#1A2230', lineHeight: 1.55, marginTop: 10 }}&gt;高斯投放改为&lt;b&gt;分块估计深度尺度与偏移&lt;/b&gt;再插值上采样（消融 26.29 → 25.41 dB），落点更贴表面。&lt;/Text&gt;&#10;        &lt;/Box&gt;&#10;        &lt;Box style={{ flex: 1, backgroundColor: '#F0F5FC', border: '1px solid #3D7BD9', borderRadius: 6, padding: '16px 18px', flexDirection: 'column' }}&gt;&#10;            &lt;Text style={{ fontSize: 25, fontWeight: 'bold', color: '#1A2230' }}&gt;簇级回环 + 图传播&lt;/Text&gt;&#10;            &lt;Text style={{ fontSize: 21, color: '#1A2230', lineHeight: 1.55, marginTop: 10 }}&gt;检测：出现两组&quot;内部密、彼此疏&quot;的簇，图上跳数 &amp;gt; 5 且有效匹配对 &amp;gt; 2。&lt;/Text&gt;&#10;            &lt;Text style={{ fontSize: 21, color: '#1A2230', lineHeight: 1.55, marginTop: 8 }}&gt;求解：两簇各扩 N/2 帧组成焊接窗口做局部 BA，由锚点刚体变换与深度尺度得到 &lt;b&gt;Sim(3)&lt;/b&gt;。&lt;/Text&gt;&#10;            &lt;Text style={{ fontSize: 21, color: '#1A2230', lineHeight: 1.55, marginTop: 8 }}&gt;传播：Dijkstra 找累计权重最小的&lt;b&gt;主干路径&lt;/b&gt;，按测地距离比例插值（旋转用 6D、尺度取对数），对全图位姿与高斯套用同一变换。&lt;/Text&gt;&#10;            &lt;Text style={{ fontSize: 22, fontWeight: 'bold', color: '#D9534F', marginTop: 12 }}&gt;代价随场景规模近似线性&lt;/Text&gt;&#10;        &lt;/Box&gt;&#10;    &lt;/Box&gt;&#10;    &lt;Box style={{ margin: '18px 40px 0px 40px', backgroundColor: '#F0F5FC', borderLeft: '5px solid #1E4FA8', padding: '14px 20px' }}&gt;&#10;        &lt;Text style={{ fontSize: 21, color: '#1A2230', lineHeight: 1.5 }}&gt;用&quot;图上的距离&quot;替代&quot;全局优化的解&quot;——这是全文最值得借鉴的工程取舍：牺牲一点精度，换来数量级的实时性。&lt;/Text&gt;&#10;    &lt;/Box&gt;&#10;&lt;/Slide&gt;&#10;"/>
+        <p:cNvPr id="433" name="" descr="&lt;Slide style={{ width: '1280px', height: '720px', backgroundColor: '#FFFFFF', padding: '0px', flexDirection: 'column' }}&gt;&#10;    &lt;Box style={{ width: '1280px', height: '8px', backgroundColor: '#1E4FA8' }} /&gt;&#10;    &lt;Box style={{ padding: '30px 40px 0px 40px', flexDirection: 'row', justifyContent: 'space-between', alignItems: 'flex-end' }}&gt;&#10;        &lt;Text style={{ fontSize: 34, fontWeight: 'bold', color: '#1E4FA8' }}&gt;关键方式②③：局部 BA 与图传播回环&lt;/Text&gt;&#10;        &lt;Text style={{ fontSize: 15, color: '#8B97A8' }}&gt;09 / 15&lt;/Text&gt;&#10;    &lt;/Box&gt;&#10;    &lt;Box style={{ padding: '16px 40px 0px 40px', flexDirection: 'row', gap: 20 }}&gt;&#10;        &lt;Box style={{ flex: 1, backgroundColor: '#F7F9FC', border: '1px solid #D6DCE5', borderRadius: 6, padding: '16px 18px', flexDirection: 'column' }}&gt;&#10;            &lt;Text style={{ fontSize: 25, fontWeight: 'bold', color: '#1A2230' }}&gt;GPU 局部重建&lt;/Text&gt;&#10;            &lt;Text style={{ fontSize: 21, color: '#1A2230', lineHeight: 1.55, marginTop: 10 }}&gt;关键帧 &lt;b&gt;N=20&lt;/b&gt;（SLAM 通常只用 5 帧时间窗），路标点固定 &lt;b&gt;1 万&lt;/b&gt;，按被观测次数采样。&lt;/Text&gt;&#10;            &lt;Text style={{ fontSize: 21, color: '#1A2230', lineHeight: 1.55, marginTop: 8 }}&gt;每个路标只允许被协视性选出的固定子集观测，避免观测数随帧数二次增长。&lt;/Text&gt;&#10;            &lt;Text style={{ fontSize: 21, color: '#1A2230', lineHeight: 1.55, marginTop: 8 }}&gt;自写核函数算残差与雅可比，稠密 Schur 补求解。&lt;/Text&gt;&#10;            &lt;Text style={{ fontSize: 22, fontWeight: 'bold', color: '#1E4FA8', marginTop: 12 }}&gt;比 g2o / CUDA-BA 快约 5 倍&lt;/Text&gt;&#10;            &lt;Text style={{ fontSize: 21, color: '#1A2230', lineHeight: 1.55, marginTop: 10 }}&gt;高斯投放改为&lt;b&gt;分块估计深度尺度与偏移&lt;/b&gt;再插值上采样（消融 26.29 → 25.41 dB），落点更贴表面。&lt;/Text&gt;&#10;        &lt;/Box&gt;&#10;        &lt;Box style={{ flex: 1, backgroundColor: '#F0F5FC', border: '1px solid #3D7BD9', borderRadius: 6, padding: '16px 18px', flexDirection: 'column' }}&gt;&#10;            &lt;Text style={{ fontSize: 25, fontWeight: 'bold', color: '#1A2230' }}&gt;簇级回环 + 图传播&lt;/Text&gt;&#10;            &lt;Text style={{ fontSize: 21, color: '#1A2230', lineHeight: 1.55, marginTop: 10 }}&gt;检测：出现两组&quot;内部密、彼此疏&quot;的簇，图上跳数 &amp;gt; 5 且有效匹配对 &amp;gt; 2。&lt;/Text&gt;&#10;            &lt;Text style={{ fontSize: 21, color: '#1A2230', lineHeight: 1.55, marginTop: 8 }}&gt;求解：两簇各扩 N/2 帧组成焊接窗口做局部 BA，由锚点刚体变换与深度尺度得到 &lt;b&gt;Sim(3)&lt;/b&gt;。&lt;/Text&gt;&#10;            &lt;Text style={{ fontSize: 21, color: '#1A2230', lineHeight: 1.55, marginTop: 8 }}&gt;传播：Dijkstra 找累计权重最小的&lt;b&gt;主干路径&lt;/b&gt;，按测地距离比例插值（旋转用 6D、尺度取对数），对全图位姿与高斯套用同一变换。&lt;/Text&gt;&#10;            &lt;Text style={{ fontSize: 22, fontWeight: 'bold', color: '#D9534F', marginTop: 12 }}&gt;代价随场景规模近似线性&lt;/Text&gt;&#10;        &lt;/Box&gt;&#10;    &lt;/Box&gt;&#10;    &lt;Box style={{ margin: '18px 40px 0px 40px', backgroundColor: '#F0F5FC', borderLeft: '5px solid #1E4FA8', padding: '14px 20px' }}&gt;&#10;        &lt;Text style={{ fontSize: 21, color: '#1A2230', lineHeight: 1.5 }}&gt;用&quot;图上的距离&quot;替代&quot;全局优化的解&quot;——这是全文最值得借鉴的工程取舍：牺牲一点精度，换来数量级的实时性。&lt;/Text&gt;&#10;    &lt;/Box&gt;&#10;&lt;/Slide&gt;&#10;"/>
         <p:cNvGrpSpPr/>
         <p:nvPr/>
       </p:nvGrpSpPr>
@@ -22329,7 +21081,7 @@
       </p:grpSpPr>
       <p:sp>
         <p:nvSpPr>
-          <p:cNvPr id="462" name=""/>
+          <p:cNvPr id="434" name=""/>
           <p:cNvSpPr/>
           <p:nvPr/>
         </p:nvSpPr>
@@ -22353,7 +21105,7 @@
       </p:sp>
       <p:sp>
         <p:nvSpPr>
-          <p:cNvPr id="463" name=""/>
+          <p:cNvPr id="435" name=""/>
           <p:cNvSpPr/>
           <p:nvPr/>
         </p:nvSpPr>
@@ -22377,7 +21129,7 @@
       </p:sp>
       <p:sp>
         <p:nvSpPr>
-          <p:cNvPr id="464" name="" descr="{&quot;isTemplate&quot;:true,&quot;type&quot;:&quot;text&quot;}"/>
+          <p:cNvPr id="436" name="" descr="{&quot;isTemplate&quot;:true,&quot;type&quot;:&quot;text&quot;}"/>
           <p:cNvSpPr txBox="1"/>
           <p:nvPr/>
         </p:nvSpPr>
@@ -22432,7 +21184,7 @@
       </p:sp>
       <p:sp>
         <p:nvSpPr>
-          <p:cNvPr id="465" name="" descr="{&quot;isTemplate&quot;:true,&quot;type&quot;:&quot;text&quot;}"/>
+          <p:cNvPr id="437" name="" descr="{&quot;isTemplate&quot;:true,&quot;type&quot;:&quot;text&quot;}"/>
           <p:cNvSpPr txBox="1"/>
           <p:nvPr/>
         </p:nvSpPr>
@@ -22467,7 +21219,7 @@
       </p:sp>
       <p:sp>
         <p:nvSpPr>
-          <p:cNvPr id="466" name=""/>
+          <p:cNvPr id="438" name=""/>
           <p:cNvSpPr/>
           <p:nvPr/>
         </p:nvSpPr>
@@ -22498,7 +21250,7 @@
       </p:sp>
       <p:sp>
         <p:nvSpPr>
-          <p:cNvPr id="467" name="" descr="{&quot;isTemplate&quot;:true,&quot;type&quot;:&quot;text&quot;}"/>
+          <p:cNvPr id="439" name="" descr="{&quot;isTemplate&quot;:true,&quot;type&quot;:&quot;text&quot;}"/>
           <p:cNvSpPr txBox="1"/>
           <p:nvPr/>
         </p:nvSpPr>
@@ -22543,7 +21295,7 @@
       </p:sp>
       <p:sp>
         <p:nvSpPr>
-          <p:cNvPr id="468" name="" descr="{&quot;isTemplate&quot;:true,&quot;type&quot;:&quot;text&quot;}"/>
+          <p:cNvPr id="440" name="" descr="{&quot;isTemplate&quot;:true,&quot;type&quot;:&quot;text&quot;}"/>
           <p:cNvSpPr txBox="1"/>
           <p:nvPr/>
         </p:nvSpPr>
@@ -22690,7 +21442,7 @@
       </p:sp>
       <p:sp>
         <p:nvSpPr>
-          <p:cNvPr id="469" name="" descr="{&quot;isTemplate&quot;:true,&quot;type&quot;:&quot;text&quot;}"/>
+          <p:cNvPr id="441" name="" descr="{&quot;isTemplate&quot;:true,&quot;type&quot;:&quot;text&quot;}"/>
           <p:cNvSpPr txBox="1"/>
           <p:nvPr/>
         </p:nvSpPr>
@@ -22727,7 +21479,7 @@
       </p:sp>
       <p:sp>
         <p:nvSpPr>
-          <p:cNvPr id="470" name="" descr="{&quot;isTemplate&quot;:true,&quot;type&quot;:&quot;text&quot;}"/>
+          <p:cNvPr id="442" name="" descr="{&quot;isTemplate&quot;:true,&quot;type&quot;:&quot;text&quot;}"/>
           <p:cNvSpPr txBox="1"/>
           <p:nvPr/>
         </p:nvSpPr>
@@ -22782,7 +21534,7 @@
       </p:sp>
       <p:sp>
         <p:nvSpPr>
-          <p:cNvPr id="471" name="" descr="{&quot;isTemplate&quot;:true,&quot;type&quot;:&quot;text&quot;}"/>
+          <p:cNvPr id="443" name="" descr="{&quot;isTemplate&quot;:true,&quot;type&quot;:&quot;text&quot;}"/>
           <p:cNvSpPr txBox="1"/>
           <p:nvPr/>
         </p:nvSpPr>
@@ -22857,7 +21609,7 @@
       </p:sp>
       <p:sp>
         <p:nvSpPr>
-          <p:cNvPr id="472" name="" descr="{&quot;isTemplate&quot;:true,&quot;type&quot;:&quot;text&quot;}"/>
+          <p:cNvPr id="444" name="" descr="{&quot;isTemplate&quot;:true,&quot;type&quot;:&quot;text&quot;}"/>
           <p:cNvSpPr txBox="1"/>
           <p:nvPr/>
         </p:nvSpPr>
@@ -22934,7 +21686,7 @@
       </p:sp>
       <p:sp>
         <p:nvSpPr>
-          <p:cNvPr id="473" name=""/>
+          <p:cNvPr id="445" name=""/>
           <p:cNvSpPr/>
           <p:nvPr/>
         </p:nvSpPr>
@@ -22965,7 +21717,7 @@
       </p:sp>
       <p:sp>
         <p:nvSpPr>
-          <p:cNvPr id="474" name="" descr="{&quot;isTemplate&quot;:true,&quot;type&quot;:&quot;text&quot;}"/>
+          <p:cNvPr id="446" name="" descr="{&quot;isTemplate&quot;:true,&quot;type&quot;:&quot;text&quot;}"/>
           <p:cNvSpPr txBox="1"/>
           <p:nvPr/>
         </p:nvSpPr>
@@ -23020,7 +21772,7 @@
       </p:sp>
       <p:sp>
         <p:nvSpPr>
-          <p:cNvPr id="475" name="" descr="{&quot;isTemplate&quot;:true,&quot;type&quot;:&quot;text&quot;}"/>
+          <p:cNvPr id="447" name="" descr="{&quot;isTemplate&quot;:true,&quot;type&quot;:&quot;text&quot;}"/>
           <p:cNvSpPr txBox="1"/>
           <p:nvPr/>
         </p:nvSpPr>
@@ -23137,7 +21889,7 @@
       </p:sp>
       <p:sp>
         <p:nvSpPr>
-          <p:cNvPr id="476" name="" descr="{&quot;isTemplate&quot;:true,&quot;type&quot;:&quot;text&quot;}"/>
+          <p:cNvPr id="448" name="" descr="{&quot;isTemplate&quot;:true,&quot;type&quot;:&quot;text&quot;}"/>
           <p:cNvSpPr txBox="1"/>
           <p:nvPr/>
         </p:nvSpPr>
@@ -23244,7 +21996,7 @@
       </p:sp>
       <p:sp>
         <p:nvSpPr>
-          <p:cNvPr id="477" name="" descr="{&quot;isTemplate&quot;:true,&quot;type&quot;:&quot;text&quot;}"/>
+          <p:cNvPr id="449" name="" descr="{&quot;isTemplate&quot;:true,&quot;type&quot;:&quot;text&quot;}"/>
           <p:cNvSpPr txBox="1"/>
           <p:nvPr/>
         </p:nvSpPr>
@@ -23341,7 +22093,7 @@
       </p:sp>
       <p:sp>
         <p:nvSpPr>
-          <p:cNvPr id="478" name="" descr="{&quot;isTemplate&quot;:true,&quot;type&quot;:&quot;text&quot;}"/>
+          <p:cNvPr id="450" name="" descr="{&quot;isTemplate&quot;:true,&quot;type&quot;:&quot;text&quot;}"/>
           <p:cNvSpPr txBox="1"/>
           <p:nvPr/>
         </p:nvSpPr>
@@ -23376,7 +22128,7 @@
       </p:sp>
       <p:sp>
         <p:nvSpPr>
-          <p:cNvPr id="479" name=""/>
+          <p:cNvPr id="451" name=""/>
           <p:cNvSpPr/>
           <p:nvPr/>
         </p:nvSpPr>
@@ -23400,7 +22152,7 @@
       </p:sp>
       <p:sp>
         <p:nvSpPr>
-          <p:cNvPr id="480" name=""/>
+          <p:cNvPr id="452" name=""/>
           <p:cNvSpPr/>
           <p:nvPr/>
         </p:nvSpPr>
@@ -23440,7 +22192,7 @@
       </p:sp>
       <p:sp>
         <p:nvSpPr>
-          <p:cNvPr id="481" name="" descr="{&quot;isTemplate&quot;:true,&quot;type&quot;:&quot;text&quot;}"/>
+          <p:cNvPr id="453" name="" descr="{&quot;isTemplate&quot;:true,&quot;type&quot;:&quot;text&quot;}"/>
           <p:cNvSpPr txBox="1"/>
           <p:nvPr/>
         </p:nvSpPr>

</xml_diff>